<commit_message>
some clustering, old RNN slides
</commit_message>
<xml_diff>
--- a/slides/2_clustering.pptx
+++ b/slides/2_clustering.pptx
@@ -5,7 +5,7 @@
     <p:sldMasterId id="2147483648" r:id="rId1"/>
   </p:sldMasterIdLst>
   <p:notesMasterIdLst>
-    <p:notesMasterId r:id="rId31"/>
+    <p:notesMasterId r:id="rId30"/>
   </p:notesMasterIdLst>
   <p:sldIdLst>
     <p:sldId id="256" r:id="rId2"/>
@@ -24,19 +24,18 @@
     <p:sldId id="274" r:id="rId15"/>
     <p:sldId id="288" r:id="rId16"/>
     <p:sldId id="273" r:id="rId17"/>
-    <p:sldId id="291" r:id="rId18"/>
-    <p:sldId id="287" r:id="rId19"/>
-    <p:sldId id="286" r:id="rId20"/>
-    <p:sldId id="275" r:id="rId21"/>
-    <p:sldId id="276" r:id="rId22"/>
-    <p:sldId id="277" r:id="rId23"/>
-    <p:sldId id="278" r:id="rId24"/>
-    <p:sldId id="279" r:id="rId25"/>
-    <p:sldId id="280" r:id="rId26"/>
-    <p:sldId id="281" r:id="rId27"/>
-    <p:sldId id="282" r:id="rId28"/>
-    <p:sldId id="283" r:id="rId29"/>
-    <p:sldId id="284" r:id="rId30"/>
+    <p:sldId id="283" r:id="rId18"/>
+    <p:sldId id="282" r:id="rId19"/>
+    <p:sldId id="291" r:id="rId20"/>
+    <p:sldId id="287" r:id="rId21"/>
+    <p:sldId id="286" r:id="rId22"/>
+    <p:sldId id="275" r:id="rId23"/>
+    <p:sldId id="276" r:id="rId24"/>
+    <p:sldId id="277" r:id="rId25"/>
+    <p:sldId id="278" r:id="rId26"/>
+    <p:sldId id="279" r:id="rId27"/>
+    <p:sldId id="280" r:id="rId28"/>
+    <p:sldId id="281" r:id="rId29"/>
   </p:sldIdLst>
   <p:sldSz cx="12192000" cy="6858000"/>
   <p:notesSz cx="6858000" cy="9144000"/>
@@ -507,7 +506,7 @@
           <a:p>
             <a:fld id="{506E0FD1-891F-4B1E-916D-E9B585160BB8}" type="datetimeFigureOut">
               <a:rPr lang="en-GB" smtClean="0"/>
-              <a:t>07/03/2026</a:t>
+              <a:t>08/03/2026</a:t>
             </a:fld>
             <a:endParaRPr lang="en-GB"/>
           </a:p>
@@ -924,7 +923,7 @@
           <a:p>
             <a:fld id="{D68C3F22-27B2-44E3-9C5F-D08126455F6F}" type="datetime1">
               <a:rPr lang="en-GB" smtClean="0"/>
-              <a:t>07/03/2026</a:t>
+              <a:t>08/03/2026</a:t>
             </a:fld>
             <a:endParaRPr lang="en-GB"/>
           </a:p>
@@ -1124,7 +1123,7 @@
           <a:p>
             <a:fld id="{1CD03846-7BF6-4FB6-A921-FF3379ADBD4C}" type="datetime1">
               <a:rPr lang="en-GB" smtClean="0"/>
-              <a:t>07/03/2026</a:t>
+              <a:t>08/03/2026</a:t>
             </a:fld>
             <a:endParaRPr lang="en-GB"/>
           </a:p>
@@ -1334,7 +1333,7 @@
           <a:p>
             <a:fld id="{99E1B91A-3FD0-4144-9C84-63E9688ED2FE}" type="datetime1">
               <a:rPr lang="en-GB" smtClean="0"/>
-              <a:t>07/03/2026</a:t>
+              <a:t>08/03/2026</a:t>
             </a:fld>
             <a:endParaRPr lang="en-GB"/>
           </a:p>
@@ -1534,7 +1533,7 @@
           <a:p>
             <a:fld id="{5295ED7B-FEAD-4734-819F-93EF4B0EA908}" type="datetime1">
               <a:rPr lang="en-GB" smtClean="0"/>
-              <a:t>07/03/2026</a:t>
+              <a:t>08/03/2026</a:t>
             </a:fld>
             <a:endParaRPr lang="en-GB"/>
           </a:p>
@@ -1810,7 +1809,7 @@
           <a:p>
             <a:fld id="{D2D5D4B4-C926-4B45-8815-1ED8911179A2}" type="datetime1">
               <a:rPr lang="en-GB" smtClean="0"/>
-              <a:t>07/03/2026</a:t>
+              <a:t>08/03/2026</a:t>
             </a:fld>
             <a:endParaRPr lang="en-GB"/>
           </a:p>
@@ -2078,7 +2077,7 @@
           <a:p>
             <a:fld id="{B4C5210A-0E37-4935-93AF-69F21A5F712F}" type="datetime1">
               <a:rPr lang="en-GB" smtClean="0"/>
-              <a:t>07/03/2026</a:t>
+              <a:t>08/03/2026</a:t>
             </a:fld>
             <a:endParaRPr lang="en-GB"/>
           </a:p>
@@ -2493,7 +2492,7 @@
           <a:p>
             <a:fld id="{3D3A6B2F-436C-4691-80E8-9C890E000E9D}" type="datetime1">
               <a:rPr lang="en-GB" smtClean="0"/>
-              <a:t>07/03/2026</a:t>
+              <a:t>08/03/2026</a:t>
             </a:fld>
             <a:endParaRPr lang="en-GB"/>
           </a:p>
@@ -2635,7 +2634,7 @@
           <a:p>
             <a:fld id="{84385F4C-D74B-496F-8D21-97E3549C783B}" type="datetime1">
               <a:rPr lang="en-GB" smtClean="0"/>
-              <a:t>07/03/2026</a:t>
+              <a:t>08/03/2026</a:t>
             </a:fld>
             <a:endParaRPr lang="en-GB"/>
           </a:p>
@@ -2748,7 +2747,7 @@
           <a:p>
             <a:fld id="{0CBDCB32-C241-4703-A832-4EB47BD54E83}" type="datetime1">
               <a:rPr lang="en-GB" smtClean="0"/>
-              <a:t>07/03/2026</a:t>
+              <a:t>08/03/2026</a:t>
             </a:fld>
             <a:endParaRPr lang="en-GB"/>
           </a:p>
@@ -3061,7 +3060,7 @@
           <a:p>
             <a:fld id="{85C150FF-BE95-4D25-A16A-E368A81CBF24}" type="datetime1">
               <a:rPr lang="en-GB" smtClean="0"/>
-              <a:t>07/03/2026</a:t>
+              <a:t>08/03/2026</a:t>
             </a:fld>
             <a:endParaRPr lang="en-GB"/>
           </a:p>
@@ -3350,7 +3349,7 @@
           <a:p>
             <a:fld id="{F3C5DB4B-B349-43C9-A424-BADA723AD9F1}" type="datetime1">
               <a:rPr lang="en-GB" smtClean="0"/>
-              <a:t>07/03/2026</a:t>
+              <a:t>08/03/2026</a:t>
             </a:fld>
             <a:endParaRPr lang="en-GB"/>
           </a:p>
@@ -3593,7 +3592,7 @@
           <a:p>
             <a:fld id="{12632426-0A0C-405F-A3D0-2D11AA44702A}" type="datetime1">
               <a:rPr lang="en-GB" smtClean="0"/>
-              <a:t>07/03/2026</a:t>
+              <a:t>08/03/2026</a:t>
             </a:fld>
             <a:endParaRPr lang="en-GB"/>
           </a:p>
@@ -5221,8 +5220,8 @@
           </a:p>
         </p:txBody>
       </p:sp>
-      <mc:AlternateContent xmlns:mc="http://schemas.openxmlformats.org/markup-compatibility/2006">
-        <mc:Choice xmlns:a14="http://schemas.microsoft.com/office/drawing/2010/main" Requires="a14">
+      <mc:AlternateContent xmlns:mc="http://schemas.openxmlformats.org/markup-compatibility/2006" xmlns:a14="http://schemas.microsoft.com/office/drawing/2010/main">
+        <mc:Choice Requires="a14">
           <p:sp>
             <p:nvSpPr>
               <p:cNvPr id="3" name="Inhaltsplatzhalter 2">
@@ -5581,7 +5580,7 @@
             </p:txBody>
           </p:sp>
         </mc:Choice>
-        <mc:Fallback>
+        <mc:Fallback xmlns="">
           <p:sp>
             <p:nvSpPr>
               <p:cNvPr id="3" name="Inhaltsplatzhalter 2">
@@ -5953,44 +5952,1321 @@
           <a:p>
             <a:r>
               <a:rPr lang="de-DE" dirty="0"/>
-              <a:t>… Mean L2 </a:t>
-            </a:r>
-            <a:r>
-              <a:rPr lang="de-DE" dirty="0" err="1"/>
-              <a:t>vs</a:t>
-            </a:r>
-            <a:r>
-              <a:rPr lang="de-DE" dirty="0"/>
-              <a:t> Median L1 …</a:t>
-            </a:r>
+              <a:t>L2 </a:t>
+            </a:r>
+            <a:r>
+              <a:rPr lang="de-DE" dirty="0">
+                <a:sym typeface="Wingdings" pitchFamily="2" charset="2"/>
+              </a:rPr>
+              <a:t> Mean, </a:t>
+            </a:r>
+            <a:r>
+              <a:rPr lang="de-DE" dirty="0"/>
+              <a:t> L1 </a:t>
+            </a:r>
+            <a:r>
+              <a:rPr lang="de-DE" dirty="0">
+                <a:sym typeface="Wingdings" pitchFamily="2" charset="2"/>
+              </a:rPr>
+              <a:t> Median</a:t>
+            </a:r>
+            <a:endParaRPr lang="de-DE" dirty="0"/>
           </a:p>
         </p:txBody>
       </p:sp>
-      <p:sp>
-        <p:nvSpPr>
-          <p:cNvPr id="3" name="Inhaltsplatzhalter 2">
-            <a:extLst>
-              <a:ext uri="{FF2B5EF4-FFF2-40B4-BE49-F238E27FC236}">
-                <a16:creationId xmlns:a16="http://schemas.microsoft.com/office/drawing/2014/main" id="{085BD90E-4E62-2134-AC41-EB7A9018D82B}"/>
-              </a:ext>
-            </a:extLst>
-          </p:cNvPr>
-          <p:cNvSpPr>
-            <a:spLocks noGrp="1"/>
-          </p:cNvSpPr>
-          <p:nvPr>
-            <p:ph idx="1"/>
-          </p:nvPr>
-        </p:nvSpPr>
-        <p:spPr/>
-        <p:txBody>
-          <a:bodyPr/>
-          <a:lstStyle/>
-          <a:p>
-            <a:endParaRPr lang="de-DE"/>
-          </a:p>
-        </p:txBody>
-      </p:sp>
+      <mc:AlternateContent xmlns:mc="http://schemas.openxmlformats.org/markup-compatibility/2006">
+        <mc:Choice xmlns:a14="http://schemas.microsoft.com/office/drawing/2010/main" Requires="a14">
+          <p:sp>
+            <p:nvSpPr>
+              <p:cNvPr id="5" name="Inhaltsplatzhalter 4">
+                <a:extLst>
+                  <a:ext uri="{FF2B5EF4-FFF2-40B4-BE49-F238E27FC236}">
+                    <a16:creationId xmlns:a16="http://schemas.microsoft.com/office/drawing/2014/main" id="{DB2D2E5C-783C-A264-2A40-ADE2D331F73F}"/>
+                  </a:ext>
+                </a:extLst>
+              </p:cNvPr>
+              <p:cNvSpPr>
+                <a:spLocks noGrp="1"/>
+              </p:cNvSpPr>
+              <p:nvPr>
+                <p:ph sz="half" idx="1"/>
+              </p:nvPr>
+            </p:nvSpPr>
+            <p:spPr/>
+            <p:txBody>
+              <a:bodyPr>
+                <a:normAutofit fontScale="92500" lnSpcReduction="20000"/>
+              </a:bodyPr>
+              <a:lstStyle/>
+              <a:p>
+                <a:pPr marL="0" indent="0">
+                  <a:buNone/>
+                </a:pPr>
+                <a:r>
+                  <a:rPr lang="de-DE" sz="3300" dirty="0"/>
+                  <a:t>L2 </a:t>
+                </a:r>
+                <a:r>
+                  <a:rPr lang="de-DE" sz="3300" dirty="0" err="1"/>
+                  <a:t>objective</a:t>
+                </a:r>
+                <a:r>
+                  <a:rPr lang="de-DE" sz="3300" dirty="0"/>
+                  <a:t>:</a:t>
+                </a:r>
+              </a:p>
+              <a:p>
+                <a:pPr marL="0" indent="0" algn="ctr">
+                  <a:buNone/>
+                </a:pPr>
+                <a:endParaRPr lang="de-DE" sz="2400" dirty="0"/>
+              </a:p>
+              <a:p>
+                <a:pPr marL="0" indent="0">
+                  <a:buNone/>
+                </a:pPr>
+                <a14:m>
+                  <m:oMathPara xmlns:m="http://schemas.openxmlformats.org/officeDocument/2006/math">
+                    <m:oMathParaPr>
+                      <m:jc m:val="left"/>
+                    </m:oMathParaPr>
+                    <m:oMath xmlns:m="http://schemas.openxmlformats.org/officeDocument/2006/math">
+                      <m:func>
+                        <m:funcPr>
+                          <m:ctrlPr>
+                            <a:rPr lang="de-DE" sz="2400" i="1" smtClean="0">
+                              <a:latin typeface="Cambria Math" panose="02040503050406030204" pitchFamily="18" charset="0"/>
+                            </a:rPr>
+                          </m:ctrlPr>
+                        </m:funcPr>
+                        <m:fName>
+                          <m:limLow>
+                            <m:limLowPr>
+                              <m:ctrlPr>
+                                <a:rPr lang="de-DE" sz="2400" i="1" smtClean="0">
+                                  <a:latin typeface="Cambria Math" panose="02040503050406030204" pitchFamily="18" charset="0"/>
+                                </a:rPr>
+                              </m:ctrlPr>
+                            </m:limLowPr>
+                            <m:e>
+                              <m:r>
+                                <m:rPr>
+                                  <m:sty m:val="p"/>
+                                </m:rPr>
+                                <a:rPr lang="de-DE" sz="2400" i="0" smtClean="0">
+                                  <a:latin typeface="Cambria Math" panose="02040503050406030204" pitchFamily="18" charset="0"/>
+                                </a:rPr>
+                                <m:t>min</m:t>
+                              </m:r>
+                            </m:e>
+                            <m:lim>
+                              <m:r>
+                                <a:rPr lang="de-DE" sz="2400" b="0" i="1" smtClean="0">
+                                  <a:latin typeface="Cambria Math" panose="02040503050406030204" pitchFamily="18" charset="0"/>
+                                </a:rPr>
+                                <m:t>𝑎</m:t>
+                              </m:r>
+                            </m:lim>
+                          </m:limLow>
+                        </m:fName>
+                        <m:e>
+                          <m:nary>
+                            <m:naryPr>
+                              <m:chr m:val="∑"/>
+                              <m:ctrlPr>
+                                <a:rPr lang="de-DE" sz="2400" i="1" smtClean="0">
+                                  <a:latin typeface="Cambria Math" panose="02040503050406030204" pitchFamily="18" charset="0"/>
+                                </a:rPr>
+                              </m:ctrlPr>
+                            </m:naryPr>
+                            <m:sub>
+                              <m:r>
+                                <m:rPr>
+                                  <m:brk m:alnAt="23"/>
+                                </m:rPr>
+                                <a:rPr lang="de-DE" sz="2400" b="0" i="1" smtClean="0">
+                                  <a:latin typeface="Cambria Math" panose="02040503050406030204" pitchFamily="18" charset="0"/>
+                                </a:rPr>
+                                <m:t>𝑖</m:t>
+                              </m:r>
+                              <m:r>
+                                <a:rPr lang="de-DE" sz="2400" b="0" i="1" smtClean="0">
+                                  <a:latin typeface="Cambria Math" panose="02040503050406030204" pitchFamily="18" charset="0"/>
+                                </a:rPr>
+                                <m:t>=1</m:t>
+                              </m:r>
+                            </m:sub>
+                            <m:sup>
+                              <m:r>
+                                <a:rPr lang="de-DE" sz="2400" b="0" i="1" smtClean="0">
+                                  <a:latin typeface="Cambria Math" panose="02040503050406030204" pitchFamily="18" charset="0"/>
+                                </a:rPr>
+                                <m:t>𝑛</m:t>
+                              </m:r>
+                            </m:sup>
+                            <m:e>
+                              <m:sSup>
+                                <m:sSupPr>
+                                  <m:ctrlPr>
+                                    <a:rPr lang="de-DE" sz="2400" i="1" smtClean="0">
+                                      <a:latin typeface="Cambria Math" panose="02040503050406030204" pitchFamily="18" charset="0"/>
+                                    </a:rPr>
+                                  </m:ctrlPr>
+                                </m:sSupPr>
+                                <m:e>
+                                  <m:d>
+                                    <m:dPr>
+                                      <m:ctrlPr>
+                                        <a:rPr lang="de-DE" sz="2400" i="1" smtClean="0">
+                                          <a:latin typeface="Cambria Math" panose="02040503050406030204" pitchFamily="18" charset="0"/>
+                                        </a:rPr>
+                                      </m:ctrlPr>
+                                    </m:dPr>
+                                    <m:e>
+                                      <m:sSub>
+                                        <m:sSubPr>
+                                          <m:ctrlPr>
+                                            <a:rPr lang="de-DE" sz="2400" i="1" smtClean="0">
+                                              <a:latin typeface="Cambria Math" panose="02040503050406030204" pitchFamily="18" charset="0"/>
+                                            </a:rPr>
+                                          </m:ctrlPr>
+                                        </m:sSubPr>
+                                        <m:e>
+                                          <m:r>
+                                            <a:rPr lang="de-DE" sz="2400" b="0" i="1" smtClean="0">
+                                              <a:latin typeface="Cambria Math" panose="02040503050406030204" pitchFamily="18" charset="0"/>
+                                            </a:rPr>
+                                            <m:t>𝑥</m:t>
+                                          </m:r>
+                                        </m:e>
+                                        <m:sub>
+                                          <m:r>
+                                            <a:rPr lang="de-DE" sz="2400" b="0" i="1" smtClean="0">
+                                              <a:latin typeface="Cambria Math" panose="02040503050406030204" pitchFamily="18" charset="0"/>
+                                            </a:rPr>
+                                            <m:t>𝑖</m:t>
+                                          </m:r>
+                                        </m:sub>
+                                      </m:sSub>
+                                      <m:r>
+                                        <a:rPr lang="de-DE" sz="2400" b="0" i="1" smtClean="0">
+                                          <a:latin typeface="Cambria Math" panose="02040503050406030204" pitchFamily="18" charset="0"/>
+                                        </a:rPr>
+                                        <m:t>−</m:t>
+                                      </m:r>
+                                      <m:r>
+                                        <a:rPr lang="de-DE" sz="2400" b="0" i="1" smtClean="0">
+                                          <a:latin typeface="Cambria Math" panose="02040503050406030204" pitchFamily="18" charset="0"/>
+                                        </a:rPr>
+                                        <m:t>𝑎</m:t>
+                                      </m:r>
+                                    </m:e>
+                                  </m:d>
+                                </m:e>
+                                <m:sup>
+                                  <m:r>
+                                    <a:rPr lang="de-DE" sz="2400" b="0" i="1" smtClean="0">
+                                      <a:latin typeface="Cambria Math" panose="02040503050406030204" pitchFamily="18" charset="0"/>
+                                    </a:rPr>
+                                    <m:t>2</m:t>
+                                  </m:r>
+                                </m:sup>
+                              </m:sSup>
+                            </m:e>
+                          </m:nary>
+                        </m:e>
+                      </m:func>
+                    </m:oMath>
+                  </m:oMathPara>
+                </a14:m>
+                <a:endParaRPr lang="de-DE" sz="2400" dirty="0"/>
+              </a:p>
+              <a:p>
+                <a:pPr marL="0" indent="0">
+                  <a:buNone/>
+                </a:pPr>
+                <a:endParaRPr lang="de-DE" sz="2400" dirty="0"/>
+              </a:p>
+              <a:p>
+                <a:pPr marL="0" indent="0">
+                  <a:buNone/>
+                </a:pPr>
+                <a14:m>
+                  <m:oMathPara xmlns:m="http://schemas.openxmlformats.org/officeDocument/2006/math">
+                    <m:oMathParaPr>
+                      <m:jc m:val="left"/>
+                    </m:oMathParaPr>
+                    <m:oMath xmlns:m="http://schemas.openxmlformats.org/officeDocument/2006/math">
+                      <m:f>
+                        <m:fPr>
+                          <m:ctrlPr>
+                            <a:rPr lang="de-DE" sz="2400" i="1" smtClean="0">
+                              <a:latin typeface="Cambria Math" panose="02040503050406030204" pitchFamily="18" charset="0"/>
+                            </a:rPr>
+                          </m:ctrlPr>
+                        </m:fPr>
+                        <m:num>
+                          <m:r>
+                            <a:rPr lang="de-DE" sz="2400" i="1" smtClean="0">
+                              <a:latin typeface="Cambria Math" panose="02040503050406030204" pitchFamily="18" charset="0"/>
+                            </a:rPr>
+                            <m:t>𝑑</m:t>
+                          </m:r>
+                        </m:num>
+                        <m:den>
+                          <m:r>
+                            <a:rPr lang="de-DE" sz="2400" i="1" smtClean="0">
+                              <a:latin typeface="Cambria Math" panose="02040503050406030204" pitchFamily="18" charset="0"/>
+                            </a:rPr>
+                            <m:t>𝑑</m:t>
+                          </m:r>
+                          <m:r>
+                            <a:rPr lang="de-DE" sz="2400" b="0" i="1" smtClean="0">
+                              <a:latin typeface="Cambria Math" panose="02040503050406030204" pitchFamily="18" charset="0"/>
+                            </a:rPr>
+                            <m:t>𝑎</m:t>
+                          </m:r>
+                        </m:den>
+                      </m:f>
+                      <m:nary>
+                        <m:naryPr>
+                          <m:chr m:val="∑"/>
+                          <m:subHide m:val="on"/>
+                          <m:supHide m:val="on"/>
+                          <m:ctrlPr>
+                            <a:rPr lang="de-DE" sz="2400" i="1">
+                              <a:latin typeface="Cambria Math" panose="02040503050406030204" pitchFamily="18" charset="0"/>
+                            </a:rPr>
+                          </m:ctrlPr>
+                        </m:naryPr>
+                        <m:sub/>
+                        <m:sup/>
+                        <m:e>
+                          <m:sSup>
+                            <m:sSupPr>
+                              <m:ctrlPr>
+                                <a:rPr lang="de-DE" sz="2400" i="1">
+                                  <a:latin typeface="Cambria Math" panose="02040503050406030204" pitchFamily="18" charset="0"/>
+                                </a:rPr>
+                              </m:ctrlPr>
+                            </m:sSupPr>
+                            <m:e>
+                              <m:d>
+                                <m:dPr>
+                                  <m:ctrlPr>
+                                    <a:rPr lang="de-DE" sz="2400" i="1">
+                                      <a:latin typeface="Cambria Math" panose="02040503050406030204" pitchFamily="18" charset="0"/>
+                                    </a:rPr>
+                                  </m:ctrlPr>
+                                </m:dPr>
+                                <m:e>
+                                  <m:sSub>
+                                    <m:sSubPr>
+                                      <m:ctrlPr>
+                                        <a:rPr lang="de-DE" sz="2400" i="1">
+                                          <a:latin typeface="Cambria Math" panose="02040503050406030204" pitchFamily="18" charset="0"/>
+                                        </a:rPr>
+                                      </m:ctrlPr>
+                                    </m:sSubPr>
+                                    <m:e>
+                                      <m:r>
+                                        <a:rPr lang="de-DE" sz="2400" i="1">
+                                          <a:latin typeface="Cambria Math" panose="02040503050406030204" pitchFamily="18" charset="0"/>
+                                        </a:rPr>
+                                        <m:t>𝑥</m:t>
+                                      </m:r>
+                                    </m:e>
+                                    <m:sub>
+                                      <m:r>
+                                        <a:rPr lang="de-DE" sz="2400" i="1">
+                                          <a:latin typeface="Cambria Math" panose="02040503050406030204" pitchFamily="18" charset="0"/>
+                                        </a:rPr>
+                                        <m:t>𝑖</m:t>
+                                      </m:r>
+                                    </m:sub>
+                                  </m:sSub>
+                                  <m:r>
+                                    <a:rPr lang="de-DE" sz="2400" i="1">
+                                      <a:latin typeface="Cambria Math" panose="02040503050406030204" pitchFamily="18" charset="0"/>
+                                    </a:rPr>
+                                    <m:t>−</m:t>
+                                  </m:r>
+                                  <m:r>
+                                    <a:rPr lang="de-DE" sz="2400" i="1">
+                                      <a:latin typeface="Cambria Math" panose="02040503050406030204" pitchFamily="18" charset="0"/>
+                                    </a:rPr>
+                                    <m:t>𝑎</m:t>
+                                  </m:r>
+                                </m:e>
+                              </m:d>
+                            </m:e>
+                            <m:sup>
+                              <m:r>
+                                <a:rPr lang="de-DE" sz="2400" i="1">
+                                  <a:latin typeface="Cambria Math" panose="02040503050406030204" pitchFamily="18" charset="0"/>
+                                </a:rPr>
+                                <m:t>2</m:t>
+                              </m:r>
+                            </m:sup>
+                          </m:sSup>
+                        </m:e>
+                      </m:nary>
+                      <m:r>
+                        <a:rPr lang="de-DE" sz="2400" b="0" i="1" smtClean="0">
+                          <a:latin typeface="Cambria Math" panose="02040503050406030204" pitchFamily="18" charset="0"/>
+                        </a:rPr>
+                        <m:t>=0</m:t>
+                      </m:r>
+                    </m:oMath>
+                  </m:oMathPara>
+                </a14:m>
+                <a:endParaRPr lang="de-DE" sz="2400" b="0" dirty="0"/>
+              </a:p>
+              <a:p>
+                <a:pPr marL="0" indent="0">
+                  <a:buNone/>
+                </a:pPr>
+                <a:endParaRPr lang="de-DE" sz="2400" b="0" dirty="0"/>
+              </a:p>
+              <a:p>
+                <a:pPr marL="0" indent="0">
+                  <a:buNone/>
+                </a:pPr>
+                <a14:m>
+                  <m:oMathPara xmlns:m="http://schemas.openxmlformats.org/officeDocument/2006/math">
+                    <m:oMathParaPr>
+                      <m:jc m:val="left"/>
+                    </m:oMathParaPr>
+                    <m:oMath xmlns:m="http://schemas.openxmlformats.org/officeDocument/2006/math">
+                      <m:r>
+                        <a:rPr lang="de-DE" sz="2400" i="1" smtClean="0">
+                          <a:latin typeface="Cambria Math" panose="02040503050406030204" pitchFamily="18" charset="0"/>
+                          <a:ea typeface="Cambria Math" panose="02040503050406030204" pitchFamily="18" charset="0"/>
+                        </a:rPr>
+                        <m:t>⇒</m:t>
+                      </m:r>
+                      <m:nary>
+                        <m:naryPr>
+                          <m:chr m:val="∑"/>
+                          <m:subHide m:val="on"/>
+                          <m:supHide m:val="on"/>
+                          <m:ctrlPr>
+                            <a:rPr lang="de-DE" sz="2400" i="1">
+                              <a:latin typeface="Cambria Math" panose="02040503050406030204" pitchFamily="18" charset="0"/>
+                            </a:rPr>
+                          </m:ctrlPr>
+                        </m:naryPr>
+                        <m:sub/>
+                        <m:sup/>
+                        <m:e>
+                          <m:d>
+                            <m:dPr>
+                              <m:ctrlPr>
+                                <a:rPr lang="de-DE" sz="2400" i="1">
+                                  <a:latin typeface="Cambria Math" panose="02040503050406030204" pitchFamily="18" charset="0"/>
+                                </a:rPr>
+                              </m:ctrlPr>
+                            </m:dPr>
+                            <m:e>
+                              <m:r>
+                                <a:rPr lang="de-DE" sz="2400" b="0" i="1" smtClean="0">
+                                  <a:latin typeface="Cambria Math" panose="02040503050406030204" pitchFamily="18" charset="0"/>
+                                </a:rPr>
+                                <m:t>𝑎</m:t>
+                              </m:r>
+                              <m:r>
+                                <a:rPr lang="de-DE" sz="2400" b="0" i="1" smtClean="0">
+                                  <a:latin typeface="Cambria Math" panose="02040503050406030204" pitchFamily="18" charset="0"/>
+                                </a:rPr>
+                                <m:t>−</m:t>
+                              </m:r>
+                              <m:sSub>
+                                <m:sSubPr>
+                                  <m:ctrlPr>
+                                    <a:rPr lang="de-DE" sz="2400" i="1">
+                                      <a:latin typeface="Cambria Math" panose="02040503050406030204" pitchFamily="18" charset="0"/>
+                                    </a:rPr>
+                                  </m:ctrlPr>
+                                </m:sSubPr>
+                                <m:e>
+                                  <m:r>
+                                    <a:rPr lang="de-DE" sz="2400" i="1">
+                                      <a:latin typeface="Cambria Math" panose="02040503050406030204" pitchFamily="18" charset="0"/>
+                                    </a:rPr>
+                                    <m:t>𝑥</m:t>
+                                  </m:r>
+                                </m:e>
+                                <m:sub>
+                                  <m:r>
+                                    <a:rPr lang="de-DE" sz="2400" i="1">
+                                      <a:latin typeface="Cambria Math" panose="02040503050406030204" pitchFamily="18" charset="0"/>
+                                    </a:rPr>
+                                    <m:t>𝑖</m:t>
+                                  </m:r>
+                                </m:sub>
+                              </m:sSub>
+                            </m:e>
+                          </m:d>
+                        </m:e>
+                      </m:nary>
+                      <m:r>
+                        <a:rPr lang="de-DE" sz="2400" b="0" i="1" smtClean="0">
+                          <a:latin typeface="Cambria Math" panose="02040503050406030204" pitchFamily="18" charset="0"/>
+                        </a:rPr>
+                        <m:t>=0</m:t>
+                      </m:r>
+                      <m:r>
+                        <a:rPr lang="de-DE" sz="2400" b="0" i="0" smtClean="0">
+                          <a:latin typeface="Cambria Math" panose="02040503050406030204" pitchFamily="18" charset="0"/>
+                        </a:rPr>
+                        <m:t> </m:t>
+                      </m:r>
+                      <m:r>
+                        <a:rPr lang="de-DE" sz="2400" b="0" i="1" smtClean="0">
+                          <a:latin typeface="Cambria Math" panose="02040503050406030204" pitchFamily="18" charset="0"/>
+                          <a:ea typeface="Cambria Math" panose="02040503050406030204" pitchFamily="18" charset="0"/>
+                        </a:rPr>
+                        <m:t>⇒</m:t>
+                      </m:r>
+                      <m:r>
+                        <a:rPr lang="de-DE" sz="2400" b="0" i="1" smtClean="0">
+                          <a:latin typeface="Cambria Math" panose="02040503050406030204" pitchFamily="18" charset="0"/>
+                        </a:rPr>
+                        <m:t>𝑛𝑎</m:t>
+                      </m:r>
+                      <m:r>
+                        <a:rPr lang="de-DE" sz="2400" b="0" i="1" smtClean="0">
+                          <a:latin typeface="Cambria Math" panose="02040503050406030204" pitchFamily="18" charset="0"/>
+                        </a:rPr>
+                        <m:t>−</m:t>
+                      </m:r>
+                      <m:nary>
+                        <m:naryPr>
+                          <m:chr m:val="∑"/>
+                          <m:subHide m:val="on"/>
+                          <m:supHide m:val="on"/>
+                          <m:ctrlPr>
+                            <a:rPr lang="de-DE" sz="2400" b="0" i="1" smtClean="0">
+                              <a:latin typeface="Cambria Math" panose="02040503050406030204" pitchFamily="18" charset="0"/>
+                            </a:rPr>
+                          </m:ctrlPr>
+                        </m:naryPr>
+                        <m:sub/>
+                        <m:sup/>
+                        <m:e>
+                          <m:sSub>
+                            <m:sSubPr>
+                              <m:ctrlPr>
+                                <a:rPr lang="de-DE" sz="2400" i="1">
+                                  <a:latin typeface="Cambria Math" panose="02040503050406030204" pitchFamily="18" charset="0"/>
+                                </a:rPr>
+                              </m:ctrlPr>
+                            </m:sSubPr>
+                            <m:e>
+                              <m:r>
+                                <a:rPr lang="de-DE" sz="2400" i="1">
+                                  <a:latin typeface="Cambria Math" panose="02040503050406030204" pitchFamily="18" charset="0"/>
+                                </a:rPr>
+                                <m:t>𝑥</m:t>
+                              </m:r>
+                            </m:e>
+                            <m:sub>
+                              <m:r>
+                                <a:rPr lang="de-DE" sz="2400" i="1">
+                                  <a:latin typeface="Cambria Math" panose="02040503050406030204" pitchFamily="18" charset="0"/>
+                                </a:rPr>
+                                <m:t>𝑖</m:t>
+                              </m:r>
+                            </m:sub>
+                          </m:sSub>
+                        </m:e>
+                      </m:nary>
+                      <m:r>
+                        <a:rPr lang="de-DE" sz="2400" b="0" i="1" smtClean="0">
+                          <a:latin typeface="Cambria Math" panose="02040503050406030204" pitchFamily="18" charset="0"/>
+                        </a:rPr>
+                        <m:t>=0</m:t>
+                      </m:r>
+                    </m:oMath>
+                  </m:oMathPara>
+                </a14:m>
+                <a:endParaRPr lang="de-DE" sz="2400" b="0" dirty="0"/>
+              </a:p>
+              <a:p>
+                <a:pPr marL="0" indent="0">
+                  <a:buNone/>
+                </a:pPr>
+                <a14:m>
+                  <m:oMath xmlns:m="http://schemas.openxmlformats.org/officeDocument/2006/math">
+                    <m:r>
+                      <a:rPr lang="de-DE" sz="2400" i="1">
+                        <a:latin typeface="Cambria Math" panose="02040503050406030204" pitchFamily="18" charset="0"/>
+                        <a:ea typeface="Cambria Math" panose="02040503050406030204" pitchFamily="18" charset="0"/>
+                      </a:rPr>
+                      <m:t>⇒</m:t>
+                    </m:r>
+                    <m:r>
+                      <a:rPr lang="de-DE" sz="2400" b="0" i="1" smtClean="0">
+                        <a:latin typeface="Cambria Math" panose="02040503050406030204" pitchFamily="18" charset="0"/>
+                      </a:rPr>
+                      <m:t>𝑎</m:t>
+                    </m:r>
+                    <m:r>
+                      <a:rPr lang="de-DE" sz="2400" b="0" i="1" smtClean="0">
+                        <a:latin typeface="Cambria Math" panose="02040503050406030204" pitchFamily="18" charset="0"/>
+                      </a:rPr>
+                      <m:t>=</m:t>
+                    </m:r>
+                    <m:f>
+                      <m:fPr>
+                        <m:ctrlPr>
+                          <a:rPr lang="de-DE" sz="2400" b="0" i="1" smtClean="0">
+                            <a:latin typeface="Cambria Math" panose="02040503050406030204" pitchFamily="18" charset="0"/>
+                          </a:rPr>
+                        </m:ctrlPr>
+                      </m:fPr>
+                      <m:num>
+                        <m:r>
+                          <a:rPr lang="de-DE" sz="2400" b="0" i="1" smtClean="0">
+                            <a:latin typeface="Cambria Math" panose="02040503050406030204" pitchFamily="18" charset="0"/>
+                          </a:rPr>
+                          <m:t>1</m:t>
+                        </m:r>
+                      </m:num>
+                      <m:den>
+                        <m:r>
+                          <a:rPr lang="de-DE" sz="2400" b="0" i="1" smtClean="0">
+                            <a:latin typeface="Cambria Math" panose="02040503050406030204" pitchFamily="18" charset="0"/>
+                          </a:rPr>
+                          <m:t>𝑛</m:t>
+                        </m:r>
+                      </m:den>
+                    </m:f>
+                    <m:nary>
+                      <m:naryPr>
+                        <m:chr m:val="∑"/>
+                        <m:ctrlPr>
+                          <a:rPr lang="de-DE" sz="2400" b="0" i="1" smtClean="0">
+                            <a:latin typeface="Cambria Math" panose="02040503050406030204" pitchFamily="18" charset="0"/>
+                          </a:rPr>
+                        </m:ctrlPr>
+                      </m:naryPr>
+                      <m:sub>
+                        <m:r>
+                          <m:rPr>
+                            <m:brk m:alnAt="23"/>
+                          </m:rPr>
+                          <a:rPr lang="de-DE" sz="2400" b="0" i="1" smtClean="0">
+                            <a:latin typeface="Cambria Math" panose="02040503050406030204" pitchFamily="18" charset="0"/>
+                          </a:rPr>
+                          <m:t>𝑖</m:t>
+                        </m:r>
+                        <m:r>
+                          <a:rPr lang="de-DE" sz="2400" b="0" i="1" smtClean="0">
+                            <a:latin typeface="Cambria Math" panose="02040503050406030204" pitchFamily="18" charset="0"/>
+                          </a:rPr>
+                          <m:t>=1</m:t>
+                        </m:r>
+                      </m:sub>
+                      <m:sup>
+                        <m:r>
+                          <a:rPr lang="de-DE" sz="2400" b="0" i="1" smtClean="0">
+                            <a:latin typeface="Cambria Math" panose="02040503050406030204" pitchFamily="18" charset="0"/>
+                          </a:rPr>
+                          <m:t>𝑛</m:t>
+                        </m:r>
+                      </m:sup>
+                      <m:e>
+                        <m:sSub>
+                          <m:sSubPr>
+                            <m:ctrlPr>
+                              <a:rPr lang="de-DE" sz="2400" b="0" i="1" smtClean="0">
+                                <a:latin typeface="Cambria Math" panose="02040503050406030204" pitchFamily="18" charset="0"/>
+                              </a:rPr>
+                            </m:ctrlPr>
+                          </m:sSubPr>
+                          <m:e>
+                            <m:r>
+                              <a:rPr lang="de-DE" sz="2400" b="0" i="1" smtClean="0">
+                                <a:latin typeface="Cambria Math" panose="02040503050406030204" pitchFamily="18" charset="0"/>
+                              </a:rPr>
+                              <m:t>𝑥</m:t>
+                            </m:r>
+                          </m:e>
+                          <m:sub>
+                            <m:r>
+                              <a:rPr lang="de-DE" sz="2400" b="0" i="1" smtClean="0">
+                                <a:latin typeface="Cambria Math" panose="02040503050406030204" pitchFamily="18" charset="0"/>
+                              </a:rPr>
+                              <m:t>𝑖</m:t>
+                            </m:r>
+                          </m:sub>
+                        </m:sSub>
+                      </m:e>
+                    </m:nary>
+                  </m:oMath>
+                </a14:m>
+                <a:r>
+                  <a:rPr lang="de-DE" sz="2400" dirty="0"/>
+                  <a:t> </a:t>
+                </a:r>
+                <a:r>
+                  <a:rPr lang="de-DE" sz="2400" dirty="0">
+                    <a:sym typeface="Wingdings" pitchFamily="2" charset="2"/>
+                  </a:rPr>
+                  <a:t> </a:t>
+                </a:r>
+                <a:r>
+                  <a:rPr lang="de-DE" sz="2400" dirty="0" err="1">
+                    <a:sym typeface="Wingdings" pitchFamily="2" charset="2"/>
+                  </a:rPr>
+                  <a:t>mean</a:t>
+                </a:r>
+                <a:endParaRPr lang="de-DE" sz="2400" dirty="0"/>
+              </a:p>
+            </p:txBody>
+          </p:sp>
+        </mc:Choice>
+        <mc:Fallback>
+          <p:sp>
+            <p:nvSpPr>
+              <p:cNvPr id="5" name="Inhaltsplatzhalter 4">
+                <a:extLst>
+                  <a:ext uri="{FF2B5EF4-FFF2-40B4-BE49-F238E27FC236}">
+                    <a16:creationId xmlns:a16="http://schemas.microsoft.com/office/drawing/2014/main" id="{DB2D2E5C-783C-A264-2A40-ADE2D331F73F}"/>
+                  </a:ext>
+                </a:extLst>
+              </p:cNvPr>
+              <p:cNvSpPr>
+                <a:spLocks noGrp="1" noRot="1" noChangeAspect="1" noMove="1" noResize="1" noEditPoints="1" noAdjustHandles="1" noChangeArrowheads="1" noChangeShapeType="1" noTextEdit="1"/>
+              </p:cNvSpPr>
+              <p:nvPr>
+                <p:ph sz="half" idx="1"/>
+              </p:nvPr>
+            </p:nvSpPr>
+            <p:spPr>
+              <a:blipFill>
+                <a:blip r:embed="rId2"/>
+                <a:stretch>
+                  <a:fillRect l="-12958" t="-10174" b="-25581"/>
+                </a:stretch>
+              </a:blipFill>
+            </p:spPr>
+            <p:txBody>
+              <a:bodyPr/>
+              <a:lstStyle/>
+              <a:p>
+                <a:r>
+                  <a:rPr lang="de-DE">
+                    <a:noFill/>
+                  </a:rPr>
+                  <a:t> </a:t>
+                </a:r>
+              </a:p>
+            </p:txBody>
+          </p:sp>
+        </mc:Fallback>
+      </mc:AlternateContent>
+      <mc:AlternateContent xmlns:mc="http://schemas.openxmlformats.org/markup-compatibility/2006">
+        <mc:Choice xmlns:a14="http://schemas.microsoft.com/office/drawing/2010/main" Requires="a14">
+          <p:sp>
+            <p:nvSpPr>
+              <p:cNvPr id="6" name="Inhaltsplatzhalter 5">
+                <a:extLst>
+                  <a:ext uri="{FF2B5EF4-FFF2-40B4-BE49-F238E27FC236}">
+                    <a16:creationId xmlns:a16="http://schemas.microsoft.com/office/drawing/2014/main" id="{734C84D0-8A69-5879-390D-1E0ACF82D07A}"/>
+                  </a:ext>
+                </a:extLst>
+              </p:cNvPr>
+              <p:cNvSpPr>
+                <a:spLocks noGrp="1"/>
+              </p:cNvSpPr>
+              <p:nvPr>
+                <p:ph sz="half" idx="2"/>
+              </p:nvPr>
+            </p:nvSpPr>
+            <p:spPr/>
+            <p:txBody>
+              <a:bodyPr>
+                <a:normAutofit fontScale="92500" lnSpcReduction="20000"/>
+              </a:bodyPr>
+              <a:lstStyle/>
+              <a:p>
+                <a:pPr marL="0" indent="0">
+                  <a:buNone/>
+                </a:pPr>
+                <a:r>
+                  <a:rPr lang="de-DE" sz="3300" dirty="0"/>
+                  <a:t>L1 </a:t>
+                </a:r>
+                <a:r>
+                  <a:rPr lang="de-DE" sz="3300" dirty="0" err="1"/>
+                  <a:t>objective</a:t>
+                </a:r>
+                <a:r>
+                  <a:rPr lang="de-DE" sz="3300" dirty="0"/>
+                  <a:t>:</a:t>
+                </a:r>
+              </a:p>
+              <a:p>
+                <a:pPr marL="0" indent="0">
+                  <a:buNone/>
+                </a:pPr>
+                <a:endParaRPr lang="de-DE" sz="2400" dirty="0"/>
+              </a:p>
+              <a:p>
+                <a:pPr marL="0" indent="0">
+                  <a:buNone/>
+                </a:pPr>
+                <a14:m>
+                  <m:oMathPara xmlns:m="http://schemas.openxmlformats.org/officeDocument/2006/math">
+                    <m:oMathParaPr>
+                      <m:jc m:val="left"/>
+                    </m:oMathParaPr>
+                    <m:oMath xmlns:m="http://schemas.openxmlformats.org/officeDocument/2006/math">
+                      <m:func>
+                        <m:funcPr>
+                          <m:ctrlPr>
+                            <a:rPr lang="de-DE" sz="2400" i="1">
+                              <a:latin typeface="Cambria Math" panose="02040503050406030204" pitchFamily="18" charset="0"/>
+                            </a:rPr>
+                          </m:ctrlPr>
+                        </m:funcPr>
+                        <m:fName>
+                          <m:limLow>
+                            <m:limLowPr>
+                              <m:ctrlPr>
+                                <a:rPr lang="de-DE" sz="2400" i="1">
+                                  <a:latin typeface="Cambria Math" panose="02040503050406030204" pitchFamily="18" charset="0"/>
+                                </a:rPr>
+                              </m:ctrlPr>
+                            </m:limLowPr>
+                            <m:e>
+                              <m:r>
+                                <m:rPr>
+                                  <m:sty m:val="p"/>
+                                </m:rPr>
+                                <a:rPr lang="de-DE" sz="2400">
+                                  <a:latin typeface="Cambria Math" panose="02040503050406030204" pitchFamily="18" charset="0"/>
+                                </a:rPr>
+                                <m:t>min</m:t>
+                              </m:r>
+                            </m:e>
+                            <m:lim>
+                              <m:r>
+                                <a:rPr lang="de-DE" sz="2400" i="1">
+                                  <a:latin typeface="Cambria Math" panose="02040503050406030204" pitchFamily="18" charset="0"/>
+                                </a:rPr>
+                                <m:t>𝑎</m:t>
+                              </m:r>
+                            </m:lim>
+                          </m:limLow>
+                        </m:fName>
+                        <m:e>
+                          <m:nary>
+                            <m:naryPr>
+                              <m:chr m:val="∑"/>
+                              <m:ctrlPr>
+                                <a:rPr lang="de-DE" sz="2400" i="1">
+                                  <a:latin typeface="Cambria Math" panose="02040503050406030204" pitchFamily="18" charset="0"/>
+                                </a:rPr>
+                              </m:ctrlPr>
+                            </m:naryPr>
+                            <m:sub>
+                              <m:r>
+                                <m:rPr>
+                                  <m:brk m:alnAt="23"/>
+                                </m:rPr>
+                                <a:rPr lang="de-DE" sz="2400" i="1">
+                                  <a:latin typeface="Cambria Math" panose="02040503050406030204" pitchFamily="18" charset="0"/>
+                                </a:rPr>
+                                <m:t>𝑖</m:t>
+                              </m:r>
+                              <m:r>
+                                <a:rPr lang="de-DE" sz="2400" i="1">
+                                  <a:latin typeface="Cambria Math" panose="02040503050406030204" pitchFamily="18" charset="0"/>
+                                </a:rPr>
+                                <m:t>=1</m:t>
+                              </m:r>
+                            </m:sub>
+                            <m:sup>
+                              <m:r>
+                                <a:rPr lang="de-DE" sz="2400" i="1">
+                                  <a:latin typeface="Cambria Math" panose="02040503050406030204" pitchFamily="18" charset="0"/>
+                                </a:rPr>
+                                <m:t>𝑛</m:t>
+                              </m:r>
+                            </m:sup>
+                            <m:e>
+                              <m:d>
+                                <m:dPr>
+                                  <m:begChr m:val="|"/>
+                                  <m:endChr m:val="|"/>
+                                  <m:ctrlPr>
+                                    <a:rPr lang="de-DE" sz="2400" i="1" smtClean="0">
+                                      <a:latin typeface="Cambria Math" panose="02040503050406030204" pitchFamily="18" charset="0"/>
+                                    </a:rPr>
+                                  </m:ctrlPr>
+                                </m:dPr>
+                                <m:e>
+                                  <m:sSub>
+                                    <m:sSubPr>
+                                      <m:ctrlPr>
+                                        <a:rPr lang="de-DE" sz="2400" i="1">
+                                          <a:latin typeface="Cambria Math" panose="02040503050406030204" pitchFamily="18" charset="0"/>
+                                        </a:rPr>
+                                      </m:ctrlPr>
+                                    </m:sSubPr>
+                                    <m:e>
+                                      <m:r>
+                                        <a:rPr lang="de-DE" sz="2400" i="1">
+                                          <a:latin typeface="Cambria Math" panose="02040503050406030204" pitchFamily="18" charset="0"/>
+                                        </a:rPr>
+                                        <m:t>𝑥</m:t>
+                                      </m:r>
+                                    </m:e>
+                                    <m:sub>
+                                      <m:r>
+                                        <a:rPr lang="de-DE" sz="2400" i="1">
+                                          <a:latin typeface="Cambria Math" panose="02040503050406030204" pitchFamily="18" charset="0"/>
+                                        </a:rPr>
+                                        <m:t>𝑖</m:t>
+                                      </m:r>
+                                    </m:sub>
+                                  </m:sSub>
+                                  <m:r>
+                                    <a:rPr lang="de-DE" sz="2400" i="1">
+                                      <a:latin typeface="Cambria Math" panose="02040503050406030204" pitchFamily="18" charset="0"/>
+                                    </a:rPr>
+                                    <m:t>−</m:t>
+                                  </m:r>
+                                  <m:r>
+                                    <a:rPr lang="de-DE" sz="2400" b="0" i="1" smtClean="0">
+                                      <a:latin typeface="Cambria Math" panose="02040503050406030204" pitchFamily="18" charset="0"/>
+                                    </a:rPr>
+                                    <m:t>𝑎</m:t>
+                                  </m:r>
+                                </m:e>
+                              </m:d>
+                            </m:e>
+                          </m:nary>
+                        </m:e>
+                      </m:func>
+                    </m:oMath>
+                  </m:oMathPara>
+                </a14:m>
+                <a:endParaRPr lang="de-DE" sz="2400" dirty="0"/>
+              </a:p>
+              <a:p>
+                <a:pPr marL="0" indent="0">
+                  <a:buNone/>
+                </a:pPr>
+                <a:endParaRPr lang="de-DE" sz="2400" dirty="0"/>
+              </a:p>
+              <a:p>
+                <a:pPr marL="0" indent="0">
+                  <a:buNone/>
+                </a:pPr>
+                <a14:m>
+                  <m:oMathPara xmlns:m="http://schemas.openxmlformats.org/officeDocument/2006/math">
+                    <m:oMathParaPr>
+                      <m:jc m:val="left"/>
+                    </m:oMathParaPr>
+                    <m:oMath xmlns:m="http://schemas.openxmlformats.org/officeDocument/2006/math">
+                      <m:f>
+                        <m:fPr>
+                          <m:ctrlPr>
+                            <a:rPr lang="de-DE" sz="2400" i="1">
+                              <a:latin typeface="Cambria Math" panose="02040503050406030204" pitchFamily="18" charset="0"/>
+                            </a:rPr>
+                          </m:ctrlPr>
+                        </m:fPr>
+                        <m:num>
+                          <m:r>
+                            <a:rPr lang="de-DE" sz="2400" i="1">
+                              <a:latin typeface="Cambria Math" panose="02040503050406030204" pitchFamily="18" charset="0"/>
+                            </a:rPr>
+                            <m:t>𝑑</m:t>
+                          </m:r>
+                        </m:num>
+                        <m:den>
+                          <m:r>
+                            <a:rPr lang="de-DE" sz="2400" i="1">
+                              <a:latin typeface="Cambria Math" panose="02040503050406030204" pitchFamily="18" charset="0"/>
+                            </a:rPr>
+                            <m:t>𝑑𝑎</m:t>
+                          </m:r>
+                        </m:den>
+                      </m:f>
+                      <m:nary>
+                        <m:naryPr>
+                          <m:chr m:val="∑"/>
+                          <m:subHide m:val="on"/>
+                          <m:supHide m:val="on"/>
+                          <m:ctrlPr>
+                            <a:rPr lang="de-DE" sz="2400" i="1">
+                              <a:latin typeface="Cambria Math" panose="02040503050406030204" pitchFamily="18" charset="0"/>
+                            </a:rPr>
+                          </m:ctrlPr>
+                        </m:naryPr>
+                        <m:sub/>
+                        <m:sup/>
+                        <m:e>
+                          <m:d>
+                            <m:dPr>
+                              <m:begChr m:val="|"/>
+                              <m:endChr m:val="|"/>
+                              <m:ctrlPr>
+                                <a:rPr lang="de-DE" sz="2400" i="1">
+                                  <a:latin typeface="Cambria Math" panose="02040503050406030204" pitchFamily="18" charset="0"/>
+                                </a:rPr>
+                              </m:ctrlPr>
+                            </m:dPr>
+                            <m:e>
+                              <m:sSub>
+                                <m:sSubPr>
+                                  <m:ctrlPr>
+                                    <a:rPr lang="de-DE" sz="2400" i="1">
+                                      <a:latin typeface="Cambria Math" panose="02040503050406030204" pitchFamily="18" charset="0"/>
+                                    </a:rPr>
+                                  </m:ctrlPr>
+                                </m:sSubPr>
+                                <m:e>
+                                  <m:r>
+                                    <a:rPr lang="de-DE" sz="2400" i="1">
+                                      <a:latin typeface="Cambria Math" panose="02040503050406030204" pitchFamily="18" charset="0"/>
+                                    </a:rPr>
+                                    <m:t>𝑥</m:t>
+                                  </m:r>
+                                </m:e>
+                                <m:sub>
+                                  <m:r>
+                                    <a:rPr lang="de-DE" sz="2400" i="1">
+                                      <a:latin typeface="Cambria Math" panose="02040503050406030204" pitchFamily="18" charset="0"/>
+                                    </a:rPr>
+                                    <m:t>𝑖</m:t>
+                                  </m:r>
+                                </m:sub>
+                              </m:sSub>
+                              <m:r>
+                                <a:rPr lang="de-DE" sz="2400" i="1">
+                                  <a:latin typeface="Cambria Math" panose="02040503050406030204" pitchFamily="18" charset="0"/>
+                                </a:rPr>
+                                <m:t>−</m:t>
+                              </m:r>
+                              <m:r>
+                                <a:rPr lang="de-DE" sz="2400" i="1">
+                                  <a:latin typeface="Cambria Math" panose="02040503050406030204" pitchFamily="18" charset="0"/>
+                                </a:rPr>
+                                <m:t>𝑎</m:t>
+                              </m:r>
+                            </m:e>
+                          </m:d>
+                        </m:e>
+                      </m:nary>
+                      <m:r>
+                        <a:rPr lang="de-DE" sz="2400" i="1">
+                          <a:latin typeface="Cambria Math" panose="02040503050406030204" pitchFamily="18" charset="0"/>
+                        </a:rPr>
+                        <m:t>=0</m:t>
+                      </m:r>
+                    </m:oMath>
+                  </m:oMathPara>
+                </a14:m>
+                <a:endParaRPr lang="de-DE" sz="2400" dirty="0"/>
+              </a:p>
+              <a:p>
+                <a:pPr marL="0" indent="0">
+                  <a:buNone/>
+                </a:pPr>
+                <a:endParaRPr lang="de-DE" sz="2400" dirty="0"/>
+              </a:p>
+              <a:p>
+                <a:pPr marL="0" indent="0">
+                  <a:buNone/>
+                </a:pPr>
+                <a14:m>
+                  <m:oMathPara xmlns:m="http://schemas.openxmlformats.org/officeDocument/2006/math">
+                    <m:oMathParaPr>
+                      <m:jc m:val="left"/>
+                    </m:oMathParaPr>
+                    <m:oMath xmlns:m="http://schemas.openxmlformats.org/officeDocument/2006/math">
+                      <m:r>
+                        <a:rPr lang="de-DE" sz="2400" i="1">
+                          <a:latin typeface="Cambria Math" panose="02040503050406030204" pitchFamily="18" charset="0"/>
+                          <a:ea typeface="Cambria Math" panose="02040503050406030204" pitchFamily="18" charset="0"/>
+                        </a:rPr>
+                        <m:t>⇒</m:t>
+                      </m:r>
+                      <m:nary>
+                        <m:naryPr>
+                          <m:chr m:val="∑"/>
+                          <m:subHide m:val="on"/>
+                          <m:supHide m:val="on"/>
+                          <m:ctrlPr>
+                            <a:rPr lang="de-DE" sz="2400" i="1">
+                              <a:latin typeface="Cambria Math" panose="02040503050406030204" pitchFamily="18" charset="0"/>
+                            </a:rPr>
+                          </m:ctrlPr>
+                        </m:naryPr>
+                        <m:sub/>
+                        <m:sup/>
+                        <m:e>
+                          <m:r>
+                            <m:rPr>
+                              <m:sty m:val="p"/>
+                            </m:rPr>
+                            <a:rPr lang="de-DE" sz="2400" b="0" i="0" smtClean="0">
+                              <a:latin typeface="Cambria Math" panose="02040503050406030204" pitchFamily="18" charset="0"/>
+                            </a:rPr>
+                            <m:t>sign</m:t>
+                          </m:r>
+                          <m:d>
+                            <m:dPr>
+                              <m:ctrlPr>
+                                <a:rPr lang="de-DE" sz="2400" i="1">
+                                  <a:latin typeface="Cambria Math" panose="02040503050406030204" pitchFamily="18" charset="0"/>
+                                </a:rPr>
+                              </m:ctrlPr>
+                            </m:dPr>
+                            <m:e>
+                              <m:r>
+                                <a:rPr lang="de-DE" sz="2400" i="1">
+                                  <a:latin typeface="Cambria Math" panose="02040503050406030204" pitchFamily="18" charset="0"/>
+                                </a:rPr>
+                                <m:t>𝑎</m:t>
+                              </m:r>
+                              <m:r>
+                                <a:rPr lang="de-DE" sz="2400" i="1">
+                                  <a:latin typeface="Cambria Math" panose="02040503050406030204" pitchFamily="18" charset="0"/>
+                                </a:rPr>
+                                <m:t>−</m:t>
+                              </m:r>
+                              <m:sSub>
+                                <m:sSubPr>
+                                  <m:ctrlPr>
+                                    <a:rPr lang="de-DE" sz="2400" i="1">
+                                      <a:latin typeface="Cambria Math" panose="02040503050406030204" pitchFamily="18" charset="0"/>
+                                    </a:rPr>
+                                  </m:ctrlPr>
+                                </m:sSubPr>
+                                <m:e>
+                                  <m:r>
+                                    <a:rPr lang="de-DE" sz="2400" i="1">
+                                      <a:latin typeface="Cambria Math" panose="02040503050406030204" pitchFamily="18" charset="0"/>
+                                    </a:rPr>
+                                    <m:t>𝑥</m:t>
+                                  </m:r>
+                                </m:e>
+                                <m:sub>
+                                  <m:r>
+                                    <a:rPr lang="de-DE" sz="2400" i="1">
+                                      <a:latin typeface="Cambria Math" panose="02040503050406030204" pitchFamily="18" charset="0"/>
+                                    </a:rPr>
+                                    <m:t>𝑖</m:t>
+                                  </m:r>
+                                </m:sub>
+                              </m:sSub>
+                            </m:e>
+                          </m:d>
+                        </m:e>
+                      </m:nary>
+                      <m:r>
+                        <a:rPr lang="de-DE" sz="2400" i="1">
+                          <a:latin typeface="Cambria Math" panose="02040503050406030204" pitchFamily="18" charset="0"/>
+                        </a:rPr>
+                        <m:t>=0</m:t>
+                      </m:r>
+                    </m:oMath>
+                  </m:oMathPara>
+                </a14:m>
+                <a:endParaRPr lang="de-DE" sz="2400" dirty="0"/>
+              </a:p>
+              <a:p>
+                <a:pPr marL="0" indent="0">
+                  <a:buNone/>
+                </a:pPr>
+                <a14:m>
+                  <m:oMath xmlns:m="http://schemas.openxmlformats.org/officeDocument/2006/math">
+                    <m:r>
+                      <a:rPr lang="de-DE" sz="2400" i="1">
+                        <a:latin typeface="Cambria Math" panose="02040503050406030204" pitchFamily="18" charset="0"/>
+                        <a:ea typeface="Cambria Math" panose="02040503050406030204" pitchFamily="18" charset="0"/>
+                      </a:rPr>
+                      <m:t>⇒</m:t>
+                    </m:r>
+                    <m:r>
+                      <a:rPr lang="de-DE" sz="2400" b="0" i="1" smtClean="0">
+                        <a:latin typeface="Cambria Math" panose="02040503050406030204" pitchFamily="18" charset="0"/>
+                        <a:sym typeface="Wingdings" pitchFamily="2" charset="2"/>
+                      </a:rPr>
+                      <m:t>#</m:t>
+                    </m:r>
+                    <m:d>
+                      <m:dPr>
+                        <m:ctrlPr>
+                          <a:rPr lang="de-DE" sz="2400" b="0" i="1" smtClean="0">
+                            <a:latin typeface="Cambria Math" panose="02040503050406030204" pitchFamily="18" charset="0"/>
+                            <a:sym typeface="Wingdings" pitchFamily="2" charset="2"/>
+                          </a:rPr>
+                        </m:ctrlPr>
+                      </m:dPr>
+                      <m:e>
+                        <m:sSub>
+                          <m:sSubPr>
+                            <m:ctrlPr>
+                              <a:rPr lang="de-DE" sz="2400" i="1">
+                                <a:latin typeface="Cambria Math" panose="02040503050406030204" pitchFamily="18" charset="0"/>
+                              </a:rPr>
+                            </m:ctrlPr>
+                          </m:sSubPr>
+                          <m:e>
+                            <m:r>
+                              <a:rPr lang="de-DE" sz="2400" i="1">
+                                <a:latin typeface="Cambria Math" panose="02040503050406030204" pitchFamily="18" charset="0"/>
+                              </a:rPr>
+                              <m:t>𝑥</m:t>
+                            </m:r>
+                          </m:e>
+                          <m:sub>
+                            <m:r>
+                              <a:rPr lang="de-DE" sz="2400" i="1">
+                                <a:latin typeface="Cambria Math" panose="02040503050406030204" pitchFamily="18" charset="0"/>
+                              </a:rPr>
+                              <m:t>𝑖</m:t>
+                            </m:r>
+                          </m:sub>
+                        </m:sSub>
+                        <m:r>
+                          <a:rPr lang="de-DE" sz="2400" i="1">
+                            <a:latin typeface="Cambria Math" panose="02040503050406030204" pitchFamily="18" charset="0"/>
+                          </a:rPr>
+                          <m:t>&lt;</m:t>
+                        </m:r>
+                        <m:r>
+                          <a:rPr lang="de-DE" sz="2400" b="0" i="1" smtClean="0">
+                            <a:latin typeface="Cambria Math" panose="02040503050406030204" pitchFamily="18" charset="0"/>
+                          </a:rPr>
+                          <m:t>𝑎</m:t>
+                        </m:r>
+                      </m:e>
+                    </m:d>
+                    <m:r>
+                      <a:rPr lang="de-DE" sz="2400" b="0" i="1" smtClean="0">
+                        <a:latin typeface="Cambria Math" panose="02040503050406030204" pitchFamily="18" charset="0"/>
+                        <a:sym typeface="Wingdings" pitchFamily="2" charset="2"/>
+                      </a:rPr>
+                      <m:t>=</m:t>
+                    </m:r>
+                    <m:r>
+                      <a:rPr lang="de-DE" sz="2400" i="1">
+                        <a:latin typeface="Cambria Math" panose="02040503050406030204" pitchFamily="18" charset="0"/>
+                        <a:sym typeface="Wingdings" pitchFamily="2" charset="2"/>
+                      </a:rPr>
+                      <m:t>#</m:t>
+                    </m:r>
+                    <m:d>
+                      <m:dPr>
+                        <m:ctrlPr>
+                          <a:rPr lang="de-DE" sz="2400" i="1">
+                            <a:latin typeface="Cambria Math" panose="02040503050406030204" pitchFamily="18" charset="0"/>
+                            <a:sym typeface="Wingdings" pitchFamily="2" charset="2"/>
+                          </a:rPr>
+                        </m:ctrlPr>
+                      </m:dPr>
+                      <m:e>
+                        <m:sSub>
+                          <m:sSubPr>
+                            <m:ctrlPr>
+                              <a:rPr lang="de-DE" sz="2400" i="1">
+                                <a:latin typeface="Cambria Math" panose="02040503050406030204" pitchFamily="18" charset="0"/>
+                              </a:rPr>
+                            </m:ctrlPr>
+                          </m:sSubPr>
+                          <m:e>
+                            <m:r>
+                              <a:rPr lang="de-DE" sz="2400" i="1">
+                                <a:latin typeface="Cambria Math" panose="02040503050406030204" pitchFamily="18" charset="0"/>
+                              </a:rPr>
+                              <m:t>𝑥</m:t>
+                            </m:r>
+                          </m:e>
+                          <m:sub>
+                            <m:r>
+                              <a:rPr lang="de-DE" sz="2400" i="1">
+                                <a:latin typeface="Cambria Math" panose="02040503050406030204" pitchFamily="18" charset="0"/>
+                              </a:rPr>
+                              <m:t>𝑖</m:t>
+                            </m:r>
+                          </m:sub>
+                        </m:sSub>
+                        <m:r>
+                          <a:rPr lang="de-DE" sz="2400" b="0" i="1" smtClean="0">
+                            <a:latin typeface="Cambria Math" panose="02040503050406030204" pitchFamily="18" charset="0"/>
+                          </a:rPr>
+                          <m:t>&gt;</m:t>
+                        </m:r>
+                        <m:r>
+                          <a:rPr lang="de-DE" sz="2400" b="0" i="1" smtClean="0">
+                            <a:latin typeface="Cambria Math" panose="02040503050406030204" pitchFamily="18" charset="0"/>
+                          </a:rPr>
+                          <m:t>𝑎</m:t>
+                        </m:r>
+                      </m:e>
+                    </m:d>
+                  </m:oMath>
+                </a14:m>
+                <a:r>
+                  <a:rPr lang="de-DE" sz="2400" dirty="0">
+                    <a:sym typeface="Wingdings" pitchFamily="2" charset="2"/>
+                  </a:rPr>
+                  <a:t>  median</a:t>
+                </a:r>
+                <a:endParaRPr lang="de-DE" sz="2400" dirty="0"/>
+              </a:p>
+            </p:txBody>
+          </p:sp>
+        </mc:Choice>
+        <mc:Fallback>
+          <p:sp>
+            <p:nvSpPr>
+              <p:cNvPr id="6" name="Inhaltsplatzhalter 5">
+                <a:extLst>
+                  <a:ext uri="{FF2B5EF4-FFF2-40B4-BE49-F238E27FC236}">
+                    <a16:creationId xmlns:a16="http://schemas.microsoft.com/office/drawing/2014/main" id="{734C84D0-8A69-5879-390D-1E0ACF82D07A}"/>
+                  </a:ext>
+                </a:extLst>
+              </p:cNvPr>
+              <p:cNvSpPr>
+                <a:spLocks noGrp="1" noRot="1" noChangeAspect="1" noMove="1" noResize="1" noEditPoints="1" noAdjustHandles="1" noChangeArrowheads="1" noChangeShapeType="1" noTextEdit="1"/>
+              </p:cNvSpPr>
+              <p:nvPr>
+                <p:ph sz="half" idx="2"/>
+              </p:nvPr>
+            </p:nvSpPr>
+            <p:spPr>
+              <a:blipFill>
+                <a:blip r:embed="rId3"/>
+                <a:stretch>
+                  <a:fillRect l="-12958" t="-10174" b="-25581"/>
+                </a:stretch>
+              </a:blipFill>
+            </p:spPr>
+            <p:txBody>
+              <a:bodyPr/>
+              <a:lstStyle/>
+              <a:p>
+                <a:r>
+                  <a:rPr lang="de-DE">
+                    <a:noFill/>
+                  </a:rPr>
+                  <a:t> </a:t>
+                </a:r>
+              </a:p>
+            </p:txBody>
+          </p:sp>
+        </mc:Fallback>
+      </mc:AlternateContent>
       <p:sp>
         <p:nvSpPr>
           <p:cNvPr id="4" name="Foliennummernplatzhalter 3">
@@ -6924,7 +8200,7 @@
           <p:cNvPr id="2" name="Titel 1">
             <a:extLst>
               <a:ext uri="{FF2B5EF4-FFF2-40B4-BE49-F238E27FC236}">
-                <a16:creationId xmlns:a16="http://schemas.microsoft.com/office/drawing/2014/main" id="{0BB459EB-FAE8-31DC-E38F-3046EC588CF6}"/>
+                <a16:creationId xmlns:a16="http://schemas.microsoft.com/office/drawing/2014/main" id="{E1872AF3-6DAA-E6C2-A919-228FF3EB5851}"/>
               </a:ext>
             </a:extLst>
           </p:cNvPr>
@@ -6941,51 +8217,22 @@
           <a:lstStyle/>
           <a:p>
             <a:r>
-              <a:rPr lang="de-DE" dirty="0"/>
-              <a:t>… Evaluation </a:t>
-            </a:r>
-            <a:r>
-              <a:rPr lang="de-DE" dirty="0" err="1"/>
-              <a:t>against</a:t>
-            </a:r>
-            <a:r>
-              <a:rPr lang="de-DE" dirty="0"/>
-              <a:t> True Labels …</a:t>
+              <a:rPr lang="de-DE" dirty="0" err="1"/>
+              <a:t>Visualizing</a:t>
+            </a:r>
+            <a:r>
+              <a:rPr lang="de-DE" dirty="0"/>
+              <a:t> Clusters</a:t>
             </a:r>
           </a:p>
         </p:txBody>
       </p:sp>
       <p:sp>
         <p:nvSpPr>
-          <p:cNvPr id="3" name="Inhaltsplatzhalter 2">
+          <p:cNvPr id="3" name="Foliennummernplatzhalter 2">
             <a:extLst>
               <a:ext uri="{FF2B5EF4-FFF2-40B4-BE49-F238E27FC236}">
-                <a16:creationId xmlns:a16="http://schemas.microsoft.com/office/drawing/2014/main" id="{392427C8-4330-BC0E-F7FF-95DB2D9863DA}"/>
-              </a:ext>
-            </a:extLst>
-          </p:cNvPr>
-          <p:cNvSpPr>
-            <a:spLocks noGrp="1"/>
-          </p:cNvSpPr>
-          <p:nvPr>
-            <p:ph idx="1"/>
-          </p:nvPr>
-        </p:nvSpPr>
-        <p:spPr/>
-        <p:txBody>
-          <a:bodyPr/>
-          <a:lstStyle/>
-          <a:p>
-            <a:endParaRPr lang="de-DE"/>
-          </a:p>
-        </p:txBody>
-      </p:sp>
-      <p:sp>
-        <p:nvSpPr>
-          <p:cNvPr id="4" name="Foliennummernplatzhalter 3">
-            <a:extLst>
-              <a:ext uri="{FF2B5EF4-FFF2-40B4-BE49-F238E27FC236}">
-                <a16:creationId xmlns:a16="http://schemas.microsoft.com/office/drawing/2014/main" id="{701A4EA1-06DA-F940-1383-630B8622B38F}"/>
+                <a16:creationId xmlns:a16="http://schemas.microsoft.com/office/drawing/2014/main" id="{81251F56-854B-D4C6-04C7-5A3B3F8DB84E}"/>
               </a:ext>
             </a:extLst>
           </p:cNvPr>
@@ -7012,7 +8259,7 @@
     </p:spTree>
     <p:extLst>
       <p:ext uri="{BB962C8B-B14F-4D97-AF65-F5344CB8AC3E}">
-        <p14:creationId xmlns:p14="http://schemas.microsoft.com/office/powerpoint/2010/main" val="2860005827"/>
+        <p14:creationId xmlns:p14="http://schemas.microsoft.com/office/powerpoint/2010/main" val="2070037097"/>
       </p:ext>
     </p:extLst>
   </p:cSld>
@@ -7044,7 +8291,7 @@
           <p:cNvPr id="2" name="Titel 1">
             <a:extLst>
               <a:ext uri="{FF2B5EF4-FFF2-40B4-BE49-F238E27FC236}">
-                <a16:creationId xmlns:a16="http://schemas.microsoft.com/office/drawing/2014/main" id="{AE45E519-E948-8501-ACAD-BDF00444DFDC}"/>
+                <a16:creationId xmlns:a16="http://schemas.microsoft.com/office/drawing/2014/main" id="{121AA823-E2CE-8C0D-90DB-02DFE9572552}"/>
               </a:ext>
             </a:extLst>
           </p:cNvPr>
@@ -7062,11 +8309,11 @@
           <a:p>
             <a:r>
               <a:rPr lang="de-DE" dirty="0"/>
-              <a:t>Mini Batch </a:t>
-            </a:r>
-            <a:r>
-              <a:rPr lang="de-DE" dirty="0" err="1"/>
-              <a:t>k-Means</a:t>
+              <a:t>Cluster Validation </a:t>
+            </a:r>
+            <a:r>
+              <a:rPr lang="de-DE" dirty="0" err="1"/>
+              <a:t>Metrics</a:t>
             </a:r>
             <a:endParaRPr lang="de-DE" dirty="0"/>
           </a:p>
@@ -7077,7 +8324,7 @@
           <p:cNvPr id="4" name="Inhaltsplatzhalter 3">
             <a:extLst>
               <a:ext uri="{FF2B5EF4-FFF2-40B4-BE49-F238E27FC236}">
-                <a16:creationId xmlns:a16="http://schemas.microsoft.com/office/drawing/2014/main" id="{DAA8C059-BF98-DA76-D11E-B2885769186E}"/>
+                <a16:creationId xmlns:a16="http://schemas.microsoft.com/office/drawing/2014/main" id="{4AAAE878-7307-C927-4B47-5A9C5B86AC4E}"/>
               </a:ext>
             </a:extLst>
           </p:cNvPr>
@@ -7093,7 +8340,182 @@
           <a:bodyPr/>
           <a:lstStyle/>
           <a:p>
-            <a:endParaRPr lang="de-DE"/>
+            <a:pPr marL="0" indent="0">
+              <a:buNone/>
+            </a:pPr>
+            <a:r>
+              <a:rPr lang="de-DE" dirty="0" err="1"/>
+              <a:t>Since</a:t>
+            </a:r>
+            <a:r>
+              <a:rPr lang="de-DE" dirty="0"/>
+              <a:t> </a:t>
+            </a:r>
+            <a:r>
+              <a:rPr lang="de-DE" dirty="0" err="1"/>
+              <a:t>clustering</a:t>
+            </a:r>
+            <a:r>
+              <a:rPr lang="de-DE" dirty="0"/>
+              <a:t> </a:t>
+            </a:r>
+            <a:r>
+              <a:rPr lang="de-DE" dirty="0" err="1"/>
+              <a:t>is</a:t>
+            </a:r>
+            <a:r>
+              <a:rPr lang="de-DE" dirty="0"/>
+              <a:t> </a:t>
+            </a:r>
+            <a:r>
+              <a:rPr lang="de-DE" dirty="0" err="1"/>
+              <a:t>unsupervised</a:t>
+            </a:r>
+            <a:r>
+              <a:rPr lang="de-DE" dirty="0"/>
+              <a:t>: </a:t>
+            </a:r>
+            <a:r>
+              <a:rPr lang="de-DE" dirty="0" err="1"/>
+              <a:t>no</a:t>
+            </a:r>
+            <a:r>
+              <a:rPr lang="de-DE" dirty="0"/>
+              <a:t> </a:t>
+            </a:r>
+            <a:r>
+              <a:rPr lang="de-DE" dirty="0" err="1"/>
+              <a:t>single</a:t>
+            </a:r>
+            <a:r>
+              <a:rPr lang="de-DE" dirty="0"/>
+              <a:t> “</a:t>
+            </a:r>
+            <a:r>
+              <a:rPr lang="de-DE" dirty="0" err="1"/>
+              <a:t>correct</a:t>
+            </a:r>
+            <a:r>
+              <a:rPr lang="de-DE" dirty="0"/>
+              <a:t>” </a:t>
+            </a:r>
+            <a:r>
+              <a:rPr lang="de-DE" dirty="0" err="1"/>
+              <a:t>answer</a:t>
+            </a:r>
+            <a:endParaRPr lang="de-DE" dirty="0"/>
+          </a:p>
+          <a:p>
+            <a:pPr marL="0" indent="0">
+              <a:buNone/>
+            </a:pPr>
+            <a:endParaRPr lang="de-DE" dirty="0"/>
+          </a:p>
+          <a:p>
+            <a:pPr marL="0" indent="0">
+              <a:buNone/>
+            </a:pPr>
+            <a:r>
+              <a:rPr lang="de-DE" dirty="0" err="1"/>
+              <a:t>Instead</a:t>
+            </a:r>
+            <a:r>
+              <a:rPr lang="de-DE" dirty="0"/>
+              <a:t> </a:t>
+            </a:r>
+            <a:r>
+              <a:rPr lang="de-DE" dirty="0" err="1"/>
+              <a:t>measure</a:t>
+            </a:r>
+            <a:r>
+              <a:rPr lang="de-DE" dirty="0"/>
+              <a:t> </a:t>
+            </a:r>
+            <a:r>
+              <a:rPr lang="de-DE" dirty="0" err="1"/>
+              <a:t>how</a:t>
+            </a:r>
+            <a:r>
+              <a:rPr lang="de-DE" dirty="0"/>
+              <a:t> well-</a:t>
+            </a:r>
+            <a:r>
+              <a:rPr lang="de-DE" dirty="0" err="1"/>
+              <a:t>separated</a:t>
+            </a:r>
+            <a:r>
+              <a:rPr lang="de-DE" dirty="0"/>
+              <a:t> and </a:t>
+            </a:r>
+            <a:r>
+              <a:rPr lang="de-DE" dirty="0" err="1"/>
+              <a:t>cohesive</a:t>
+            </a:r>
+            <a:r>
+              <a:rPr lang="de-DE" dirty="0"/>
+              <a:t> </a:t>
+            </a:r>
+            <a:r>
+              <a:rPr lang="de-DE" dirty="0" err="1"/>
+              <a:t>clusters</a:t>
+            </a:r>
+            <a:r>
+              <a:rPr lang="de-DE" dirty="0"/>
+              <a:t> </a:t>
+            </a:r>
+            <a:r>
+              <a:rPr lang="de-DE" dirty="0" err="1"/>
+              <a:t>are</a:t>
+            </a:r>
+            <a:endParaRPr lang="de-DE" dirty="0"/>
+          </a:p>
+          <a:p>
+            <a:pPr marL="0" indent="0">
+              <a:buNone/>
+            </a:pPr>
+            <a:endParaRPr lang="de-DE" dirty="0"/>
+          </a:p>
+          <a:p>
+            <a:pPr marL="0" indent="0">
+              <a:buNone/>
+            </a:pPr>
+            <a:r>
+              <a:rPr lang="de-DE" dirty="0"/>
+              <a:t>Evaluation </a:t>
+            </a:r>
+            <a:r>
+              <a:rPr lang="de-DE" dirty="0" err="1"/>
+              <a:t>metrics</a:t>
+            </a:r>
+            <a:r>
+              <a:rPr lang="de-DE" dirty="0"/>
+              <a:t>:</a:t>
+            </a:r>
+          </a:p>
+          <a:p>
+            <a:r>
+              <a:rPr lang="de-DE" dirty="0"/>
+              <a:t>Silhouette score</a:t>
+            </a:r>
+          </a:p>
+          <a:p>
+            <a:r>
+              <a:rPr lang="de-DE" dirty="0"/>
+              <a:t>Davies-</a:t>
+            </a:r>
+            <a:r>
+              <a:rPr lang="de-DE" dirty="0" err="1"/>
+              <a:t>Bouldin</a:t>
+            </a:r>
+            <a:r>
+              <a:rPr lang="de-DE" dirty="0"/>
+              <a:t> </a:t>
+            </a:r>
+            <a:r>
+              <a:rPr lang="de-DE" dirty="0" err="1"/>
+              <a:t>index</a:t>
+            </a:r>
+            <a:endParaRPr lang="de-DE" dirty="0"/>
           </a:p>
         </p:txBody>
       </p:sp>
@@ -7102,7 +8524,7 @@
           <p:cNvPr id="3" name="Foliennummernplatzhalter 2">
             <a:extLst>
               <a:ext uri="{FF2B5EF4-FFF2-40B4-BE49-F238E27FC236}">
-                <a16:creationId xmlns:a16="http://schemas.microsoft.com/office/drawing/2014/main" id="{2B02C868-452A-3E9E-3E72-BA889BC8609C}"/>
+                <a16:creationId xmlns:a16="http://schemas.microsoft.com/office/drawing/2014/main" id="{563E3869-C5B7-1A95-0614-2B381BD8C120}"/>
               </a:ext>
             </a:extLst>
           </p:cNvPr>
@@ -7121,6 +8543,967 @@
             <a:fld id="{08C366F5-AFAD-49CB-854A-9D9E238FCA13}" type="slidenum">
               <a:rPr lang="en-GB" smtClean="0"/>
               <a:t>18</a:t>
+            </a:fld>
+            <a:endParaRPr lang="en-GB"/>
+          </a:p>
+        </p:txBody>
+      </p:sp>
+    </p:spTree>
+    <p:extLst>
+      <p:ext uri="{BB962C8B-B14F-4D97-AF65-F5344CB8AC3E}">
+        <p14:creationId xmlns:p14="http://schemas.microsoft.com/office/powerpoint/2010/main" val="474217543"/>
+      </p:ext>
+    </p:extLst>
+  </p:cSld>
+  <p:clrMapOvr>
+    <a:masterClrMapping/>
+  </p:clrMapOvr>
+</p:sld>
+</file>
+
+<file path=ppt/slides/slide19.xml><?xml version="1.0" encoding="utf-8"?>
+<p:sld xmlns:a="http://schemas.openxmlformats.org/drawingml/2006/main" xmlns:r="http://schemas.openxmlformats.org/officeDocument/2006/relationships" xmlns:p="http://schemas.openxmlformats.org/presentationml/2006/main">
+  <p:cSld>
+    <p:spTree>
+      <p:nvGrpSpPr>
+        <p:cNvPr id="1" name=""/>
+        <p:cNvGrpSpPr/>
+        <p:nvPr/>
+      </p:nvGrpSpPr>
+      <p:grpSpPr>
+        <a:xfrm>
+          <a:off x="0" y="0"/>
+          <a:ext cx="0" cy="0"/>
+          <a:chOff x="0" y="0"/>
+          <a:chExt cx="0" cy="0"/>
+        </a:xfrm>
+      </p:grpSpPr>
+      <p:sp>
+        <p:nvSpPr>
+          <p:cNvPr id="2" name="Titel 1">
+            <a:extLst>
+              <a:ext uri="{FF2B5EF4-FFF2-40B4-BE49-F238E27FC236}">
+                <a16:creationId xmlns:a16="http://schemas.microsoft.com/office/drawing/2014/main" id="{0BB459EB-FAE8-31DC-E38F-3046EC588CF6}"/>
+              </a:ext>
+            </a:extLst>
+          </p:cNvPr>
+          <p:cNvSpPr>
+            <a:spLocks noGrp="1"/>
+          </p:cNvSpPr>
+          <p:nvPr>
+            <p:ph type="title"/>
+          </p:nvPr>
+        </p:nvSpPr>
+        <p:spPr/>
+        <p:txBody>
+          <a:bodyPr/>
+          <a:lstStyle/>
+          <a:p>
+            <a:r>
+              <a:rPr lang="de-DE" dirty="0" err="1"/>
+              <a:t>Supervised</a:t>
+            </a:r>
+            <a:r>
+              <a:rPr lang="de-DE" dirty="0"/>
+              <a:t> Clustering Validation</a:t>
+            </a:r>
+          </a:p>
+        </p:txBody>
+      </p:sp>
+      <p:sp>
+        <p:nvSpPr>
+          <p:cNvPr id="3" name="Inhaltsplatzhalter 2">
+            <a:extLst>
+              <a:ext uri="{FF2B5EF4-FFF2-40B4-BE49-F238E27FC236}">
+                <a16:creationId xmlns:a16="http://schemas.microsoft.com/office/drawing/2014/main" id="{392427C8-4330-BC0E-F7FF-95DB2D9863DA}"/>
+              </a:ext>
+            </a:extLst>
+          </p:cNvPr>
+          <p:cNvSpPr>
+            <a:spLocks noGrp="1"/>
+          </p:cNvSpPr>
+          <p:nvPr>
+            <p:ph idx="1"/>
+          </p:nvPr>
+        </p:nvSpPr>
+        <p:spPr/>
+        <p:txBody>
+          <a:bodyPr>
+            <a:normAutofit fontScale="92500"/>
+          </a:bodyPr>
+          <a:lstStyle/>
+          <a:p>
+            <a:pPr marL="0" indent="0">
+              <a:buNone/>
+            </a:pPr>
+            <a:r>
+              <a:rPr lang="de-DE" dirty="0"/>
+              <a:t>…</a:t>
+            </a:r>
+          </a:p>
+          <a:p>
+            <a:r>
+              <a:rPr lang="de-DE" dirty="0" err="1"/>
+              <a:t>homogeneity</a:t>
+            </a:r>
+            <a:r>
+              <a:rPr lang="de-DE" dirty="0"/>
+              <a:t> score: A </a:t>
+            </a:r>
+            <a:r>
+              <a:rPr lang="de-DE" dirty="0" err="1"/>
+              <a:t>clustering</a:t>
+            </a:r>
+            <a:r>
+              <a:rPr lang="de-DE" dirty="0"/>
+              <a:t> </a:t>
+            </a:r>
+            <a:r>
+              <a:rPr lang="de-DE" dirty="0" err="1"/>
+              <a:t>result</a:t>
+            </a:r>
+            <a:r>
+              <a:rPr lang="de-DE" dirty="0"/>
+              <a:t> </a:t>
+            </a:r>
+            <a:r>
+              <a:rPr lang="de-DE" dirty="0" err="1"/>
+              <a:t>satisfies</a:t>
+            </a:r>
+            <a:r>
+              <a:rPr lang="de-DE" dirty="0"/>
+              <a:t> </a:t>
+            </a:r>
+            <a:r>
+              <a:rPr lang="de-DE" dirty="0" err="1"/>
+              <a:t>homogeneity</a:t>
+            </a:r>
+            <a:r>
+              <a:rPr lang="de-DE" dirty="0"/>
+              <a:t> </a:t>
+            </a:r>
+            <a:r>
+              <a:rPr lang="de-DE" dirty="0" err="1"/>
+              <a:t>if</a:t>
+            </a:r>
+            <a:r>
+              <a:rPr lang="de-DE" dirty="0"/>
+              <a:t> all </a:t>
+            </a:r>
+            <a:r>
+              <a:rPr lang="de-DE" dirty="0" err="1"/>
+              <a:t>of</a:t>
+            </a:r>
+            <a:r>
+              <a:rPr lang="de-DE" dirty="0"/>
+              <a:t> </a:t>
+            </a:r>
+            <a:r>
+              <a:rPr lang="de-DE" dirty="0" err="1"/>
+              <a:t>its</a:t>
+            </a:r>
+            <a:r>
+              <a:rPr lang="de-DE" dirty="0"/>
+              <a:t> </a:t>
+            </a:r>
+            <a:r>
+              <a:rPr lang="de-DE" dirty="0" err="1"/>
+              <a:t>clusters</a:t>
+            </a:r>
+            <a:r>
+              <a:rPr lang="de-DE" dirty="0"/>
+              <a:t> </a:t>
+            </a:r>
+            <a:r>
+              <a:rPr lang="de-DE" dirty="0" err="1"/>
+              <a:t>contain</a:t>
+            </a:r>
+            <a:r>
+              <a:rPr lang="de-DE" dirty="0"/>
+              <a:t> </a:t>
+            </a:r>
+            <a:r>
+              <a:rPr lang="de-DE" dirty="0" err="1"/>
+              <a:t>only</a:t>
+            </a:r>
+            <a:r>
+              <a:rPr lang="de-DE" dirty="0"/>
+              <a:t> </a:t>
+            </a:r>
+            <a:r>
+              <a:rPr lang="de-DE" dirty="0" err="1"/>
+              <a:t>data</a:t>
+            </a:r>
+            <a:r>
+              <a:rPr lang="de-DE" dirty="0"/>
+              <a:t> </a:t>
+            </a:r>
+            <a:r>
+              <a:rPr lang="de-DE" dirty="0" err="1"/>
+              <a:t>points</a:t>
+            </a:r>
+            <a:r>
+              <a:rPr lang="de-DE" dirty="0"/>
+              <a:t> </a:t>
+            </a:r>
+            <a:r>
+              <a:rPr lang="de-DE" dirty="0" err="1"/>
+              <a:t>which</a:t>
+            </a:r>
+            <a:r>
+              <a:rPr lang="de-DE" dirty="0"/>
+              <a:t> </a:t>
+            </a:r>
+            <a:r>
+              <a:rPr lang="de-DE" dirty="0" err="1"/>
+              <a:t>are</a:t>
+            </a:r>
+            <a:r>
+              <a:rPr lang="de-DE" dirty="0"/>
+              <a:t> </a:t>
+            </a:r>
+            <a:r>
+              <a:rPr lang="de-DE" dirty="0" err="1"/>
+              <a:t>members</a:t>
+            </a:r>
+            <a:r>
+              <a:rPr lang="de-DE" dirty="0"/>
+              <a:t> </a:t>
+            </a:r>
+            <a:r>
+              <a:rPr lang="de-DE" dirty="0" err="1"/>
+              <a:t>of</a:t>
+            </a:r>
+            <a:r>
+              <a:rPr lang="de-DE" dirty="0"/>
+              <a:t> a </a:t>
+            </a:r>
+            <a:r>
+              <a:rPr lang="de-DE" dirty="0" err="1"/>
+              <a:t>single</a:t>
+            </a:r>
+            <a:r>
+              <a:rPr lang="de-DE" dirty="0"/>
+              <a:t> </a:t>
+            </a:r>
+            <a:r>
+              <a:rPr lang="de-DE" dirty="0" err="1"/>
+              <a:t>class</a:t>
+            </a:r>
+            <a:r>
+              <a:rPr lang="de-DE" dirty="0"/>
+              <a:t>.</a:t>
+            </a:r>
+          </a:p>
+          <a:p>
+            <a:r>
+              <a:rPr lang="de-DE" dirty="0" err="1"/>
+              <a:t>completeness</a:t>
+            </a:r>
+            <a:r>
+              <a:rPr lang="de-DE" dirty="0"/>
+              <a:t> score: A </a:t>
+            </a:r>
+            <a:r>
+              <a:rPr lang="de-DE" dirty="0" err="1"/>
+              <a:t>clustering</a:t>
+            </a:r>
+            <a:r>
+              <a:rPr lang="de-DE" dirty="0"/>
+              <a:t> </a:t>
+            </a:r>
+            <a:r>
+              <a:rPr lang="de-DE" dirty="0" err="1"/>
+              <a:t>result</a:t>
+            </a:r>
+            <a:r>
+              <a:rPr lang="de-DE" dirty="0"/>
+              <a:t> </a:t>
+            </a:r>
+            <a:r>
+              <a:rPr lang="de-DE" dirty="0" err="1"/>
+              <a:t>satisfies</a:t>
+            </a:r>
+            <a:r>
+              <a:rPr lang="de-DE" dirty="0"/>
+              <a:t> </a:t>
+            </a:r>
+            <a:r>
+              <a:rPr lang="de-DE" dirty="0" err="1"/>
+              <a:t>completeness</a:t>
+            </a:r>
+            <a:r>
+              <a:rPr lang="de-DE" dirty="0"/>
+              <a:t> </a:t>
+            </a:r>
+            <a:r>
+              <a:rPr lang="de-DE" dirty="0" err="1"/>
+              <a:t>if</a:t>
+            </a:r>
+            <a:r>
+              <a:rPr lang="de-DE" dirty="0"/>
+              <a:t> all </a:t>
+            </a:r>
+            <a:r>
+              <a:rPr lang="de-DE" dirty="0" err="1"/>
+              <a:t>the</a:t>
+            </a:r>
+            <a:r>
+              <a:rPr lang="de-DE" dirty="0"/>
+              <a:t> </a:t>
+            </a:r>
+            <a:r>
+              <a:rPr lang="de-DE" dirty="0" err="1"/>
+              <a:t>data</a:t>
+            </a:r>
+            <a:r>
+              <a:rPr lang="de-DE" dirty="0"/>
+              <a:t> </a:t>
+            </a:r>
+            <a:r>
+              <a:rPr lang="de-DE" dirty="0" err="1"/>
+              <a:t>points</a:t>
+            </a:r>
+            <a:r>
+              <a:rPr lang="de-DE" dirty="0"/>
+              <a:t> </a:t>
+            </a:r>
+            <a:r>
+              <a:rPr lang="de-DE" dirty="0" err="1"/>
+              <a:t>that</a:t>
+            </a:r>
+            <a:r>
+              <a:rPr lang="de-DE" dirty="0"/>
+              <a:t> </a:t>
+            </a:r>
+            <a:r>
+              <a:rPr lang="de-DE" dirty="0" err="1"/>
+              <a:t>are</a:t>
+            </a:r>
+            <a:r>
+              <a:rPr lang="de-DE" dirty="0"/>
+              <a:t> </a:t>
+            </a:r>
+            <a:r>
+              <a:rPr lang="de-DE" dirty="0" err="1"/>
+              <a:t>members</a:t>
+            </a:r>
+            <a:r>
+              <a:rPr lang="de-DE" dirty="0"/>
+              <a:t> </a:t>
+            </a:r>
+            <a:r>
+              <a:rPr lang="de-DE" dirty="0" err="1"/>
+              <a:t>of</a:t>
+            </a:r>
+            <a:r>
+              <a:rPr lang="de-DE" dirty="0"/>
+              <a:t> a </a:t>
+            </a:r>
+            <a:r>
+              <a:rPr lang="de-DE" dirty="0" err="1"/>
+              <a:t>given</a:t>
+            </a:r>
+            <a:r>
+              <a:rPr lang="de-DE" dirty="0"/>
+              <a:t> </a:t>
+            </a:r>
+            <a:r>
+              <a:rPr lang="de-DE" dirty="0" err="1"/>
+              <a:t>class</a:t>
+            </a:r>
+            <a:r>
+              <a:rPr lang="de-DE" dirty="0"/>
+              <a:t> </a:t>
+            </a:r>
+            <a:r>
+              <a:rPr lang="de-DE" dirty="0" err="1"/>
+              <a:t>are</a:t>
+            </a:r>
+            <a:r>
+              <a:rPr lang="de-DE" dirty="0"/>
+              <a:t> </a:t>
+            </a:r>
+            <a:r>
+              <a:rPr lang="de-DE" dirty="0" err="1"/>
+              <a:t>elements</a:t>
+            </a:r>
+            <a:r>
+              <a:rPr lang="de-DE" dirty="0"/>
+              <a:t> </a:t>
+            </a:r>
+            <a:r>
+              <a:rPr lang="de-DE" dirty="0" err="1"/>
+              <a:t>of</a:t>
+            </a:r>
+            <a:r>
+              <a:rPr lang="de-DE" dirty="0"/>
+              <a:t> </a:t>
+            </a:r>
+            <a:r>
+              <a:rPr lang="de-DE" dirty="0" err="1"/>
+              <a:t>the</a:t>
+            </a:r>
+            <a:r>
+              <a:rPr lang="de-DE" dirty="0"/>
+              <a:t> same </a:t>
+            </a:r>
+            <a:r>
+              <a:rPr lang="de-DE" dirty="0" err="1"/>
+              <a:t>cluster</a:t>
+            </a:r>
+            <a:r>
+              <a:rPr lang="de-DE" dirty="0"/>
+              <a:t>.</a:t>
+            </a:r>
+          </a:p>
+          <a:p>
+            <a:r>
+              <a:rPr lang="de-DE" dirty="0"/>
+              <a:t>V-</a:t>
+            </a:r>
+            <a:r>
+              <a:rPr lang="de-DE" dirty="0" err="1"/>
+              <a:t>measure</a:t>
+            </a:r>
+            <a:r>
+              <a:rPr lang="de-DE" dirty="0"/>
+              <a:t> score: </a:t>
+            </a:r>
+            <a:r>
+              <a:rPr lang="de-DE" dirty="0" err="1"/>
+              <a:t>harmonic</a:t>
+            </a:r>
+            <a:r>
+              <a:rPr lang="de-DE" dirty="0"/>
+              <a:t> </a:t>
+            </a:r>
+            <a:r>
+              <a:rPr lang="de-DE" dirty="0" err="1"/>
+              <a:t>mean</a:t>
+            </a:r>
+            <a:r>
+              <a:rPr lang="de-DE" dirty="0"/>
+              <a:t> </a:t>
+            </a:r>
+            <a:r>
+              <a:rPr lang="de-DE" dirty="0" err="1"/>
+              <a:t>between</a:t>
+            </a:r>
+            <a:r>
+              <a:rPr lang="de-DE" dirty="0"/>
+              <a:t> </a:t>
+            </a:r>
+            <a:r>
+              <a:rPr lang="de-DE" dirty="0" err="1"/>
+              <a:t>homogeneity</a:t>
+            </a:r>
+            <a:r>
+              <a:rPr lang="de-DE" dirty="0"/>
+              <a:t> and </a:t>
+            </a:r>
+            <a:r>
+              <a:rPr lang="de-DE" dirty="0" err="1"/>
+              <a:t>completeness</a:t>
+            </a:r>
+            <a:endParaRPr lang="de-DE" dirty="0"/>
+          </a:p>
+          <a:p>
+            <a:r>
+              <a:rPr lang="de-DE" dirty="0"/>
+              <a:t>(</a:t>
+            </a:r>
+            <a:r>
+              <a:rPr lang="de-DE" dirty="0" err="1"/>
+              <a:t>adjusted</a:t>
+            </a:r>
+            <a:r>
+              <a:rPr lang="de-DE" dirty="0"/>
+              <a:t>) Rand </a:t>
+            </a:r>
+            <a:r>
+              <a:rPr lang="de-DE" dirty="0" err="1"/>
+              <a:t>index</a:t>
+            </a:r>
+            <a:r>
+              <a:rPr lang="de-DE" dirty="0"/>
+              <a:t>: …</a:t>
+            </a:r>
+          </a:p>
+          <a:p>
+            <a:r>
+              <a:rPr lang="de-DE" dirty="0"/>
+              <a:t>(</a:t>
+            </a:r>
+            <a:r>
+              <a:rPr lang="de-DE" dirty="0" err="1"/>
+              <a:t>adjusted</a:t>
+            </a:r>
+            <a:r>
+              <a:rPr lang="de-DE" dirty="0"/>
+              <a:t>) mutual </a:t>
+            </a:r>
+            <a:r>
+              <a:rPr lang="de-DE" dirty="0" err="1"/>
+              <a:t>information</a:t>
+            </a:r>
+            <a:r>
+              <a:rPr lang="de-DE" dirty="0"/>
+              <a:t> score: …</a:t>
+            </a:r>
+          </a:p>
+        </p:txBody>
+      </p:sp>
+      <p:sp>
+        <p:nvSpPr>
+          <p:cNvPr id="4" name="Foliennummernplatzhalter 3">
+            <a:extLst>
+              <a:ext uri="{FF2B5EF4-FFF2-40B4-BE49-F238E27FC236}">
+                <a16:creationId xmlns:a16="http://schemas.microsoft.com/office/drawing/2014/main" id="{701A4EA1-06DA-F940-1383-630B8622B38F}"/>
+              </a:ext>
+            </a:extLst>
+          </p:cNvPr>
+          <p:cNvSpPr>
+            <a:spLocks noGrp="1"/>
+          </p:cNvSpPr>
+          <p:nvPr>
+            <p:ph type="sldNum" sz="quarter" idx="12"/>
+          </p:nvPr>
+        </p:nvSpPr>
+        <p:spPr/>
+        <p:txBody>
+          <a:bodyPr/>
+          <a:lstStyle/>
+          <a:p>
+            <a:fld id="{08C366F5-AFAD-49CB-854A-9D9E238FCA13}" type="slidenum">
+              <a:rPr lang="en-GB" smtClean="0"/>
+              <a:t>19</a:t>
+            </a:fld>
+            <a:endParaRPr lang="en-GB"/>
+          </a:p>
+        </p:txBody>
+      </p:sp>
+    </p:spTree>
+    <p:extLst>
+      <p:ext uri="{BB962C8B-B14F-4D97-AF65-F5344CB8AC3E}">
+        <p14:creationId xmlns:p14="http://schemas.microsoft.com/office/powerpoint/2010/main" val="2860005827"/>
+      </p:ext>
+    </p:extLst>
+  </p:cSld>
+  <p:clrMapOvr>
+    <a:masterClrMapping/>
+  </p:clrMapOvr>
+</p:sld>
+</file>
+
+<file path=ppt/slides/slide2.xml><?xml version="1.0" encoding="utf-8"?>
+<p:sld xmlns:a="http://schemas.openxmlformats.org/drawingml/2006/main" xmlns:r="http://schemas.openxmlformats.org/officeDocument/2006/relationships" xmlns:p="http://schemas.openxmlformats.org/presentationml/2006/main">
+  <p:cSld>
+    <p:spTree>
+      <p:nvGrpSpPr>
+        <p:cNvPr id="1" name=""/>
+        <p:cNvGrpSpPr/>
+        <p:nvPr/>
+      </p:nvGrpSpPr>
+      <p:grpSpPr>
+        <a:xfrm>
+          <a:off x="0" y="0"/>
+          <a:ext cx="0" cy="0"/>
+          <a:chOff x="0" y="0"/>
+          <a:chExt cx="0" cy="0"/>
+        </a:xfrm>
+      </p:grpSpPr>
+      <p:sp>
+        <p:nvSpPr>
+          <p:cNvPr id="4" name="Title 3">
+            <a:extLst>
+              <a:ext uri="{FF2B5EF4-FFF2-40B4-BE49-F238E27FC236}">
+                <a16:creationId xmlns:a16="http://schemas.microsoft.com/office/drawing/2014/main" id="{080AD447-446B-E09E-6F4A-522C1DBB462E}"/>
+              </a:ext>
+            </a:extLst>
+          </p:cNvPr>
+          <p:cNvSpPr>
+            <a:spLocks noGrp="1"/>
+          </p:cNvSpPr>
+          <p:nvPr>
+            <p:ph type="title"/>
+          </p:nvPr>
+        </p:nvSpPr>
+        <p:spPr/>
+        <p:txBody>
+          <a:bodyPr/>
+          <a:lstStyle/>
+          <a:p>
+            <a:r>
+              <a:rPr lang="en-GB" dirty="0"/>
+              <a:t>Course Schedule</a:t>
+            </a:r>
+          </a:p>
+        </p:txBody>
+      </p:sp>
+      <p:sp>
+        <p:nvSpPr>
+          <p:cNvPr id="6" name="Inhaltsplatzhalter 5">
+            <a:extLst>
+              <a:ext uri="{FF2B5EF4-FFF2-40B4-BE49-F238E27FC236}">
+                <a16:creationId xmlns:a16="http://schemas.microsoft.com/office/drawing/2014/main" id="{CF502483-E45D-7D7D-D169-ACA4F8327D26}"/>
+              </a:ext>
+            </a:extLst>
+          </p:cNvPr>
+          <p:cNvSpPr>
+            <a:spLocks noGrp="1"/>
+          </p:cNvSpPr>
+          <p:nvPr>
+            <p:ph sz="half" idx="1"/>
+          </p:nvPr>
+        </p:nvSpPr>
+        <p:spPr/>
+        <p:txBody>
+          <a:bodyPr>
+            <a:normAutofit lnSpcReduction="10000"/>
+          </a:bodyPr>
+          <a:lstStyle/>
+          <a:p>
+            <a:pPr marL="514350" indent="-514350">
+              <a:buFont typeface="+mj-lt"/>
+              <a:buAutoNum type="arabicPeriod"/>
+            </a:pPr>
+            <a:r>
+              <a:rPr lang="de-DE" dirty="0" err="1"/>
+              <a:t>Exploratory</a:t>
+            </a:r>
+            <a:r>
+              <a:rPr lang="de-DE" dirty="0"/>
+              <a:t> Data Analysis</a:t>
+            </a:r>
+          </a:p>
+          <a:p>
+            <a:pPr marL="514350" indent="-514350">
+              <a:buFont typeface="+mj-lt"/>
+              <a:buAutoNum type="arabicPeriod"/>
+            </a:pPr>
+            <a:endParaRPr lang="de-DE" dirty="0"/>
+          </a:p>
+          <a:p>
+            <a:pPr marL="514350" indent="-514350">
+              <a:buFont typeface="+mj-lt"/>
+              <a:buAutoNum type="arabicPeriod"/>
+            </a:pPr>
+            <a:r>
+              <a:rPr lang="de-DE" dirty="0"/>
+              <a:t>Clustering</a:t>
+            </a:r>
+          </a:p>
+          <a:p>
+            <a:pPr marL="514350" indent="-514350">
+              <a:buFont typeface="+mj-lt"/>
+              <a:buAutoNum type="arabicPeriod"/>
+            </a:pPr>
+            <a:endParaRPr lang="de-DE" dirty="0"/>
+          </a:p>
+          <a:p>
+            <a:pPr marL="514350" indent="-514350">
+              <a:buFont typeface="+mj-lt"/>
+              <a:buAutoNum type="arabicPeriod"/>
+            </a:pPr>
+            <a:r>
+              <a:rPr lang="de-DE" dirty="0" err="1"/>
+              <a:t>Probabilistic</a:t>
+            </a:r>
+            <a:r>
+              <a:rPr lang="de-DE" dirty="0"/>
+              <a:t> Models</a:t>
+            </a:r>
+          </a:p>
+          <a:p>
+            <a:pPr marL="514350" indent="-514350">
+              <a:buFont typeface="+mj-lt"/>
+              <a:buAutoNum type="arabicPeriod"/>
+            </a:pPr>
+            <a:endParaRPr lang="de-DE" dirty="0"/>
+          </a:p>
+          <a:p>
+            <a:pPr marL="514350" indent="-514350">
+              <a:buFont typeface="+mj-lt"/>
+              <a:buAutoNum type="arabicPeriod"/>
+            </a:pPr>
+            <a:r>
+              <a:rPr lang="de-DE" dirty="0"/>
+              <a:t>Statistical </a:t>
+            </a:r>
+            <a:r>
+              <a:rPr lang="de-DE" dirty="0" err="1"/>
+              <a:t>Inference</a:t>
+            </a:r>
+            <a:endParaRPr lang="de-DE" dirty="0"/>
+          </a:p>
+          <a:p>
+            <a:pPr marL="514350" indent="-514350">
+              <a:buFont typeface="+mj-lt"/>
+              <a:buAutoNum type="arabicPeriod"/>
+            </a:pPr>
+            <a:endParaRPr lang="de-DE" dirty="0"/>
+          </a:p>
+          <a:p>
+            <a:pPr marL="514350" indent="-514350">
+              <a:buFont typeface="+mj-lt"/>
+              <a:buAutoNum type="arabicPeriod"/>
+            </a:pPr>
+            <a:r>
+              <a:rPr lang="de-DE" dirty="0" err="1"/>
+              <a:t>Machine</a:t>
+            </a:r>
+            <a:r>
+              <a:rPr lang="de-DE" dirty="0"/>
+              <a:t> Learning</a:t>
+            </a:r>
+          </a:p>
+        </p:txBody>
+      </p:sp>
+      <p:sp>
+        <p:nvSpPr>
+          <p:cNvPr id="7" name="Inhaltsplatzhalter 6">
+            <a:extLst>
+              <a:ext uri="{FF2B5EF4-FFF2-40B4-BE49-F238E27FC236}">
+                <a16:creationId xmlns:a16="http://schemas.microsoft.com/office/drawing/2014/main" id="{B671907E-FFFA-73EF-8E7D-4AB4EBDD957B}"/>
+              </a:ext>
+            </a:extLst>
+          </p:cNvPr>
+          <p:cNvSpPr>
+            <a:spLocks noGrp="1"/>
+          </p:cNvSpPr>
+          <p:nvPr>
+            <p:ph sz="half" idx="2"/>
+          </p:nvPr>
+        </p:nvSpPr>
+        <p:spPr/>
+        <p:txBody>
+          <a:bodyPr>
+            <a:normAutofit lnSpcReduction="10000"/>
+          </a:bodyPr>
+          <a:lstStyle/>
+          <a:p>
+            <a:pPr marL="514350" indent="-514350">
+              <a:buFont typeface="+mj-lt"/>
+              <a:buAutoNum type="arabicPeriod" startAt="6"/>
+            </a:pPr>
+            <a:r>
+              <a:rPr lang="de-DE" dirty="0"/>
+              <a:t>Feature Engineering</a:t>
+            </a:r>
+          </a:p>
+          <a:p>
+            <a:pPr marL="514350" indent="-514350">
+              <a:buFont typeface="+mj-lt"/>
+              <a:buAutoNum type="arabicPeriod" startAt="6"/>
+            </a:pPr>
+            <a:endParaRPr lang="de-DE" dirty="0"/>
+          </a:p>
+          <a:p>
+            <a:pPr marL="514350" indent="-514350">
+              <a:buFont typeface="+mj-lt"/>
+              <a:buAutoNum type="arabicPeriod" startAt="6"/>
+            </a:pPr>
+            <a:r>
+              <a:rPr lang="de-DE" dirty="0"/>
+              <a:t>Model Evaluation</a:t>
+            </a:r>
+          </a:p>
+          <a:p>
+            <a:pPr marL="514350" indent="-514350">
+              <a:buFont typeface="+mj-lt"/>
+              <a:buAutoNum type="arabicPeriod" startAt="6"/>
+            </a:pPr>
+            <a:endParaRPr lang="de-DE" dirty="0"/>
+          </a:p>
+          <a:p>
+            <a:pPr marL="514350" indent="-514350">
+              <a:buFont typeface="+mj-lt"/>
+              <a:buAutoNum type="arabicPeriod" startAt="6"/>
+            </a:pPr>
+            <a:r>
+              <a:rPr lang="de-DE" dirty="0"/>
+              <a:t>Deep Learning</a:t>
+            </a:r>
+          </a:p>
+          <a:p>
+            <a:pPr marL="514350" indent="-514350">
+              <a:buFont typeface="+mj-lt"/>
+              <a:buAutoNum type="arabicPeriod" startAt="6"/>
+            </a:pPr>
+            <a:endParaRPr lang="de-DE" dirty="0"/>
+          </a:p>
+          <a:p>
+            <a:pPr marL="514350" indent="-514350">
+              <a:buFont typeface="+mj-lt"/>
+              <a:buAutoNum type="arabicPeriod" startAt="6"/>
+            </a:pPr>
+            <a:r>
+              <a:rPr lang="de-DE" dirty="0"/>
+              <a:t>Time Series</a:t>
+            </a:r>
+          </a:p>
+          <a:p>
+            <a:pPr marL="514350" indent="-514350">
+              <a:buFont typeface="+mj-lt"/>
+              <a:buAutoNum type="arabicPeriod" startAt="6"/>
+            </a:pPr>
+            <a:endParaRPr lang="de-DE" dirty="0"/>
+          </a:p>
+          <a:p>
+            <a:pPr marL="514350" indent="-514350">
+              <a:buFont typeface="+mj-lt"/>
+              <a:buAutoNum type="arabicPeriod" startAt="6"/>
+            </a:pPr>
+            <a:r>
+              <a:rPr lang="de-DE" dirty="0" err="1"/>
+              <a:t>Causality</a:t>
+            </a:r>
+            <a:endParaRPr lang="de-DE" dirty="0"/>
+          </a:p>
+        </p:txBody>
+      </p:sp>
+      <p:sp>
+        <p:nvSpPr>
+          <p:cNvPr id="3" name="Slide Number Placeholder 2">
+            <a:extLst>
+              <a:ext uri="{FF2B5EF4-FFF2-40B4-BE49-F238E27FC236}">
+                <a16:creationId xmlns:a16="http://schemas.microsoft.com/office/drawing/2014/main" id="{A0664D44-83AC-6A7A-17E0-C1AE2ED18FF5}"/>
+              </a:ext>
+            </a:extLst>
+          </p:cNvPr>
+          <p:cNvSpPr>
+            <a:spLocks noGrp="1"/>
+          </p:cNvSpPr>
+          <p:nvPr>
+            <p:ph type="sldNum" sz="quarter" idx="12"/>
+          </p:nvPr>
+        </p:nvSpPr>
+        <p:spPr/>
+        <p:txBody>
+          <a:bodyPr/>
+          <a:lstStyle/>
+          <a:p>
+            <a:fld id="{08C366F5-AFAD-49CB-854A-9D9E238FCA13}" type="slidenum">
+              <a:rPr lang="en-GB" smtClean="0"/>
+              <a:t>2</a:t>
+            </a:fld>
+            <a:endParaRPr lang="en-GB" dirty="0"/>
+          </a:p>
+        </p:txBody>
+      </p:sp>
+    </p:spTree>
+    <p:extLst>
+      <p:ext uri="{BB962C8B-B14F-4D97-AF65-F5344CB8AC3E}">
+        <p14:creationId xmlns:p14="http://schemas.microsoft.com/office/powerpoint/2010/main" val="310336692"/>
+      </p:ext>
+    </p:extLst>
+  </p:cSld>
+  <p:clrMapOvr>
+    <a:masterClrMapping/>
+  </p:clrMapOvr>
+</p:sld>
+</file>
+
+<file path=ppt/slides/slide20.xml><?xml version="1.0" encoding="utf-8"?>
+<p:sld xmlns:a="http://schemas.openxmlformats.org/drawingml/2006/main" xmlns:r="http://schemas.openxmlformats.org/officeDocument/2006/relationships" xmlns:p="http://schemas.openxmlformats.org/presentationml/2006/main">
+  <p:cSld>
+    <p:spTree>
+      <p:nvGrpSpPr>
+        <p:cNvPr id="1" name=""/>
+        <p:cNvGrpSpPr/>
+        <p:nvPr/>
+      </p:nvGrpSpPr>
+      <p:grpSpPr>
+        <a:xfrm>
+          <a:off x="0" y="0"/>
+          <a:ext cx="0" cy="0"/>
+          <a:chOff x="0" y="0"/>
+          <a:chExt cx="0" cy="0"/>
+        </a:xfrm>
+      </p:grpSpPr>
+      <p:sp>
+        <p:nvSpPr>
+          <p:cNvPr id="2" name="Titel 1">
+            <a:extLst>
+              <a:ext uri="{FF2B5EF4-FFF2-40B4-BE49-F238E27FC236}">
+                <a16:creationId xmlns:a16="http://schemas.microsoft.com/office/drawing/2014/main" id="{AE45E519-E948-8501-ACAD-BDF00444DFDC}"/>
+              </a:ext>
+            </a:extLst>
+          </p:cNvPr>
+          <p:cNvSpPr>
+            <a:spLocks noGrp="1"/>
+          </p:cNvSpPr>
+          <p:nvPr>
+            <p:ph type="title"/>
+          </p:nvPr>
+        </p:nvSpPr>
+        <p:spPr/>
+        <p:txBody>
+          <a:bodyPr/>
+          <a:lstStyle/>
+          <a:p>
+            <a:r>
+              <a:rPr lang="de-DE" dirty="0"/>
+              <a:t>Mini Batch </a:t>
+            </a:r>
+            <a:r>
+              <a:rPr lang="de-DE" dirty="0" err="1"/>
+              <a:t>k-Means</a:t>
+            </a:r>
+            <a:endParaRPr lang="de-DE" dirty="0"/>
+          </a:p>
+        </p:txBody>
+      </p:sp>
+      <p:sp>
+        <p:nvSpPr>
+          <p:cNvPr id="4" name="Inhaltsplatzhalter 3">
+            <a:extLst>
+              <a:ext uri="{FF2B5EF4-FFF2-40B4-BE49-F238E27FC236}">
+                <a16:creationId xmlns:a16="http://schemas.microsoft.com/office/drawing/2014/main" id="{DAA8C059-BF98-DA76-D11E-B2885769186E}"/>
+              </a:ext>
+            </a:extLst>
+          </p:cNvPr>
+          <p:cNvSpPr>
+            <a:spLocks noGrp="1"/>
+          </p:cNvSpPr>
+          <p:nvPr>
+            <p:ph idx="1"/>
+          </p:nvPr>
+        </p:nvSpPr>
+        <p:spPr/>
+        <p:txBody>
+          <a:bodyPr/>
+          <a:lstStyle/>
+          <a:p>
+            <a:endParaRPr lang="de-DE"/>
+          </a:p>
+        </p:txBody>
+      </p:sp>
+      <p:sp>
+        <p:nvSpPr>
+          <p:cNvPr id="3" name="Foliennummernplatzhalter 2">
+            <a:extLst>
+              <a:ext uri="{FF2B5EF4-FFF2-40B4-BE49-F238E27FC236}">
+                <a16:creationId xmlns:a16="http://schemas.microsoft.com/office/drawing/2014/main" id="{2B02C868-452A-3E9E-3E72-BA889BC8609C}"/>
+              </a:ext>
+            </a:extLst>
+          </p:cNvPr>
+          <p:cNvSpPr>
+            <a:spLocks noGrp="1"/>
+          </p:cNvSpPr>
+          <p:nvPr>
+            <p:ph type="sldNum" sz="quarter" idx="12"/>
+          </p:nvPr>
+        </p:nvSpPr>
+        <p:spPr/>
+        <p:txBody>
+          <a:bodyPr/>
+          <a:lstStyle/>
+          <a:p>
+            <a:fld id="{08C366F5-AFAD-49CB-854A-9D9E238FCA13}" type="slidenum">
+              <a:rPr lang="en-GB" smtClean="0"/>
+              <a:t>20</a:t>
             </a:fld>
             <a:endParaRPr lang="en-GB"/>
           </a:p>
@@ -7186,617 +9569,6 @@
 </p:sld>
 </file>
 
-<file path=ppt/slides/slide19.xml><?xml version="1.0" encoding="utf-8"?>
-<p:sld xmlns:a="http://schemas.openxmlformats.org/drawingml/2006/main" xmlns:r="http://schemas.openxmlformats.org/officeDocument/2006/relationships" xmlns:p="http://schemas.openxmlformats.org/presentationml/2006/main">
-  <p:cSld>
-    <p:spTree>
-      <p:nvGrpSpPr>
-        <p:cNvPr id="1" name=""/>
-        <p:cNvGrpSpPr/>
-        <p:nvPr/>
-      </p:nvGrpSpPr>
-      <p:grpSpPr>
-        <a:xfrm>
-          <a:off x="0" y="0"/>
-          <a:ext cx="0" cy="0"/>
-          <a:chOff x="0" y="0"/>
-          <a:chExt cx="0" cy="0"/>
-        </a:xfrm>
-      </p:grpSpPr>
-      <p:sp>
-        <p:nvSpPr>
-          <p:cNvPr id="2" name="Titel 1">
-            <a:extLst>
-              <a:ext uri="{FF2B5EF4-FFF2-40B4-BE49-F238E27FC236}">
-                <a16:creationId xmlns:a16="http://schemas.microsoft.com/office/drawing/2014/main" id="{DFE85EF2-749A-FE44-0A02-FD2D92497601}"/>
-              </a:ext>
-            </a:extLst>
-          </p:cNvPr>
-          <p:cNvSpPr>
-            <a:spLocks noGrp="1"/>
-          </p:cNvSpPr>
-          <p:nvPr>
-            <p:ph type="title"/>
-          </p:nvPr>
-        </p:nvSpPr>
-        <p:spPr/>
-        <p:txBody>
-          <a:bodyPr/>
-          <a:lstStyle/>
-          <a:p>
-            <a:r>
-              <a:rPr lang="de-DE" dirty="0" err="1"/>
-              <a:t>Gaussian</a:t>
-            </a:r>
-            <a:r>
-              <a:rPr lang="de-DE" dirty="0"/>
-              <a:t> </a:t>
-            </a:r>
-            <a:r>
-              <a:rPr lang="de-DE" dirty="0" err="1"/>
-              <a:t>Mixture</a:t>
-            </a:r>
-            <a:r>
-              <a:rPr lang="de-DE" dirty="0"/>
-              <a:t> Models</a:t>
-            </a:r>
-          </a:p>
-        </p:txBody>
-      </p:sp>
-      <p:sp>
-        <p:nvSpPr>
-          <p:cNvPr id="4" name="Inhaltsplatzhalter 3">
-            <a:extLst>
-              <a:ext uri="{FF2B5EF4-FFF2-40B4-BE49-F238E27FC236}">
-                <a16:creationId xmlns:a16="http://schemas.microsoft.com/office/drawing/2014/main" id="{0A2F8357-AF4F-871F-2CBC-4B5FD73DABB1}"/>
-              </a:ext>
-            </a:extLst>
-          </p:cNvPr>
-          <p:cNvSpPr>
-            <a:spLocks noGrp="1"/>
-          </p:cNvSpPr>
-          <p:nvPr>
-            <p:ph idx="1"/>
-          </p:nvPr>
-        </p:nvSpPr>
-        <p:spPr/>
-        <p:txBody>
-          <a:bodyPr/>
-          <a:lstStyle/>
-          <a:p>
-            <a:pPr marL="0" indent="0">
-              <a:buNone/>
-            </a:pPr>
-            <a:r>
-              <a:rPr lang="de-DE" dirty="0" err="1"/>
-              <a:t>k-Means</a:t>
-            </a:r>
-            <a:r>
-              <a:rPr lang="de-DE" dirty="0"/>
-              <a:t>: </a:t>
-            </a:r>
-            <a:r>
-              <a:rPr lang="de-DE" dirty="0" err="1"/>
-              <a:t>special</a:t>
-            </a:r>
-            <a:r>
-              <a:rPr lang="de-DE" dirty="0"/>
-              <a:t> </a:t>
-            </a:r>
-            <a:r>
-              <a:rPr lang="de-DE" dirty="0" err="1"/>
-              <a:t>case</a:t>
-            </a:r>
-            <a:r>
-              <a:rPr lang="de-DE" dirty="0"/>
-              <a:t> </a:t>
-            </a:r>
-            <a:r>
-              <a:rPr lang="de-DE" dirty="0" err="1"/>
-              <a:t>of</a:t>
-            </a:r>
-            <a:r>
-              <a:rPr lang="de-DE" dirty="0"/>
-              <a:t> </a:t>
-            </a:r>
-            <a:r>
-              <a:rPr lang="de-DE" dirty="0" err="1"/>
-              <a:t>Gaussian</a:t>
-            </a:r>
-            <a:r>
-              <a:rPr lang="de-DE" dirty="0"/>
-              <a:t> </a:t>
-            </a:r>
-            <a:r>
-              <a:rPr lang="de-DE" dirty="0" err="1"/>
-              <a:t>mixture</a:t>
-            </a:r>
-            <a:r>
-              <a:rPr lang="de-DE" dirty="0"/>
-              <a:t> </a:t>
-            </a:r>
-            <a:r>
-              <a:rPr lang="de-DE" dirty="0" err="1"/>
-              <a:t>model</a:t>
-            </a:r>
-            <a:r>
-              <a:rPr lang="de-DE" dirty="0"/>
-              <a:t> </a:t>
-            </a:r>
-            <a:r>
-              <a:rPr lang="de-DE" dirty="0" err="1"/>
-              <a:t>with</a:t>
-            </a:r>
-            <a:r>
-              <a:rPr lang="de-DE" dirty="0"/>
-              <a:t> </a:t>
-            </a:r>
-            <a:r>
-              <a:rPr lang="de-DE" dirty="0" err="1"/>
-              <a:t>equal</a:t>
-            </a:r>
-            <a:r>
-              <a:rPr lang="de-DE" dirty="0"/>
-              <a:t> </a:t>
-            </a:r>
-            <a:r>
-              <a:rPr lang="de-DE" dirty="0" err="1"/>
-              <a:t>covariance</a:t>
-            </a:r>
-            <a:r>
-              <a:rPr lang="de-DE" dirty="0"/>
-              <a:t> per </a:t>
-            </a:r>
-            <a:r>
-              <a:rPr lang="de-DE" dirty="0" err="1"/>
-              <a:t>component</a:t>
-            </a:r>
-            <a:endParaRPr lang="de-DE" dirty="0"/>
-          </a:p>
-        </p:txBody>
-      </p:sp>
-      <p:sp>
-        <p:nvSpPr>
-          <p:cNvPr id="3" name="Foliennummernplatzhalter 2">
-            <a:extLst>
-              <a:ext uri="{FF2B5EF4-FFF2-40B4-BE49-F238E27FC236}">
-                <a16:creationId xmlns:a16="http://schemas.microsoft.com/office/drawing/2014/main" id="{0B40836D-FBB2-F6AE-DB5B-B3E743214157}"/>
-              </a:ext>
-            </a:extLst>
-          </p:cNvPr>
-          <p:cNvSpPr>
-            <a:spLocks noGrp="1"/>
-          </p:cNvSpPr>
-          <p:nvPr>
-            <p:ph type="sldNum" sz="quarter" idx="12"/>
-          </p:nvPr>
-        </p:nvSpPr>
-        <p:spPr/>
-        <p:txBody>
-          <a:bodyPr/>
-          <a:lstStyle/>
-          <a:p>
-            <a:fld id="{08C366F5-AFAD-49CB-854A-9D9E238FCA13}" type="slidenum">
-              <a:rPr lang="en-GB" smtClean="0"/>
-              <a:t>19</a:t>
-            </a:fld>
-            <a:endParaRPr lang="en-GB"/>
-          </a:p>
-        </p:txBody>
-      </p:sp>
-    </p:spTree>
-    <p:extLst>
-      <p:ext uri="{BB962C8B-B14F-4D97-AF65-F5344CB8AC3E}">
-        <p14:creationId xmlns:p14="http://schemas.microsoft.com/office/powerpoint/2010/main" val="3563920324"/>
-      </p:ext>
-    </p:extLst>
-  </p:cSld>
-  <p:clrMapOvr>
-    <a:masterClrMapping/>
-  </p:clrMapOvr>
-</p:sld>
-</file>
-
-<file path=ppt/slides/slide2.xml><?xml version="1.0" encoding="utf-8"?>
-<p:sld xmlns:a="http://schemas.openxmlformats.org/drawingml/2006/main" xmlns:r="http://schemas.openxmlformats.org/officeDocument/2006/relationships" xmlns:p="http://schemas.openxmlformats.org/presentationml/2006/main">
-  <p:cSld>
-    <p:spTree>
-      <p:nvGrpSpPr>
-        <p:cNvPr id="1" name=""/>
-        <p:cNvGrpSpPr/>
-        <p:nvPr/>
-      </p:nvGrpSpPr>
-      <p:grpSpPr>
-        <a:xfrm>
-          <a:off x="0" y="0"/>
-          <a:ext cx="0" cy="0"/>
-          <a:chOff x="0" y="0"/>
-          <a:chExt cx="0" cy="0"/>
-        </a:xfrm>
-      </p:grpSpPr>
-      <p:sp>
-        <p:nvSpPr>
-          <p:cNvPr id="4" name="Title 3">
-            <a:extLst>
-              <a:ext uri="{FF2B5EF4-FFF2-40B4-BE49-F238E27FC236}">
-                <a16:creationId xmlns:a16="http://schemas.microsoft.com/office/drawing/2014/main" id="{080AD447-446B-E09E-6F4A-522C1DBB462E}"/>
-              </a:ext>
-            </a:extLst>
-          </p:cNvPr>
-          <p:cNvSpPr>
-            <a:spLocks noGrp="1"/>
-          </p:cNvSpPr>
-          <p:nvPr>
-            <p:ph type="title"/>
-          </p:nvPr>
-        </p:nvSpPr>
-        <p:spPr/>
-        <p:txBody>
-          <a:bodyPr/>
-          <a:lstStyle/>
-          <a:p>
-            <a:r>
-              <a:rPr lang="en-GB" dirty="0"/>
-              <a:t>Course Schedule</a:t>
-            </a:r>
-          </a:p>
-        </p:txBody>
-      </p:sp>
-      <p:sp>
-        <p:nvSpPr>
-          <p:cNvPr id="6" name="Inhaltsplatzhalter 5">
-            <a:extLst>
-              <a:ext uri="{FF2B5EF4-FFF2-40B4-BE49-F238E27FC236}">
-                <a16:creationId xmlns:a16="http://schemas.microsoft.com/office/drawing/2014/main" id="{CF502483-E45D-7D7D-D169-ACA4F8327D26}"/>
-              </a:ext>
-            </a:extLst>
-          </p:cNvPr>
-          <p:cNvSpPr>
-            <a:spLocks noGrp="1"/>
-          </p:cNvSpPr>
-          <p:nvPr>
-            <p:ph sz="half" idx="1"/>
-          </p:nvPr>
-        </p:nvSpPr>
-        <p:spPr/>
-        <p:txBody>
-          <a:bodyPr>
-            <a:normAutofit lnSpcReduction="10000"/>
-          </a:bodyPr>
-          <a:lstStyle/>
-          <a:p>
-            <a:pPr marL="514350" indent="-514350">
-              <a:buFont typeface="+mj-lt"/>
-              <a:buAutoNum type="arabicPeriod"/>
-            </a:pPr>
-            <a:r>
-              <a:rPr lang="de-DE" dirty="0" err="1"/>
-              <a:t>Exploratory</a:t>
-            </a:r>
-            <a:r>
-              <a:rPr lang="de-DE" dirty="0"/>
-              <a:t> Data Analysis</a:t>
-            </a:r>
-          </a:p>
-          <a:p>
-            <a:pPr marL="514350" indent="-514350">
-              <a:buFont typeface="+mj-lt"/>
-              <a:buAutoNum type="arabicPeriod"/>
-            </a:pPr>
-            <a:endParaRPr lang="de-DE" dirty="0"/>
-          </a:p>
-          <a:p>
-            <a:pPr marL="514350" indent="-514350">
-              <a:buFont typeface="+mj-lt"/>
-              <a:buAutoNum type="arabicPeriod"/>
-            </a:pPr>
-            <a:r>
-              <a:rPr lang="de-DE" dirty="0"/>
-              <a:t>Clustering</a:t>
-            </a:r>
-          </a:p>
-          <a:p>
-            <a:pPr marL="514350" indent="-514350">
-              <a:buFont typeface="+mj-lt"/>
-              <a:buAutoNum type="arabicPeriod"/>
-            </a:pPr>
-            <a:endParaRPr lang="de-DE" dirty="0"/>
-          </a:p>
-          <a:p>
-            <a:pPr marL="514350" indent="-514350">
-              <a:buFont typeface="+mj-lt"/>
-              <a:buAutoNum type="arabicPeriod"/>
-            </a:pPr>
-            <a:r>
-              <a:rPr lang="de-DE" dirty="0" err="1"/>
-              <a:t>Probabilistic</a:t>
-            </a:r>
-            <a:r>
-              <a:rPr lang="de-DE" dirty="0"/>
-              <a:t> Models</a:t>
-            </a:r>
-          </a:p>
-          <a:p>
-            <a:pPr marL="514350" indent="-514350">
-              <a:buFont typeface="+mj-lt"/>
-              <a:buAutoNum type="arabicPeriod"/>
-            </a:pPr>
-            <a:endParaRPr lang="de-DE" dirty="0"/>
-          </a:p>
-          <a:p>
-            <a:pPr marL="514350" indent="-514350">
-              <a:buFont typeface="+mj-lt"/>
-              <a:buAutoNum type="arabicPeriod"/>
-            </a:pPr>
-            <a:r>
-              <a:rPr lang="de-DE" dirty="0"/>
-              <a:t>Statistical </a:t>
-            </a:r>
-            <a:r>
-              <a:rPr lang="de-DE" dirty="0" err="1"/>
-              <a:t>Inference</a:t>
-            </a:r>
-            <a:endParaRPr lang="de-DE" dirty="0"/>
-          </a:p>
-          <a:p>
-            <a:pPr marL="514350" indent="-514350">
-              <a:buFont typeface="+mj-lt"/>
-              <a:buAutoNum type="arabicPeriod"/>
-            </a:pPr>
-            <a:endParaRPr lang="de-DE" dirty="0"/>
-          </a:p>
-          <a:p>
-            <a:pPr marL="514350" indent="-514350">
-              <a:buFont typeface="+mj-lt"/>
-              <a:buAutoNum type="arabicPeriod"/>
-            </a:pPr>
-            <a:r>
-              <a:rPr lang="de-DE" dirty="0" err="1"/>
-              <a:t>Machine</a:t>
-            </a:r>
-            <a:r>
-              <a:rPr lang="de-DE" dirty="0"/>
-              <a:t> Learning</a:t>
-            </a:r>
-          </a:p>
-        </p:txBody>
-      </p:sp>
-      <p:sp>
-        <p:nvSpPr>
-          <p:cNvPr id="7" name="Inhaltsplatzhalter 6">
-            <a:extLst>
-              <a:ext uri="{FF2B5EF4-FFF2-40B4-BE49-F238E27FC236}">
-                <a16:creationId xmlns:a16="http://schemas.microsoft.com/office/drawing/2014/main" id="{B671907E-FFFA-73EF-8E7D-4AB4EBDD957B}"/>
-              </a:ext>
-            </a:extLst>
-          </p:cNvPr>
-          <p:cNvSpPr>
-            <a:spLocks noGrp="1"/>
-          </p:cNvSpPr>
-          <p:nvPr>
-            <p:ph sz="half" idx="2"/>
-          </p:nvPr>
-        </p:nvSpPr>
-        <p:spPr/>
-        <p:txBody>
-          <a:bodyPr>
-            <a:normAutofit lnSpcReduction="10000"/>
-          </a:bodyPr>
-          <a:lstStyle/>
-          <a:p>
-            <a:pPr marL="514350" indent="-514350">
-              <a:buFont typeface="+mj-lt"/>
-              <a:buAutoNum type="arabicPeriod" startAt="6"/>
-            </a:pPr>
-            <a:r>
-              <a:rPr lang="de-DE" dirty="0"/>
-              <a:t>Feature Engineering</a:t>
-            </a:r>
-          </a:p>
-          <a:p>
-            <a:pPr marL="514350" indent="-514350">
-              <a:buFont typeface="+mj-lt"/>
-              <a:buAutoNum type="arabicPeriod" startAt="6"/>
-            </a:pPr>
-            <a:endParaRPr lang="de-DE" dirty="0"/>
-          </a:p>
-          <a:p>
-            <a:pPr marL="514350" indent="-514350">
-              <a:buFont typeface="+mj-lt"/>
-              <a:buAutoNum type="arabicPeriod" startAt="6"/>
-            </a:pPr>
-            <a:r>
-              <a:rPr lang="de-DE" dirty="0"/>
-              <a:t>Model Evaluation</a:t>
-            </a:r>
-          </a:p>
-          <a:p>
-            <a:pPr marL="514350" indent="-514350">
-              <a:buFont typeface="+mj-lt"/>
-              <a:buAutoNum type="arabicPeriod" startAt="6"/>
-            </a:pPr>
-            <a:endParaRPr lang="de-DE" dirty="0"/>
-          </a:p>
-          <a:p>
-            <a:pPr marL="514350" indent="-514350">
-              <a:buFont typeface="+mj-lt"/>
-              <a:buAutoNum type="arabicPeriod" startAt="6"/>
-            </a:pPr>
-            <a:r>
-              <a:rPr lang="de-DE" dirty="0"/>
-              <a:t>Deep Learning</a:t>
-            </a:r>
-          </a:p>
-          <a:p>
-            <a:pPr marL="514350" indent="-514350">
-              <a:buFont typeface="+mj-lt"/>
-              <a:buAutoNum type="arabicPeriod" startAt="6"/>
-            </a:pPr>
-            <a:endParaRPr lang="de-DE" dirty="0"/>
-          </a:p>
-          <a:p>
-            <a:pPr marL="514350" indent="-514350">
-              <a:buFont typeface="+mj-lt"/>
-              <a:buAutoNum type="arabicPeriod" startAt="6"/>
-            </a:pPr>
-            <a:r>
-              <a:rPr lang="de-DE" dirty="0"/>
-              <a:t>Time Series</a:t>
-            </a:r>
-          </a:p>
-          <a:p>
-            <a:pPr marL="514350" indent="-514350">
-              <a:buFont typeface="+mj-lt"/>
-              <a:buAutoNum type="arabicPeriod" startAt="6"/>
-            </a:pPr>
-            <a:endParaRPr lang="de-DE" dirty="0"/>
-          </a:p>
-          <a:p>
-            <a:pPr marL="514350" indent="-514350">
-              <a:buFont typeface="+mj-lt"/>
-              <a:buAutoNum type="arabicPeriod" startAt="6"/>
-            </a:pPr>
-            <a:r>
-              <a:rPr lang="de-DE" dirty="0" err="1"/>
-              <a:t>Causality</a:t>
-            </a:r>
-            <a:endParaRPr lang="de-DE" dirty="0"/>
-          </a:p>
-        </p:txBody>
-      </p:sp>
-      <p:sp>
-        <p:nvSpPr>
-          <p:cNvPr id="3" name="Slide Number Placeholder 2">
-            <a:extLst>
-              <a:ext uri="{FF2B5EF4-FFF2-40B4-BE49-F238E27FC236}">
-                <a16:creationId xmlns:a16="http://schemas.microsoft.com/office/drawing/2014/main" id="{A0664D44-83AC-6A7A-17E0-C1AE2ED18FF5}"/>
-              </a:ext>
-            </a:extLst>
-          </p:cNvPr>
-          <p:cNvSpPr>
-            <a:spLocks noGrp="1"/>
-          </p:cNvSpPr>
-          <p:nvPr>
-            <p:ph type="sldNum" sz="quarter" idx="12"/>
-          </p:nvPr>
-        </p:nvSpPr>
-        <p:spPr/>
-        <p:txBody>
-          <a:bodyPr/>
-          <a:lstStyle/>
-          <a:p>
-            <a:fld id="{08C366F5-AFAD-49CB-854A-9D9E238FCA13}" type="slidenum">
-              <a:rPr lang="en-GB" smtClean="0"/>
-              <a:t>2</a:t>
-            </a:fld>
-            <a:endParaRPr lang="en-GB" dirty="0"/>
-          </a:p>
-        </p:txBody>
-      </p:sp>
-    </p:spTree>
-    <p:extLst>
-      <p:ext uri="{BB962C8B-B14F-4D97-AF65-F5344CB8AC3E}">
-        <p14:creationId xmlns:p14="http://schemas.microsoft.com/office/powerpoint/2010/main" val="310336692"/>
-      </p:ext>
-    </p:extLst>
-  </p:cSld>
-  <p:clrMapOvr>
-    <a:masterClrMapping/>
-  </p:clrMapOvr>
-</p:sld>
-</file>
-
-<file path=ppt/slides/slide20.xml><?xml version="1.0" encoding="utf-8"?>
-<p:sld xmlns:a="http://schemas.openxmlformats.org/drawingml/2006/main" xmlns:r="http://schemas.openxmlformats.org/officeDocument/2006/relationships" xmlns:p="http://schemas.openxmlformats.org/presentationml/2006/main">
-  <p:cSld>
-    <p:spTree>
-      <p:nvGrpSpPr>
-        <p:cNvPr id="1" name=""/>
-        <p:cNvGrpSpPr/>
-        <p:nvPr/>
-      </p:nvGrpSpPr>
-      <p:grpSpPr>
-        <a:xfrm>
-          <a:off x="0" y="0"/>
-          <a:ext cx="0" cy="0"/>
-          <a:chOff x="0" y="0"/>
-          <a:chExt cx="0" cy="0"/>
-        </a:xfrm>
-      </p:grpSpPr>
-      <p:sp>
-        <p:nvSpPr>
-          <p:cNvPr id="2" name="Titel 1">
-            <a:extLst>
-              <a:ext uri="{FF2B5EF4-FFF2-40B4-BE49-F238E27FC236}">
-                <a16:creationId xmlns:a16="http://schemas.microsoft.com/office/drawing/2014/main" id="{712D266D-155F-F226-2B1D-358BA749E8CC}"/>
-              </a:ext>
-            </a:extLst>
-          </p:cNvPr>
-          <p:cNvSpPr>
-            <a:spLocks noGrp="1"/>
-          </p:cNvSpPr>
-          <p:nvPr>
-            <p:ph type="title"/>
-          </p:nvPr>
-        </p:nvSpPr>
-        <p:spPr/>
-        <p:txBody>
-          <a:bodyPr/>
-          <a:lstStyle/>
-          <a:p>
-            <a:r>
-              <a:rPr lang="de-DE" dirty="0" err="1"/>
-              <a:t>Hierarchical</a:t>
-            </a:r>
-            <a:r>
-              <a:rPr lang="de-DE" dirty="0"/>
-              <a:t> Clustering: Motivation</a:t>
-            </a:r>
-          </a:p>
-        </p:txBody>
-      </p:sp>
-      <p:sp>
-        <p:nvSpPr>
-          <p:cNvPr id="3" name="Foliennummernplatzhalter 2">
-            <a:extLst>
-              <a:ext uri="{FF2B5EF4-FFF2-40B4-BE49-F238E27FC236}">
-                <a16:creationId xmlns:a16="http://schemas.microsoft.com/office/drawing/2014/main" id="{0837E5E9-930A-77A7-EDB3-BE3C126787F0}"/>
-              </a:ext>
-            </a:extLst>
-          </p:cNvPr>
-          <p:cNvSpPr>
-            <a:spLocks noGrp="1"/>
-          </p:cNvSpPr>
-          <p:nvPr>
-            <p:ph type="sldNum" sz="quarter" idx="12"/>
-          </p:nvPr>
-        </p:nvSpPr>
-        <p:spPr/>
-        <p:txBody>
-          <a:bodyPr/>
-          <a:lstStyle/>
-          <a:p>
-            <a:fld id="{08C366F5-AFAD-49CB-854A-9D9E238FCA13}" type="slidenum">
-              <a:rPr lang="en-GB" smtClean="0"/>
-              <a:t>20</a:t>
-            </a:fld>
-            <a:endParaRPr lang="en-GB"/>
-          </a:p>
-        </p:txBody>
-      </p:sp>
-    </p:spTree>
-    <p:extLst>
-      <p:ext uri="{BB962C8B-B14F-4D97-AF65-F5344CB8AC3E}">
-        <p14:creationId xmlns:p14="http://schemas.microsoft.com/office/powerpoint/2010/main" val="3112906239"/>
-      </p:ext>
-    </p:extLst>
-  </p:cSld>
-  <p:clrMapOvr>
-    <a:masterClrMapping/>
-  </p:clrMapOvr>
-</p:sld>
-</file>
-
 <file path=ppt/slides/slide21.xml><?xml version="1.0" encoding="utf-8"?>
 <p:sld xmlns:a="http://schemas.openxmlformats.org/drawingml/2006/main" xmlns:r="http://schemas.openxmlformats.org/officeDocument/2006/relationships" xmlns:p="http://schemas.openxmlformats.org/presentationml/2006/main">
   <p:cSld>
@@ -7819,7 +9591,7 @@
           <p:cNvPr id="2" name="Titel 1">
             <a:extLst>
               <a:ext uri="{FF2B5EF4-FFF2-40B4-BE49-F238E27FC236}">
-                <a16:creationId xmlns:a16="http://schemas.microsoft.com/office/drawing/2014/main" id="{4DB71406-467A-A03D-EBA2-95505D3C5AF2}"/>
+                <a16:creationId xmlns:a16="http://schemas.microsoft.com/office/drawing/2014/main" id="{DFE85EF2-749A-FE44-0A02-FD2D92497601}"/>
               </a:ext>
             </a:extLst>
           </p:cNvPr>
@@ -7837,15 +9609,130 @@
           <a:p>
             <a:r>
               <a:rPr lang="de-DE" dirty="0" err="1"/>
-              <a:t>Linkage</a:t>
-            </a:r>
-            <a:r>
-              <a:rPr lang="de-DE" dirty="0"/>
-              <a:t> </a:t>
-            </a:r>
-            <a:r>
-              <a:rPr lang="de-DE" dirty="0" err="1"/>
-              <a:t>Criteria</a:t>
+              <a:t>Gaussian</a:t>
+            </a:r>
+            <a:r>
+              <a:rPr lang="de-DE" dirty="0"/>
+              <a:t> </a:t>
+            </a:r>
+            <a:r>
+              <a:rPr lang="de-DE" dirty="0" err="1"/>
+              <a:t>Mixture</a:t>
+            </a:r>
+            <a:r>
+              <a:rPr lang="de-DE" dirty="0"/>
+              <a:t> Models</a:t>
+            </a:r>
+          </a:p>
+        </p:txBody>
+      </p:sp>
+      <p:sp>
+        <p:nvSpPr>
+          <p:cNvPr id="4" name="Inhaltsplatzhalter 3">
+            <a:extLst>
+              <a:ext uri="{FF2B5EF4-FFF2-40B4-BE49-F238E27FC236}">
+                <a16:creationId xmlns:a16="http://schemas.microsoft.com/office/drawing/2014/main" id="{0A2F8357-AF4F-871F-2CBC-4B5FD73DABB1}"/>
+              </a:ext>
+            </a:extLst>
+          </p:cNvPr>
+          <p:cNvSpPr>
+            <a:spLocks noGrp="1"/>
+          </p:cNvSpPr>
+          <p:nvPr>
+            <p:ph idx="1"/>
+          </p:nvPr>
+        </p:nvSpPr>
+        <p:spPr/>
+        <p:txBody>
+          <a:bodyPr/>
+          <a:lstStyle/>
+          <a:p>
+            <a:pPr marL="0" indent="0">
+              <a:buNone/>
+            </a:pPr>
+            <a:r>
+              <a:rPr lang="de-DE" dirty="0" err="1"/>
+              <a:t>k-Means</a:t>
+            </a:r>
+            <a:r>
+              <a:rPr lang="de-DE" dirty="0"/>
+              <a:t>: </a:t>
+            </a:r>
+            <a:r>
+              <a:rPr lang="de-DE" dirty="0" err="1"/>
+              <a:t>special</a:t>
+            </a:r>
+            <a:r>
+              <a:rPr lang="de-DE" dirty="0"/>
+              <a:t> </a:t>
+            </a:r>
+            <a:r>
+              <a:rPr lang="de-DE" dirty="0" err="1"/>
+              <a:t>case</a:t>
+            </a:r>
+            <a:r>
+              <a:rPr lang="de-DE" dirty="0"/>
+              <a:t> </a:t>
+            </a:r>
+            <a:r>
+              <a:rPr lang="de-DE" dirty="0" err="1"/>
+              <a:t>of</a:t>
+            </a:r>
+            <a:r>
+              <a:rPr lang="de-DE" dirty="0"/>
+              <a:t> </a:t>
+            </a:r>
+            <a:r>
+              <a:rPr lang="de-DE" dirty="0" err="1"/>
+              <a:t>Gaussian</a:t>
+            </a:r>
+            <a:r>
+              <a:rPr lang="de-DE" dirty="0"/>
+              <a:t> </a:t>
+            </a:r>
+            <a:r>
+              <a:rPr lang="de-DE" dirty="0" err="1"/>
+              <a:t>mixture</a:t>
+            </a:r>
+            <a:r>
+              <a:rPr lang="de-DE" dirty="0"/>
+              <a:t> </a:t>
+            </a:r>
+            <a:r>
+              <a:rPr lang="de-DE" dirty="0" err="1"/>
+              <a:t>model</a:t>
+            </a:r>
+            <a:r>
+              <a:rPr lang="de-DE" dirty="0"/>
+              <a:t> </a:t>
+            </a:r>
+            <a:r>
+              <a:rPr lang="de-DE" dirty="0" err="1"/>
+              <a:t>with</a:t>
+            </a:r>
+            <a:r>
+              <a:rPr lang="de-DE" dirty="0"/>
+              <a:t> </a:t>
+            </a:r>
+            <a:r>
+              <a:rPr lang="de-DE" dirty="0" err="1"/>
+              <a:t>equal</a:t>
+            </a:r>
+            <a:r>
+              <a:rPr lang="de-DE" dirty="0"/>
+              <a:t> </a:t>
+            </a:r>
+            <a:r>
+              <a:rPr lang="de-DE" dirty="0" err="1"/>
+              <a:t>covariance</a:t>
+            </a:r>
+            <a:r>
+              <a:rPr lang="de-DE" dirty="0"/>
+              <a:t> per </a:t>
+            </a:r>
+            <a:r>
+              <a:rPr lang="de-DE" dirty="0" err="1"/>
+              <a:t>component</a:t>
             </a:r>
             <a:endParaRPr lang="de-DE" dirty="0"/>
           </a:p>
@@ -7856,7 +9743,7 @@
           <p:cNvPr id="3" name="Foliennummernplatzhalter 2">
             <a:extLst>
               <a:ext uri="{FF2B5EF4-FFF2-40B4-BE49-F238E27FC236}">
-                <a16:creationId xmlns:a16="http://schemas.microsoft.com/office/drawing/2014/main" id="{0F696987-D96D-454C-5E9D-CD69887E2F65}"/>
+                <a16:creationId xmlns:a16="http://schemas.microsoft.com/office/drawing/2014/main" id="{0B40836D-FBB2-F6AE-DB5B-B3E743214157}"/>
               </a:ext>
             </a:extLst>
           </p:cNvPr>
@@ -7883,7 +9770,7 @@
     </p:spTree>
     <p:extLst>
       <p:ext uri="{BB962C8B-B14F-4D97-AF65-F5344CB8AC3E}">
-        <p14:creationId xmlns:p14="http://schemas.microsoft.com/office/powerpoint/2010/main" val="2365265487"/>
+        <p14:creationId xmlns:p14="http://schemas.microsoft.com/office/powerpoint/2010/main" val="3563920324"/>
       </p:ext>
     </p:extLst>
   </p:cSld>
@@ -7915,7 +9802,7 @@
           <p:cNvPr id="2" name="Titel 1">
             <a:extLst>
               <a:ext uri="{FF2B5EF4-FFF2-40B4-BE49-F238E27FC236}">
-                <a16:creationId xmlns:a16="http://schemas.microsoft.com/office/drawing/2014/main" id="{54142ABE-7200-78B0-CCD9-D683F1797E62}"/>
+                <a16:creationId xmlns:a16="http://schemas.microsoft.com/office/drawing/2014/main" id="{712D266D-155F-F226-2B1D-358BA749E8CC}"/>
               </a:ext>
             </a:extLst>
           </p:cNvPr>
@@ -7933,11 +9820,11 @@
           <a:p>
             <a:r>
               <a:rPr lang="de-DE" dirty="0" err="1"/>
-              <a:t>Dendrograms</a:t>
-            </a:r>
-            <a:r>
-              <a:rPr lang="de-DE" dirty="0"/>
-              <a:t> and Interpretation</a:t>
+              <a:t>Hierarchical</a:t>
+            </a:r>
+            <a:r>
+              <a:rPr lang="de-DE" dirty="0"/>
+              <a:t> Clustering: Motivation</a:t>
             </a:r>
           </a:p>
         </p:txBody>
@@ -7947,7 +9834,7 @@
           <p:cNvPr id="3" name="Foliennummernplatzhalter 2">
             <a:extLst>
               <a:ext uri="{FF2B5EF4-FFF2-40B4-BE49-F238E27FC236}">
-                <a16:creationId xmlns:a16="http://schemas.microsoft.com/office/drawing/2014/main" id="{3CF1EAA3-D7F2-B045-B22D-C9405AEBC70C}"/>
+                <a16:creationId xmlns:a16="http://schemas.microsoft.com/office/drawing/2014/main" id="{0837E5E9-930A-77A7-EDB3-BE3C126787F0}"/>
               </a:ext>
             </a:extLst>
           </p:cNvPr>
@@ -7974,7 +9861,7 @@
     </p:spTree>
     <p:extLst>
       <p:ext uri="{BB962C8B-B14F-4D97-AF65-F5344CB8AC3E}">
-        <p14:creationId xmlns:p14="http://schemas.microsoft.com/office/powerpoint/2010/main" val="1704252082"/>
+        <p14:creationId xmlns:p14="http://schemas.microsoft.com/office/powerpoint/2010/main" val="3112906239"/>
       </p:ext>
     </p:extLst>
   </p:cSld>
@@ -8006,7 +9893,7 @@
           <p:cNvPr id="2" name="Titel 1">
             <a:extLst>
               <a:ext uri="{FF2B5EF4-FFF2-40B4-BE49-F238E27FC236}">
-                <a16:creationId xmlns:a16="http://schemas.microsoft.com/office/drawing/2014/main" id="{C1279D54-116A-6D58-B75A-2556899D6B46}"/>
+                <a16:creationId xmlns:a16="http://schemas.microsoft.com/office/drawing/2014/main" id="{4DB71406-467A-A03D-EBA2-95505D3C5AF2}"/>
               </a:ext>
             </a:extLst>
           </p:cNvPr>
@@ -8023,17 +9910,18 @@
           <a:lstStyle/>
           <a:p>
             <a:r>
-              <a:rPr lang="de-DE" dirty="0"/>
-              <a:t>DBSCAN: Density-</a:t>
-            </a:r>
-            <a:r>
-              <a:rPr lang="de-DE" dirty="0" err="1"/>
-              <a:t>Based</a:t>
-            </a:r>
-            <a:r>
-              <a:rPr lang="de-DE" dirty="0"/>
-              <a:t> Clustering</a:t>
-            </a:r>
+              <a:rPr lang="de-DE" dirty="0" err="1"/>
+              <a:t>Linkage</a:t>
+            </a:r>
+            <a:r>
+              <a:rPr lang="de-DE" dirty="0"/>
+              <a:t> </a:t>
+            </a:r>
+            <a:r>
+              <a:rPr lang="de-DE" dirty="0" err="1"/>
+              <a:t>Criteria</a:t>
+            </a:r>
+            <a:endParaRPr lang="de-DE" dirty="0"/>
           </a:p>
         </p:txBody>
       </p:sp>
@@ -8042,7 +9930,7 @@
           <p:cNvPr id="3" name="Foliennummernplatzhalter 2">
             <a:extLst>
               <a:ext uri="{FF2B5EF4-FFF2-40B4-BE49-F238E27FC236}">
-                <a16:creationId xmlns:a16="http://schemas.microsoft.com/office/drawing/2014/main" id="{C6A32FD8-548B-71F2-BB0C-E2FA7DE0D672}"/>
+                <a16:creationId xmlns:a16="http://schemas.microsoft.com/office/drawing/2014/main" id="{0F696987-D96D-454C-5E9D-CD69887E2F65}"/>
               </a:ext>
             </a:extLst>
           </p:cNvPr>
@@ -8069,7 +9957,7 @@
     </p:spTree>
     <p:extLst>
       <p:ext uri="{BB962C8B-B14F-4D97-AF65-F5344CB8AC3E}">
-        <p14:creationId xmlns:p14="http://schemas.microsoft.com/office/powerpoint/2010/main" val="3058453600"/>
+        <p14:creationId xmlns:p14="http://schemas.microsoft.com/office/powerpoint/2010/main" val="2365265487"/>
       </p:ext>
     </p:extLst>
   </p:cSld>
@@ -8101,7 +9989,7 @@
           <p:cNvPr id="2" name="Titel 1">
             <a:extLst>
               <a:ext uri="{FF2B5EF4-FFF2-40B4-BE49-F238E27FC236}">
-                <a16:creationId xmlns:a16="http://schemas.microsoft.com/office/drawing/2014/main" id="{9CC7556B-98BB-9EF2-B9BD-688767AA83EE}"/>
+                <a16:creationId xmlns:a16="http://schemas.microsoft.com/office/drawing/2014/main" id="{54142ABE-7200-78B0-CCD9-D683F1797E62}"/>
               </a:ext>
             </a:extLst>
           </p:cNvPr>
@@ -8118,8 +10006,12 @@
           <a:lstStyle/>
           <a:p>
             <a:r>
-              <a:rPr lang="de-DE" dirty="0"/>
-              <a:t>Core Points, Border Points, Noise</a:t>
+              <a:rPr lang="de-DE" dirty="0" err="1"/>
+              <a:t>Dendrograms</a:t>
+            </a:r>
+            <a:r>
+              <a:rPr lang="de-DE" dirty="0"/>
+              <a:t> and Interpretation</a:t>
             </a:r>
           </a:p>
         </p:txBody>
@@ -8129,7 +10021,7 @@
           <p:cNvPr id="3" name="Foliennummernplatzhalter 2">
             <a:extLst>
               <a:ext uri="{FF2B5EF4-FFF2-40B4-BE49-F238E27FC236}">
-                <a16:creationId xmlns:a16="http://schemas.microsoft.com/office/drawing/2014/main" id="{157EE93D-CF21-6985-77E6-E17034472C2F}"/>
+                <a16:creationId xmlns:a16="http://schemas.microsoft.com/office/drawing/2014/main" id="{3CF1EAA3-D7F2-B045-B22D-C9405AEBC70C}"/>
               </a:ext>
             </a:extLst>
           </p:cNvPr>
@@ -8156,7 +10048,7 @@
     </p:spTree>
     <p:extLst>
       <p:ext uri="{BB962C8B-B14F-4D97-AF65-F5344CB8AC3E}">
-        <p14:creationId xmlns:p14="http://schemas.microsoft.com/office/powerpoint/2010/main" val="1093548525"/>
+        <p14:creationId xmlns:p14="http://schemas.microsoft.com/office/powerpoint/2010/main" val="1704252082"/>
       </p:ext>
     </p:extLst>
   </p:cSld>
@@ -8188,7 +10080,7 @@
           <p:cNvPr id="2" name="Titel 1">
             <a:extLst>
               <a:ext uri="{FF2B5EF4-FFF2-40B4-BE49-F238E27FC236}">
-                <a16:creationId xmlns:a16="http://schemas.microsoft.com/office/drawing/2014/main" id="{9AD358E7-F39E-EF65-C4C0-6907CB00234F}"/>
+                <a16:creationId xmlns:a16="http://schemas.microsoft.com/office/drawing/2014/main" id="{C1279D54-116A-6D58-B75A-2556899D6B46}"/>
               </a:ext>
             </a:extLst>
           </p:cNvPr>
@@ -8205,26 +10097,17 @@
           <a:lstStyle/>
           <a:p>
             <a:r>
-              <a:rPr lang="de-DE" dirty="0" err="1"/>
-              <a:t>Choosing</a:t>
-            </a:r>
-            <a:r>
-              <a:rPr lang="de-DE" dirty="0"/>
-              <a:t> </a:t>
-            </a:r>
-            <a:r>
-              <a:rPr lang="el-GR" dirty="0"/>
-              <a:t>ε </a:t>
-            </a:r>
-            <a:r>
-              <a:rPr lang="de-DE" dirty="0"/>
-              <a:t>and </a:t>
-            </a:r>
-            <a:r>
-              <a:rPr lang="de-DE" dirty="0" err="1"/>
-              <a:t>min_samples</a:t>
-            </a:r>
-            <a:endParaRPr lang="de-DE" dirty="0"/>
+              <a:rPr lang="de-DE" dirty="0"/>
+              <a:t>DBSCAN: Density-</a:t>
+            </a:r>
+            <a:r>
+              <a:rPr lang="de-DE" dirty="0" err="1"/>
+              <a:t>Based</a:t>
+            </a:r>
+            <a:r>
+              <a:rPr lang="de-DE" dirty="0"/>
+              <a:t> Clustering</a:t>
+            </a:r>
           </a:p>
         </p:txBody>
       </p:sp>
@@ -8233,7 +10116,7 @@
           <p:cNvPr id="3" name="Foliennummernplatzhalter 2">
             <a:extLst>
               <a:ext uri="{FF2B5EF4-FFF2-40B4-BE49-F238E27FC236}">
-                <a16:creationId xmlns:a16="http://schemas.microsoft.com/office/drawing/2014/main" id="{7F67A71D-5771-002A-3ED3-D1F7EA87F83F}"/>
+                <a16:creationId xmlns:a16="http://schemas.microsoft.com/office/drawing/2014/main" id="{C6A32FD8-548B-71F2-BB0C-E2FA7DE0D672}"/>
               </a:ext>
             </a:extLst>
           </p:cNvPr>
@@ -8260,7 +10143,7 @@
     </p:spTree>
     <p:extLst>
       <p:ext uri="{BB962C8B-B14F-4D97-AF65-F5344CB8AC3E}">
-        <p14:creationId xmlns:p14="http://schemas.microsoft.com/office/powerpoint/2010/main" val="1011311951"/>
+        <p14:creationId xmlns:p14="http://schemas.microsoft.com/office/powerpoint/2010/main" val="3058453600"/>
       </p:ext>
     </p:extLst>
   </p:cSld>
@@ -8292,7 +10175,7 @@
           <p:cNvPr id="2" name="Titel 1">
             <a:extLst>
               <a:ext uri="{FF2B5EF4-FFF2-40B4-BE49-F238E27FC236}">
-                <a16:creationId xmlns:a16="http://schemas.microsoft.com/office/drawing/2014/main" id="{AB0A312D-A6FF-AB8E-359F-EE1BDB1D4399}"/>
+                <a16:creationId xmlns:a16="http://schemas.microsoft.com/office/drawing/2014/main" id="{9CC7556B-98BB-9EF2-B9BD-688767AA83EE}"/>
               </a:ext>
             </a:extLst>
           </p:cNvPr>
@@ -8309,12 +10192,8 @@
           <a:lstStyle/>
           <a:p>
             <a:r>
-              <a:rPr lang="de-DE" dirty="0" err="1"/>
-              <a:t>Comparing</a:t>
-            </a:r>
-            <a:r>
-              <a:rPr lang="de-DE" dirty="0"/>
-              <a:t> Clustering Methods</a:t>
+              <a:rPr lang="de-DE" dirty="0"/>
+              <a:t>Core Points, Border Points, Noise</a:t>
             </a:r>
           </a:p>
         </p:txBody>
@@ -8324,7 +10203,7 @@
           <p:cNvPr id="3" name="Foliennummernplatzhalter 2">
             <a:extLst>
               <a:ext uri="{FF2B5EF4-FFF2-40B4-BE49-F238E27FC236}">
-                <a16:creationId xmlns:a16="http://schemas.microsoft.com/office/drawing/2014/main" id="{6EFA0DEA-9C10-4341-0996-B658FBE37513}"/>
+                <a16:creationId xmlns:a16="http://schemas.microsoft.com/office/drawing/2014/main" id="{157EE93D-CF21-6985-77E6-E17034472C2F}"/>
               </a:ext>
             </a:extLst>
           </p:cNvPr>
@@ -8351,7 +10230,7 @@
     </p:spTree>
     <p:extLst>
       <p:ext uri="{BB962C8B-B14F-4D97-AF65-F5344CB8AC3E}">
-        <p14:creationId xmlns:p14="http://schemas.microsoft.com/office/powerpoint/2010/main" val="2928299488"/>
+        <p14:creationId xmlns:p14="http://schemas.microsoft.com/office/powerpoint/2010/main" val="1093548525"/>
       </p:ext>
     </p:extLst>
   </p:cSld>
@@ -8383,7 +10262,7 @@
           <p:cNvPr id="2" name="Titel 1">
             <a:extLst>
               <a:ext uri="{FF2B5EF4-FFF2-40B4-BE49-F238E27FC236}">
-                <a16:creationId xmlns:a16="http://schemas.microsoft.com/office/drawing/2014/main" id="{121AA823-E2CE-8C0D-90DB-02DFE9572552}"/>
+                <a16:creationId xmlns:a16="http://schemas.microsoft.com/office/drawing/2014/main" id="{9AD358E7-F39E-EF65-C4C0-6907CB00234F}"/>
               </a:ext>
             </a:extLst>
           </p:cNvPr>
@@ -8400,212 +10279,24 @@
           <a:lstStyle/>
           <a:p>
             <a:r>
-              <a:rPr lang="de-DE" dirty="0"/>
-              <a:t>Cluster Validation </a:t>
-            </a:r>
-            <a:r>
-              <a:rPr lang="de-DE" dirty="0" err="1"/>
-              <a:t>Metrics</a:t>
-            </a:r>
-            <a:endParaRPr lang="de-DE" dirty="0"/>
-          </a:p>
-        </p:txBody>
-      </p:sp>
-      <p:sp>
-        <p:nvSpPr>
-          <p:cNvPr id="4" name="Inhaltsplatzhalter 3">
-            <a:extLst>
-              <a:ext uri="{FF2B5EF4-FFF2-40B4-BE49-F238E27FC236}">
-                <a16:creationId xmlns:a16="http://schemas.microsoft.com/office/drawing/2014/main" id="{4AAAE878-7307-C927-4B47-5A9C5B86AC4E}"/>
-              </a:ext>
-            </a:extLst>
-          </p:cNvPr>
-          <p:cNvSpPr>
-            <a:spLocks noGrp="1"/>
-          </p:cNvSpPr>
-          <p:nvPr>
-            <p:ph idx="1"/>
-          </p:nvPr>
-        </p:nvSpPr>
-        <p:spPr/>
-        <p:txBody>
-          <a:bodyPr/>
-          <a:lstStyle/>
-          <a:p>
-            <a:pPr marL="0" indent="0">
-              <a:buNone/>
-            </a:pPr>
-            <a:r>
-              <a:rPr lang="de-DE" dirty="0" err="1"/>
-              <a:t>Since</a:t>
-            </a:r>
-            <a:r>
-              <a:rPr lang="de-DE" dirty="0"/>
-              <a:t> </a:t>
-            </a:r>
-            <a:r>
-              <a:rPr lang="de-DE" dirty="0" err="1"/>
-              <a:t>clustering</a:t>
-            </a:r>
-            <a:r>
-              <a:rPr lang="de-DE" dirty="0"/>
-              <a:t> </a:t>
-            </a:r>
-            <a:r>
-              <a:rPr lang="de-DE" dirty="0" err="1"/>
-              <a:t>is</a:t>
-            </a:r>
-            <a:r>
-              <a:rPr lang="de-DE" dirty="0"/>
-              <a:t> </a:t>
-            </a:r>
-            <a:r>
-              <a:rPr lang="de-DE" dirty="0" err="1"/>
-              <a:t>unsupervised</a:t>
-            </a:r>
-            <a:r>
-              <a:rPr lang="de-DE" dirty="0"/>
-              <a:t>: </a:t>
-            </a:r>
-            <a:r>
-              <a:rPr lang="de-DE" dirty="0" err="1"/>
-              <a:t>no</a:t>
-            </a:r>
-            <a:r>
-              <a:rPr lang="de-DE" dirty="0"/>
-              <a:t> </a:t>
-            </a:r>
-            <a:r>
-              <a:rPr lang="de-DE" dirty="0" err="1"/>
-              <a:t>single</a:t>
-            </a:r>
-            <a:r>
-              <a:rPr lang="de-DE" dirty="0"/>
-              <a:t> “</a:t>
-            </a:r>
-            <a:r>
-              <a:rPr lang="de-DE" dirty="0" err="1"/>
-              <a:t>correct</a:t>
-            </a:r>
-            <a:r>
-              <a:rPr lang="de-DE" dirty="0"/>
-              <a:t>” </a:t>
-            </a:r>
-            <a:r>
-              <a:rPr lang="de-DE" dirty="0" err="1"/>
-              <a:t>answer</a:t>
-            </a:r>
-            <a:endParaRPr lang="de-DE" dirty="0"/>
-          </a:p>
-          <a:p>
-            <a:pPr marL="0" indent="0">
-              <a:buNone/>
-            </a:pPr>
-            <a:endParaRPr lang="de-DE" dirty="0"/>
-          </a:p>
-          <a:p>
-            <a:pPr marL="0" indent="0">
-              <a:buNone/>
-            </a:pPr>
-            <a:r>
-              <a:rPr lang="de-DE" dirty="0" err="1"/>
-              <a:t>Instead</a:t>
-            </a:r>
-            <a:r>
-              <a:rPr lang="de-DE" dirty="0"/>
-              <a:t> </a:t>
-            </a:r>
-            <a:r>
-              <a:rPr lang="de-DE" dirty="0" err="1"/>
-              <a:t>measure</a:t>
-            </a:r>
-            <a:r>
-              <a:rPr lang="de-DE" dirty="0"/>
-              <a:t> </a:t>
-            </a:r>
-            <a:r>
-              <a:rPr lang="de-DE" dirty="0" err="1"/>
-              <a:t>how</a:t>
-            </a:r>
-            <a:r>
-              <a:rPr lang="de-DE" dirty="0"/>
-              <a:t> well-</a:t>
-            </a:r>
-            <a:r>
-              <a:rPr lang="de-DE" dirty="0" err="1"/>
-              <a:t>separated</a:t>
-            </a:r>
-            <a:r>
-              <a:rPr lang="de-DE" dirty="0"/>
-              <a:t> and </a:t>
-            </a:r>
-            <a:r>
-              <a:rPr lang="de-DE" dirty="0" err="1"/>
-              <a:t>cohesive</a:t>
-            </a:r>
-            <a:r>
-              <a:rPr lang="de-DE" dirty="0"/>
-              <a:t> </a:t>
-            </a:r>
-            <a:r>
-              <a:rPr lang="de-DE" dirty="0" err="1"/>
-              <a:t>clusters</a:t>
-            </a:r>
-            <a:r>
-              <a:rPr lang="de-DE" dirty="0"/>
-              <a:t> </a:t>
-            </a:r>
-            <a:r>
-              <a:rPr lang="de-DE" dirty="0" err="1"/>
-              <a:t>are</a:t>
-            </a:r>
-            <a:endParaRPr lang="de-DE" dirty="0"/>
-          </a:p>
-          <a:p>
-            <a:pPr marL="0" indent="0">
-              <a:buNone/>
-            </a:pPr>
-            <a:endParaRPr lang="de-DE" dirty="0"/>
-          </a:p>
-          <a:p>
-            <a:pPr marL="0" indent="0">
-              <a:buNone/>
-            </a:pPr>
-            <a:r>
-              <a:rPr lang="de-DE" dirty="0"/>
-              <a:t>Evaluation </a:t>
-            </a:r>
-            <a:r>
-              <a:rPr lang="de-DE" dirty="0" err="1"/>
-              <a:t>metrics</a:t>
-            </a:r>
-            <a:r>
-              <a:rPr lang="de-DE" dirty="0"/>
-              <a:t>:</a:t>
-            </a:r>
-          </a:p>
-          <a:p>
-            <a:r>
-              <a:rPr lang="de-DE" dirty="0"/>
-              <a:t>Silhouette score</a:t>
-            </a:r>
-          </a:p>
-          <a:p>
-            <a:r>
-              <a:rPr lang="de-DE" dirty="0"/>
-              <a:t>Davies-</a:t>
-            </a:r>
-            <a:r>
-              <a:rPr lang="de-DE" dirty="0" err="1"/>
-              <a:t>Bouldin</a:t>
-            </a:r>
-            <a:r>
-              <a:rPr lang="de-DE" dirty="0"/>
-              <a:t> </a:t>
-            </a:r>
-            <a:r>
-              <a:rPr lang="de-DE" dirty="0" err="1"/>
-              <a:t>index</a:t>
+              <a:rPr lang="de-DE" dirty="0" err="1"/>
+              <a:t>Choosing</a:t>
+            </a:r>
+            <a:r>
+              <a:rPr lang="de-DE" dirty="0"/>
+              <a:t> </a:t>
+            </a:r>
+            <a:r>
+              <a:rPr lang="el-GR" dirty="0"/>
+              <a:t>ε </a:t>
+            </a:r>
+            <a:r>
+              <a:rPr lang="de-DE" dirty="0"/>
+              <a:t>and </a:t>
+            </a:r>
+            <a:r>
+              <a:rPr lang="de-DE" dirty="0" err="1"/>
+              <a:t>min_samples</a:t>
             </a:r>
             <a:endParaRPr lang="de-DE" dirty="0"/>
           </a:p>
@@ -8616,7 +10307,7 @@
           <p:cNvPr id="3" name="Foliennummernplatzhalter 2">
             <a:extLst>
               <a:ext uri="{FF2B5EF4-FFF2-40B4-BE49-F238E27FC236}">
-                <a16:creationId xmlns:a16="http://schemas.microsoft.com/office/drawing/2014/main" id="{563E3869-C5B7-1A95-0614-2B381BD8C120}"/>
+                <a16:creationId xmlns:a16="http://schemas.microsoft.com/office/drawing/2014/main" id="{7F67A71D-5771-002A-3ED3-D1F7EA87F83F}"/>
               </a:ext>
             </a:extLst>
           </p:cNvPr>
@@ -8643,7 +10334,7 @@
     </p:spTree>
     <p:extLst>
       <p:ext uri="{BB962C8B-B14F-4D97-AF65-F5344CB8AC3E}">
-        <p14:creationId xmlns:p14="http://schemas.microsoft.com/office/powerpoint/2010/main" val="474217543"/>
+        <p14:creationId xmlns:p14="http://schemas.microsoft.com/office/powerpoint/2010/main" val="1011311951"/>
       </p:ext>
     </p:extLst>
   </p:cSld>
@@ -8675,7 +10366,7 @@
           <p:cNvPr id="2" name="Titel 1">
             <a:extLst>
               <a:ext uri="{FF2B5EF4-FFF2-40B4-BE49-F238E27FC236}">
-                <a16:creationId xmlns:a16="http://schemas.microsoft.com/office/drawing/2014/main" id="{E1872AF3-6DAA-E6C2-A919-228FF3EB5851}"/>
+                <a16:creationId xmlns:a16="http://schemas.microsoft.com/office/drawing/2014/main" id="{AB0A312D-A6FF-AB8E-359F-EE1BDB1D4399}"/>
               </a:ext>
             </a:extLst>
           </p:cNvPr>
@@ -8693,11 +10384,11 @@
           <a:p>
             <a:r>
               <a:rPr lang="de-DE" dirty="0" err="1"/>
-              <a:t>Visualizing</a:t>
-            </a:r>
-            <a:r>
-              <a:rPr lang="de-DE" dirty="0"/>
-              <a:t> Clusters</a:t>
+              <a:t>Comparing</a:t>
+            </a:r>
+            <a:r>
+              <a:rPr lang="de-DE" dirty="0"/>
+              <a:t> Clustering Methods</a:t>
             </a:r>
           </a:p>
         </p:txBody>
@@ -8707,7 +10398,7 @@
           <p:cNvPr id="3" name="Foliennummernplatzhalter 2">
             <a:extLst>
               <a:ext uri="{FF2B5EF4-FFF2-40B4-BE49-F238E27FC236}">
-                <a16:creationId xmlns:a16="http://schemas.microsoft.com/office/drawing/2014/main" id="{81251F56-854B-D4C6-04C7-5A3B3F8DB84E}"/>
+                <a16:creationId xmlns:a16="http://schemas.microsoft.com/office/drawing/2014/main" id="{6EFA0DEA-9C10-4341-0996-B658FBE37513}"/>
               </a:ext>
             </a:extLst>
           </p:cNvPr>
@@ -8734,103 +10425,7 @@
     </p:spTree>
     <p:extLst>
       <p:ext uri="{BB962C8B-B14F-4D97-AF65-F5344CB8AC3E}">
-        <p14:creationId xmlns:p14="http://schemas.microsoft.com/office/powerpoint/2010/main" val="2070037097"/>
-      </p:ext>
-    </p:extLst>
-  </p:cSld>
-  <p:clrMapOvr>
-    <a:masterClrMapping/>
-  </p:clrMapOvr>
-</p:sld>
-</file>
-
-<file path=ppt/slides/slide29.xml><?xml version="1.0" encoding="utf-8"?>
-<p:sld xmlns:a="http://schemas.openxmlformats.org/drawingml/2006/main" xmlns:r="http://schemas.openxmlformats.org/officeDocument/2006/relationships" xmlns:p="http://schemas.openxmlformats.org/presentationml/2006/main">
-  <p:cSld>
-    <p:spTree>
-      <p:nvGrpSpPr>
-        <p:cNvPr id="1" name=""/>
-        <p:cNvGrpSpPr/>
-        <p:nvPr/>
-      </p:nvGrpSpPr>
-      <p:grpSpPr>
-        <a:xfrm>
-          <a:off x="0" y="0"/>
-          <a:ext cx="0" cy="0"/>
-          <a:chOff x="0" y="0"/>
-          <a:chExt cx="0" cy="0"/>
-        </a:xfrm>
-      </p:grpSpPr>
-      <p:sp>
-        <p:nvSpPr>
-          <p:cNvPr id="2" name="Titel 1">
-            <a:extLst>
-              <a:ext uri="{FF2B5EF4-FFF2-40B4-BE49-F238E27FC236}">
-                <a16:creationId xmlns:a16="http://schemas.microsoft.com/office/drawing/2014/main" id="{45D9CD1B-A5B6-7BCE-AB1E-4C80D77AE1D3}"/>
-              </a:ext>
-            </a:extLst>
-          </p:cNvPr>
-          <p:cNvSpPr>
-            <a:spLocks noGrp="1"/>
-          </p:cNvSpPr>
-          <p:nvPr>
-            <p:ph type="title"/>
-          </p:nvPr>
-        </p:nvSpPr>
-        <p:spPr/>
-        <p:txBody>
-          <a:bodyPr/>
-          <a:lstStyle/>
-          <a:p>
-            <a:r>
-              <a:rPr lang="de-DE" dirty="0" err="1"/>
-              <a:t>Practical</a:t>
-            </a:r>
-            <a:r>
-              <a:rPr lang="de-DE" dirty="0"/>
-              <a:t> </a:t>
-            </a:r>
-            <a:r>
-              <a:rPr lang="de-DE" dirty="0" err="1"/>
-              <a:t>Considerations</a:t>
-            </a:r>
-            <a:endParaRPr lang="de-DE" dirty="0"/>
-          </a:p>
-        </p:txBody>
-      </p:sp>
-      <p:sp>
-        <p:nvSpPr>
-          <p:cNvPr id="3" name="Foliennummernplatzhalter 2">
-            <a:extLst>
-              <a:ext uri="{FF2B5EF4-FFF2-40B4-BE49-F238E27FC236}">
-                <a16:creationId xmlns:a16="http://schemas.microsoft.com/office/drawing/2014/main" id="{5AE0FEB0-A1C8-1184-0009-46A75979A2F5}"/>
-              </a:ext>
-            </a:extLst>
-          </p:cNvPr>
-          <p:cNvSpPr>
-            <a:spLocks noGrp="1"/>
-          </p:cNvSpPr>
-          <p:nvPr>
-            <p:ph type="sldNum" sz="quarter" idx="12"/>
-          </p:nvPr>
-        </p:nvSpPr>
-        <p:spPr/>
-        <p:txBody>
-          <a:bodyPr/>
-          <a:lstStyle/>
-          <a:p>
-            <a:fld id="{08C366F5-AFAD-49CB-854A-9D9E238FCA13}" type="slidenum">
-              <a:rPr lang="en-GB" smtClean="0"/>
-              <a:t>29</a:t>
-            </a:fld>
-            <a:endParaRPr lang="en-GB"/>
-          </a:p>
-        </p:txBody>
-      </p:sp>
-    </p:spTree>
-    <p:extLst>
-      <p:ext uri="{BB962C8B-B14F-4D97-AF65-F5344CB8AC3E}">
-        <p14:creationId xmlns:p14="http://schemas.microsoft.com/office/powerpoint/2010/main" val="3939287568"/>
+        <p14:creationId xmlns:p14="http://schemas.microsoft.com/office/powerpoint/2010/main" val="2928299488"/>
       </p:ext>
     </p:extLst>
   </p:cSld>

</xml_diff>

<commit_message>
more details on clustering
</commit_message>
<xml_diff>
--- a/slides/2_clustering.pptx
+++ b/slides/2_clustering.pptx
@@ -5,7 +5,7 @@
     <p:sldMasterId id="2147483648" r:id="rId1"/>
   </p:sldMasterIdLst>
   <p:notesMasterIdLst>
-    <p:notesMasterId r:id="rId37"/>
+    <p:notesMasterId r:id="rId38"/>
   </p:notesMasterIdLst>
   <p:sldIdLst>
     <p:sldId id="256" r:id="rId2"/>
@@ -41,8 +41,9 @@
     <p:sldId id="279" r:id="rId32"/>
     <p:sldId id="303" r:id="rId33"/>
     <p:sldId id="280" r:id="rId34"/>
-    <p:sldId id="281" r:id="rId35"/>
-    <p:sldId id="302" r:id="rId36"/>
+    <p:sldId id="304" r:id="rId35"/>
+    <p:sldId id="281" r:id="rId36"/>
+    <p:sldId id="302" r:id="rId37"/>
   </p:sldIdLst>
   <p:sldSz cx="12192000" cy="6858000"/>
   <p:notesSz cx="6858000" cy="9144000"/>
@@ -513,7 +514,7 @@
           <a:p>
             <a:fld id="{506E0FD1-891F-4B1E-916D-E9B585160BB8}" type="datetimeFigureOut">
               <a:rPr lang="en-GB" smtClean="0"/>
-              <a:t>19/03/2026</a:t>
+              <a:t>21/03/2026</a:t>
             </a:fld>
             <a:endParaRPr lang="en-GB"/>
           </a:p>
@@ -930,7 +931,7 @@
           <a:p>
             <a:fld id="{D68C3F22-27B2-44E3-9C5F-D08126455F6F}" type="datetime1">
               <a:rPr lang="en-GB" smtClean="0"/>
-              <a:t>19/03/2026</a:t>
+              <a:t>21/03/2026</a:t>
             </a:fld>
             <a:endParaRPr lang="en-GB"/>
           </a:p>
@@ -1130,7 +1131,7 @@
           <a:p>
             <a:fld id="{1CD03846-7BF6-4FB6-A921-FF3379ADBD4C}" type="datetime1">
               <a:rPr lang="en-GB" smtClean="0"/>
-              <a:t>19/03/2026</a:t>
+              <a:t>21/03/2026</a:t>
             </a:fld>
             <a:endParaRPr lang="en-GB"/>
           </a:p>
@@ -1340,7 +1341,7 @@
           <a:p>
             <a:fld id="{99E1B91A-3FD0-4144-9C84-63E9688ED2FE}" type="datetime1">
               <a:rPr lang="en-GB" smtClean="0"/>
-              <a:t>19/03/2026</a:t>
+              <a:t>21/03/2026</a:t>
             </a:fld>
             <a:endParaRPr lang="en-GB"/>
           </a:p>
@@ -1540,7 +1541,7 @@
           <a:p>
             <a:fld id="{5295ED7B-FEAD-4734-819F-93EF4B0EA908}" type="datetime1">
               <a:rPr lang="en-GB" smtClean="0"/>
-              <a:t>19/03/2026</a:t>
+              <a:t>21/03/2026</a:t>
             </a:fld>
             <a:endParaRPr lang="en-GB"/>
           </a:p>
@@ -1816,7 +1817,7 @@
           <a:p>
             <a:fld id="{D2D5D4B4-C926-4B45-8815-1ED8911179A2}" type="datetime1">
               <a:rPr lang="en-GB" smtClean="0"/>
-              <a:t>19/03/2026</a:t>
+              <a:t>21/03/2026</a:t>
             </a:fld>
             <a:endParaRPr lang="en-GB"/>
           </a:p>
@@ -2084,7 +2085,7 @@
           <a:p>
             <a:fld id="{B4C5210A-0E37-4935-93AF-69F21A5F712F}" type="datetime1">
               <a:rPr lang="en-GB" smtClean="0"/>
-              <a:t>19/03/2026</a:t>
+              <a:t>21/03/2026</a:t>
             </a:fld>
             <a:endParaRPr lang="en-GB"/>
           </a:p>
@@ -2499,7 +2500,7 @@
           <a:p>
             <a:fld id="{3D3A6B2F-436C-4691-80E8-9C890E000E9D}" type="datetime1">
               <a:rPr lang="en-GB" smtClean="0"/>
-              <a:t>19/03/2026</a:t>
+              <a:t>21/03/2026</a:t>
             </a:fld>
             <a:endParaRPr lang="en-GB"/>
           </a:p>
@@ -2641,7 +2642,7 @@
           <a:p>
             <a:fld id="{84385F4C-D74B-496F-8D21-97E3549C783B}" type="datetime1">
               <a:rPr lang="en-GB" smtClean="0"/>
-              <a:t>19/03/2026</a:t>
+              <a:t>21/03/2026</a:t>
             </a:fld>
             <a:endParaRPr lang="en-GB"/>
           </a:p>
@@ -2754,7 +2755,7 @@
           <a:p>
             <a:fld id="{0CBDCB32-C241-4703-A832-4EB47BD54E83}" type="datetime1">
               <a:rPr lang="en-GB" smtClean="0"/>
-              <a:t>19/03/2026</a:t>
+              <a:t>21/03/2026</a:t>
             </a:fld>
             <a:endParaRPr lang="en-GB"/>
           </a:p>
@@ -3067,7 +3068,7 @@
           <a:p>
             <a:fld id="{85C150FF-BE95-4D25-A16A-E368A81CBF24}" type="datetime1">
               <a:rPr lang="en-GB" smtClean="0"/>
-              <a:t>19/03/2026</a:t>
+              <a:t>21/03/2026</a:t>
             </a:fld>
             <a:endParaRPr lang="en-GB"/>
           </a:p>
@@ -3356,7 +3357,7 @@
           <a:p>
             <a:fld id="{F3C5DB4B-B349-43C9-A424-BADA723AD9F1}" type="datetime1">
               <a:rPr lang="en-GB" smtClean="0"/>
-              <a:t>19/03/2026</a:t>
+              <a:t>21/03/2026</a:t>
             </a:fld>
             <a:endParaRPr lang="en-GB"/>
           </a:p>
@@ -3599,7 +3600,7 @@
           <a:p>
             <a:fld id="{12632426-0A0C-405F-A3D0-2D11AA44702A}" type="datetime1">
               <a:rPr lang="en-GB" smtClean="0"/>
-              <a:t>19/03/2026</a:t>
+              <a:t>21/03/2026</a:t>
             </a:fld>
             <a:endParaRPr lang="en-GB"/>
           </a:p>
@@ -4159,9 +4160,18 @@
         <p:spPr/>
         <p:txBody>
           <a:bodyPr>
-            <a:normAutofit/>
+            <a:normAutofit fontScale="85000" lnSpcReduction="20000"/>
           </a:bodyPr>
           <a:lstStyle/>
+          <a:p>
+            <a:pPr marL="0" indent="0">
+              <a:buNone/>
+            </a:pPr>
+            <a:r>
+              <a:rPr lang="de-DE" dirty="0"/>
+              <a:t>Fit:</a:t>
+            </a:r>
+          </a:p>
           <a:p>
             <a:pPr marL="514350" indent="-514350">
               <a:buFont typeface="+mj-lt"/>
@@ -4580,6 +4590,123 @@
               <a:rPr lang="de-DE" dirty="0"/>
               <a:t>)</a:t>
             </a:r>
+          </a:p>
+          <a:p>
+            <a:pPr marL="0" indent="0">
+              <a:buNone/>
+            </a:pPr>
+            <a:endParaRPr lang="de-DE" dirty="0"/>
+          </a:p>
+          <a:p>
+            <a:pPr marL="0" indent="0">
+              <a:buNone/>
+            </a:pPr>
+            <a:r>
+              <a:rPr lang="de-DE" dirty="0" err="1"/>
+              <a:t>Predict</a:t>
+            </a:r>
+            <a:r>
+              <a:rPr lang="de-DE" dirty="0"/>
+              <a:t>:</a:t>
+            </a:r>
+          </a:p>
+          <a:p>
+            <a:pPr marL="0" indent="0">
+              <a:buNone/>
+            </a:pPr>
+            <a:r>
+              <a:rPr lang="de-DE" dirty="0" err="1"/>
+              <a:t>For</a:t>
+            </a:r>
+            <a:r>
+              <a:rPr lang="de-DE" dirty="0"/>
+              <a:t> a </a:t>
+            </a:r>
+            <a:r>
+              <a:rPr lang="de-DE" dirty="0" err="1"/>
+              <a:t>new</a:t>
+            </a:r>
+            <a:r>
+              <a:rPr lang="de-DE" dirty="0"/>
+              <a:t> </a:t>
+            </a:r>
+            <a:r>
+              <a:rPr lang="de-DE" dirty="0" err="1"/>
+              <a:t>point</a:t>
+            </a:r>
+            <a:r>
+              <a:rPr lang="de-DE" dirty="0"/>
+              <a:t>: </a:t>
+            </a:r>
+            <a:r>
+              <a:rPr lang="de-DE" dirty="0" err="1"/>
+              <a:t>Assign</a:t>
+            </a:r>
+            <a:r>
+              <a:rPr lang="de-DE" dirty="0"/>
+              <a:t> </a:t>
+            </a:r>
+            <a:r>
+              <a:rPr lang="de-DE" dirty="0" err="1"/>
+              <a:t>it</a:t>
+            </a:r>
+            <a:r>
+              <a:rPr lang="de-DE" dirty="0"/>
+              <a:t> </a:t>
+            </a:r>
+            <a:r>
+              <a:rPr lang="de-DE" dirty="0" err="1"/>
+              <a:t>to</a:t>
+            </a:r>
+            <a:r>
+              <a:rPr lang="de-DE" dirty="0"/>
+              <a:t> </a:t>
+            </a:r>
+            <a:r>
+              <a:rPr lang="de-DE" dirty="0" err="1"/>
+              <a:t>the</a:t>
+            </a:r>
+            <a:r>
+              <a:rPr lang="de-DE" dirty="0"/>
+              <a:t> </a:t>
+            </a:r>
+            <a:r>
+              <a:rPr lang="de-DE" dirty="0" err="1"/>
+              <a:t>cluster</a:t>
+            </a:r>
+            <a:r>
+              <a:rPr lang="de-DE" dirty="0"/>
+              <a:t> </a:t>
+            </a:r>
+            <a:r>
+              <a:rPr lang="de-DE" dirty="0" err="1"/>
+              <a:t>with</a:t>
+            </a:r>
+            <a:r>
+              <a:rPr lang="de-DE" dirty="0"/>
+              <a:t> </a:t>
+            </a:r>
+            <a:r>
+              <a:rPr lang="de-DE" dirty="0" err="1"/>
+              <a:t>the</a:t>
+            </a:r>
+            <a:r>
+              <a:rPr lang="de-DE" dirty="0"/>
+              <a:t> </a:t>
+            </a:r>
+            <a:r>
+              <a:rPr lang="de-DE" b="1" dirty="0" err="1"/>
+              <a:t>nearest</a:t>
+            </a:r>
+            <a:r>
+              <a:rPr lang="de-DE" b="1" dirty="0"/>
+              <a:t> </a:t>
+            </a:r>
+            <a:r>
+              <a:rPr lang="de-DE" b="1" dirty="0" err="1"/>
+              <a:t>centroid</a:t>
+            </a:r>
+            <a:endParaRPr lang="de-DE" dirty="0"/>
           </a:p>
         </p:txBody>
       </p:sp>
@@ -15289,7 +15416,7 @@
         </p:nvSpPr>
         <p:spPr>
           <a:xfrm>
-            <a:off x="838200" y="1825625"/>
+            <a:off x="838200" y="1477759"/>
             <a:ext cx="5801783" cy="4351338"/>
           </a:xfrm>
         </p:spPr>
@@ -15661,7 +15788,7 @@
         </p:blipFill>
         <p:spPr bwMode="auto">
           <a:xfrm>
-            <a:off x="6390217" y="1690688"/>
+            <a:off x="6390217" y="1342822"/>
             <a:ext cx="5801783" cy="4351338"/>
           </a:xfrm>
           <a:prstGeom prst="rect">
@@ -15679,6 +15806,346 @@
           </a:extLst>
         </p:spPr>
       </p:pic>
+      <p:sp>
+        <p:nvSpPr>
+          <p:cNvPr id="7" name="Textfeld 6">
+            <a:extLst>
+              <a:ext uri="{FF2B5EF4-FFF2-40B4-BE49-F238E27FC236}">
+                <a16:creationId xmlns:a16="http://schemas.microsoft.com/office/drawing/2014/main" id="{1AF073BF-A815-CFE5-9DA2-61E930072E0D}"/>
+              </a:ext>
+            </a:extLst>
+          </p:cNvPr>
+          <p:cNvSpPr txBox="1"/>
+          <p:nvPr/>
+        </p:nvSpPr>
+        <p:spPr>
+          <a:xfrm>
+            <a:off x="838200" y="5975797"/>
+            <a:ext cx="9707216" cy="830997"/>
+          </a:xfrm>
+          <a:prstGeom prst="rect">
+            <a:avLst/>
+          </a:prstGeom>
+          <a:noFill/>
+        </p:spPr>
+        <p:txBody>
+          <a:bodyPr wrap="square">
+            <a:spAutoFit/>
+          </a:bodyPr>
+          <a:lstStyle/>
+          <a:p>
+            <a:pPr>
+              <a:buNone/>
+            </a:pPr>
+            <a:r>
+              <a:rPr lang="de-DE" sz="2400" dirty="0" err="1">
+                <a:solidFill>
+                  <a:srgbClr val="0E0E0E"/>
+                </a:solidFill>
+                <a:effectLst/>
+                <a:latin typeface=".AppleSystemUIFont"/>
+              </a:rPr>
+              <a:t>Assign</a:t>
+            </a:r>
+            <a:r>
+              <a:rPr lang="de-DE" sz="2400" dirty="0">
+                <a:solidFill>
+                  <a:srgbClr val="0E0E0E"/>
+                </a:solidFill>
+                <a:effectLst/>
+                <a:latin typeface=".AppleSystemUIFont"/>
+              </a:rPr>
+              <a:t> </a:t>
+            </a:r>
+            <a:r>
+              <a:rPr lang="de-DE" sz="2400" dirty="0" err="1">
+                <a:solidFill>
+                  <a:srgbClr val="0E0E0E"/>
+                </a:solidFill>
+                <a:effectLst/>
+                <a:latin typeface=".AppleSystemUIFont"/>
+              </a:rPr>
+              <a:t>new</a:t>
+            </a:r>
+            <a:r>
+              <a:rPr lang="de-DE" sz="2400" dirty="0">
+                <a:solidFill>
+                  <a:srgbClr val="0E0E0E"/>
+                </a:solidFill>
+                <a:effectLst/>
+                <a:latin typeface=".AppleSystemUIFont"/>
+              </a:rPr>
+              <a:t> </a:t>
+            </a:r>
+            <a:r>
+              <a:rPr lang="de-DE" sz="2400" dirty="0" err="1">
+                <a:solidFill>
+                  <a:srgbClr val="0E0E0E"/>
+                </a:solidFill>
+                <a:effectLst/>
+                <a:latin typeface=".AppleSystemUIFont"/>
+              </a:rPr>
+              <a:t>points</a:t>
+            </a:r>
+            <a:r>
+              <a:rPr lang="de-DE" sz="2400" dirty="0">
+                <a:solidFill>
+                  <a:srgbClr val="0E0E0E"/>
+                </a:solidFill>
+                <a:effectLst/>
+                <a:latin typeface=".AppleSystemUIFont"/>
+              </a:rPr>
+              <a:t> </a:t>
+            </a:r>
+            <a:r>
+              <a:rPr lang="de-DE" sz="2400" dirty="0" err="1">
+                <a:solidFill>
+                  <a:srgbClr val="0E0E0E"/>
+                </a:solidFill>
+                <a:effectLst/>
+                <a:latin typeface=".AppleSystemUIFont"/>
+              </a:rPr>
+              <a:t>by</a:t>
+            </a:r>
+            <a:r>
+              <a:rPr lang="de-DE" sz="2400" dirty="0">
+                <a:solidFill>
+                  <a:srgbClr val="0E0E0E"/>
+                </a:solidFill>
+                <a:effectLst/>
+                <a:latin typeface=".AppleSystemUIFont"/>
+              </a:rPr>
+              <a:t> </a:t>
+            </a:r>
+            <a:r>
+              <a:rPr lang="de-DE" sz="2400" dirty="0" err="1">
+                <a:solidFill>
+                  <a:srgbClr val="0E0E0E"/>
+                </a:solidFill>
+                <a:effectLst/>
+                <a:latin typeface=".AppleSystemUIFont"/>
+              </a:rPr>
+              <a:t>distance</a:t>
+            </a:r>
+            <a:r>
+              <a:rPr lang="de-DE" sz="2400" dirty="0">
+                <a:solidFill>
+                  <a:srgbClr val="0E0E0E"/>
+                </a:solidFill>
+                <a:effectLst/>
+                <a:latin typeface=".AppleSystemUIFont"/>
+              </a:rPr>
+              <a:t> </a:t>
+            </a:r>
+            <a:r>
+              <a:rPr lang="de-DE" sz="2400" dirty="0" err="1">
+                <a:solidFill>
+                  <a:srgbClr val="0E0E0E"/>
+                </a:solidFill>
+                <a:effectLst/>
+                <a:latin typeface=".AppleSystemUIFont"/>
+              </a:rPr>
+              <a:t>to</a:t>
+            </a:r>
+            <a:r>
+              <a:rPr lang="de-DE" sz="2400" dirty="0">
+                <a:solidFill>
+                  <a:srgbClr val="0E0E0E"/>
+                </a:solidFill>
+                <a:effectLst/>
+                <a:latin typeface=".AppleSystemUIFont"/>
+              </a:rPr>
+              <a:t> </a:t>
+            </a:r>
+            <a:r>
+              <a:rPr lang="de-DE" sz="2400" dirty="0" err="1">
+                <a:solidFill>
+                  <a:srgbClr val="0E0E0E"/>
+                </a:solidFill>
+                <a:effectLst/>
+                <a:latin typeface=".AppleSystemUIFont"/>
+              </a:rPr>
+              <a:t>cluster</a:t>
+            </a:r>
+            <a:r>
+              <a:rPr lang="de-DE" sz="2400" dirty="0">
+                <a:solidFill>
+                  <a:srgbClr val="0E0E0E"/>
+                </a:solidFill>
+                <a:effectLst/>
+                <a:latin typeface=".AppleSystemUIFont"/>
+              </a:rPr>
+              <a:t> </a:t>
+            </a:r>
+            <a:r>
+              <a:rPr lang="de-DE" sz="2400" dirty="0" err="1">
+                <a:solidFill>
+                  <a:srgbClr val="0E0E0E"/>
+                </a:solidFill>
+                <a:effectLst/>
+                <a:latin typeface=".AppleSystemUIFont"/>
+              </a:rPr>
+              <a:t>representatives</a:t>
+            </a:r>
+            <a:r>
+              <a:rPr lang="de-DE" sz="2400" dirty="0">
+                <a:solidFill>
+                  <a:srgbClr val="0E0E0E"/>
+                </a:solidFill>
+                <a:effectLst/>
+                <a:latin typeface=".AppleSystemUIFont"/>
+              </a:rPr>
+              <a:t> (e.g., </a:t>
+            </a:r>
+            <a:r>
+              <a:rPr lang="de-DE" sz="2400" dirty="0" err="1">
+                <a:solidFill>
+                  <a:srgbClr val="0E0E0E"/>
+                </a:solidFill>
+                <a:effectLst/>
+                <a:latin typeface=".AppleSystemUIFont"/>
+              </a:rPr>
+              <a:t>centroids</a:t>
+            </a:r>
+            <a:r>
+              <a:rPr lang="de-DE" sz="2400" dirty="0">
+                <a:solidFill>
+                  <a:srgbClr val="0E0E0E"/>
+                </a:solidFill>
+                <a:effectLst/>
+                <a:latin typeface=".AppleSystemUIFont"/>
+              </a:rPr>
+              <a:t>):</a:t>
+            </a:r>
+            <a:r>
+              <a:rPr lang="de-DE" sz="2400" dirty="0">
+                <a:solidFill>
+                  <a:srgbClr val="0E0E0E"/>
+                </a:solidFill>
+                <a:latin typeface=".AppleSystemUIFont"/>
+              </a:rPr>
+              <a:t> </a:t>
+            </a:r>
+            <a:r>
+              <a:rPr lang="de-DE" sz="2400" dirty="0" err="1">
+                <a:solidFill>
+                  <a:srgbClr val="0E0E0E"/>
+                </a:solidFill>
+                <a:effectLst/>
+                <a:latin typeface=".AppleSystemUIFont"/>
+              </a:rPr>
+              <a:t>practical</a:t>
+            </a:r>
+            <a:r>
+              <a:rPr lang="de-DE" sz="2400" dirty="0">
+                <a:solidFill>
+                  <a:srgbClr val="0E0E0E"/>
+                </a:solidFill>
+                <a:effectLst/>
+                <a:latin typeface=".AppleSystemUIFont"/>
+              </a:rPr>
+              <a:t> </a:t>
+            </a:r>
+            <a:r>
+              <a:rPr lang="de-DE" sz="2400" dirty="0" err="1">
+                <a:solidFill>
+                  <a:srgbClr val="0E0E0E"/>
+                </a:solidFill>
+                <a:effectLst/>
+                <a:latin typeface=".AppleSystemUIFont"/>
+              </a:rPr>
+              <a:t>heuristic</a:t>
+            </a:r>
+            <a:r>
+              <a:rPr lang="de-DE" sz="2400" dirty="0">
+                <a:solidFill>
+                  <a:srgbClr val="0E0E0E"/>
+                </a:solidFill>
+                <a:effectLst/>
+                <a:latin typeface=".AppleSystemUIFont"/>
+              </a:rPr>
+              <a:t>, not </a:t>
+            </a:r>
+            <a:r>
+              <a:rPr lang="de-DE" sz="2400" dirty="0" err="1">
+                <a:solidFill>
+                  <a:srgbClr val="0E0E0E"/>
+                </a:solidFill>
+                <a:effectLst/>
+                <a:latin typeface=".AppleSystemUIFont"/>
+              </a:rPr>
+              <a:t>inherent</a:t>
+            </a:r>
+            <a:r>
+              <a:rPr lang="de-DE" sz="2400" dirty="0">
+                <a:solidFill>
+                  <a:srgbClr val="0E0E0E"/>
+                </a:solidFill>
+                <a:effectLst/>
+                <a:latin typeface=".AppleSystemUIFont"/>
+              </a:rPr>
+              <a:t> </a:t>
+            </a:r>
+            <a:r>
+              <a:rPr lang="de-DE" sz="2400" dirty="0" err="1">
+                <a:solidFill>
+                  <a:srgbClr val="0E0E0E"/>
+                </a:solidFill>
+                <a:effectLst/>
+                <a:latin typeface=".AppleSystemUIFont"/>
+              </a:rPr>
+              <a:t>to</a:t>
+            </a:r>
+            <a:r>
+              <a:rPr lang="de-DE" sz="2400" dirty="0">
+                <a:solidFill>
+                  <a:srgbClr val="0E0E0E"/>
+                </a:solidFill>
+                <a:effectLst/>
+                <a:latin typeface=".AppleSystemUIFont"/>
+              </a:rPr>
+              <a:t> </a:t>
+            </a:r>
+            <a:r>
+              <a:rPr lang="de-DE" sz="2400" dirty="0" err="1">
+                <a:solidFill>
+                  <a:srgbClr val="0E0E0E"/>
+                </a:solidFill>
+                <a:effectLst/>
+                <a:latin typeface=".AppleSystemUIFont"/>
+              </a:rPr>
+              <a:t>hierarchical</a:t>
+            </a:r>
+            <a:r>
+              <a:rPr lang="de-DE" sz="2400" dirty="0">
+                <a:solidFill>
+                  <a:srgbClr val="0E0E0E"/>
+                </a:solidFill>
+                <a:effectLst/>
+                <a:latin typeface=".AppleSystemUIFont"/>
+              </a:rPr>
+              <a:t> </a:t>
+            </a:r>
+            <a:r>
+              <a:rPr lang="de-DE" sz="2400" dirty="0" err="1">
+                <a:solidFill>
+                  <a:srgbClr val="0E0E0E"/>
+                </a:solidFill>
+                <a:effectLst/>
+                <a:latin typeface=".AppleSystemUIFont"/>
+              </a:rPr>
+              <a:t>clustering</a:t>
+            </a:r>
+            <a:endParaRPr lang="de-DE" sz="2400" dirty="0">
+              <a:solidFill>
+                <a:srgbClr val="0E0E0E"/>
+              </a:solidFill>
+              <a:effectLst/>
+              <a:latin typeface=".AppleSystemUIFont"/>
+            </a:endParaRPr>
+          </a:p>
+        </p:txBody>
+      </p:sp>
     </p:spTree>
     <p:extLst>
       <p:ext uri="{BB962C8B-B14F-4D97-AF65-F5344CB8AC3E}">
@@ -16487,7 +16954,7 @@
           <a:p>
             <a:r>
               <a:rPr lang="de-DE" dirty="0"/>
-              <a:t>Core Points: </a:t>
+              <a:t>Core Point: </a:t>
             </a:r>
             <a:r>
               <a:rPr lang="de-DE" dirty="0" err="1"/>
@@ -16577,7 +17044,7 @@
           <a:p>
             <a:r>
               <a:rPr lang="de-DE" dirty="0"/>
-              <a:t>Border Points: </a:t>
+              <a:t>Border Point: </a:t>
             </a:r>
             <a:r>
               <a:rPr lang="de-DE" dirty="0" err="1"/>
@@ -16620,7 +17087,31 @@
             </a:r>
             <a:r>
               <a:rPr lang="de-DE" dirty="0"/>
-              <a:t>, but not </a:t>
+              <a:t>, but not a </a:t>
+            </a:r>
+            <a:r>
+              <a:rPr lang="de-DE" dirty="0" err="1"/>
+              <a:t>core</a:t>
+            </a:r>
+            <a:r>
+              <a:rPr lang="de-DE" dirty="0"/>
+              <a:t> </a:t>
+            </a:r>
+            <a:r>
+              <a:rPr lang="de-DE" dirty="0" err="1"/>
+              <a:t>point</a:t>
+            </a:r>
+            <a:r>
+              <a:rPr lang="de-DE" dirty="0"/>
+              <a:t> </a:t>
+            </a:r>
+            <a:r>
+              <a:rPr lang="de-DE" dirty="0" err="1"/>
+              <a:t>itself</a:t>
+            </a:r>
+            <a:r>
+              <a:rPr lang="de-DE" dirty="0"/>
+              <a:t> (not </a:t>
             </a:r>
             <a:r>
               <a:rPr lang="de-DE" dirty="0" err="1"/>
@@ -16636,15 +17127,7 @@
             </a:r>
             <a:r>
               <a:rPr lang="de-DE" dirty="0"/>
-              <a:t> </a:t>
-            </a:r>
-            <a:r>
-              <a:rPr lang="de-DE" dirty="0" err="1"/>
-              <a:t>themselves</a:t>
-            </a:r>
-            <a:r>
-              <a:rPr lang="de-DE" dirty="0"/>
-              <a:t> </a:t>
+              <a:t>) </a:t>
             </a:r>
             <a:r>
               <a:rPr lang="de-DE" dirty="0">
@@ -16693,7 +17176,7 @@
           <a:p>
             <a:r>
               <a:rPr lang="de-DE" dirty="0"/>
-              <a:t>Noise Points: not </a:t>
+              <a:t>Noise Point: not </a:t>
             </a:r>
             <a:r>
               <a:rPr lang="de-DE" dirty="0" err="1"/>
@@ -16757,7 +17240,7 @@
               <a:rPr lang="de-DE" dirty="0" err="1">
                 <a:sym typeface="Wingdings" pitchFamily="2" charset="2"/>
               </a:rPr>
-              <a:t>points</a:t>
+              <a:t>point</a:t>
             </a:r>
             <a:endParaRPr lang="de-DE" dirty="0"/>
           </a:p>
@@ -16855,432 +17338,1049 @@
           </a:p>
         </p:txBody>
       </p:sp>
-      <p:sp>
-        <p:nvSpPr>
-          <p:cNvPr id="3" name="Inhaltsplatzhalter 2">
-            <a:extLst>
-              <a:ext uri="{FF2B5EF4-FFF2-40B4-BE49-F238E27FC236}">
-                <a16:creationId xmlns:a16="http://schemas.microsoft.com/office/drawing/2014/main" id="{48293539-B5EA-4406-02DD-1F9D36FDC673}"/>
-              </a:ext>
-            </a:extLst>
-          </p:cNvPr>
-          <p:cNvSpPr>
-            <a:spLocks noGrp="1"/>
-          </p:cNvSpPr>
-          <p:nvPr>
-            <p:ph idx="1"/>
-          </p:nvPr>
-        </p:nvSpPr>
-        <p:spPr/>
-        <p:txBody>
-          <a:bodyPr>
-            <a:normAutofit fontScale="92500" lnSpcReduction="20000"/>
-          </a:bodyPr>
-          <a:lstStyle/>
-          <a:p>
-            <a:pPr marL="514350" indent="-514350">
-              <a:buFont typeface="+mj-lt"/>
-              <a:buAutoNum type="arabicPeriod"/>
-            </a:pPr>
-            <a:r>
-              <a:rPr lang="de-DE" dirty="0"/>
-              <a:t>Pick an </a:t>
-            </a:r>
-            <a:r>
-              <a:rPr lang="de-DE" dirty="0" err="1"/>
-              <a:t>unvisited</a:t>
-            </a:r>
-            <a:r>
-              <a:rPr lang="de-DE" dirty="0"/>
-              <a:t> </a:t>
-            </a:r>
-            <a:r>
-              <a:rPr lang="de-DE" dirty="0" err="1"/>
-              <a:t>point</a:t>
-            </a:r>
-            <a:endParaRPr lang="de-DE" dirty="0"/>
-          </a:p>
-          <a:p>
-            <a:pPr marL="514350" indent="-514350">
-              <a:buFont typeface="+mj-lt"/>
-              <a:buAutoNum type="arabicPeriod"/>
-            </a:pPr>
-            <a:r>
-              <a:rPr lang="de-DE" dirty="0"/>
-              <a:t>Check </a:t>
-            </a:r>
-            <a:r>
-              <a:rPr lang="de-DE" dirty="0" err="1"/>
-              <a:t>its</a:t>
-            </a:r>
-            <a:r>
-              <a:rPr lang="de-DE" dirty="0"/>
-              <a:t> </a:t>
-            </a:r>
-            <a:r>
-              <a:rPr lang="el-GR" dirty="0"/>
-              <a:t>ε-</a:t>
-            </a:r>
-            <a:r>
-              <a:rPr lang="de-DE" dirty="0" err="1"/>
-              <a:t>neighborhood</a:t>
-            </a:r>
-            <a:endParaRPr lang="de-DE" dirty="0"/>
-          </a:p>
-          <a:p>
-            <a:pPr marL="514350" indent="-514350">
-              <a:buFont typeface="+mj-lt"/>
-              <a:buAutoNum type="arabicPeriod"/>
-            </a:pPr>
-            <a:r>
-              <a:rPr lang="de-DE" dirty="0" err="1"/>
-              <a:t>If</a:t>
-            </a:r>
-            <a:r>
-              <a:rPr lang="de-DE" dirty="0"/>
-              <a:t> </a:t>
-            </a:r>
-            <a:r>
-              <a:rPr lang="de-DE" dirty="0" err="1"/>
-              <a:t>core</a:t>
-            </a:r>
-            <a:r>
-              <a:rPr lang="de-DE" dirty="0"/>
-              <a:t> </a:t>
-            </a:r>
-            <a:r>
-              <a:rPr lang="de-DE" dirty="0" err="1"/>
-              <a:t>point</a:t>
-            </a:r>
-            <a:r>
-              <a:rPr lang="de-DE" dirty="0"/>
-              <a:t>: </a:t>
-            </a:r>
-            <a:r>
-              <a:rPr lang="de-DE" dirty="0" err="1"/>
-              <a:t>create</a:t>
-            </a:r>
-            <a:r>
-              <a:rPr lang="de-DE" dirty="0"/>
-              <a:t> </a:t>
-            </a:r>
-            <a:r>
-              <a:rPr lang="de-DE" dirty="0" err="1"/>
-              <a:t>new</a:t>
-            </a:r>
-            <a:r>
-              <a:rPr lang="de-DE" dirty="0"/>
-              <a:t> </a:t>
-            </a:r>
-            <a:r>
-              <a:rPr lang="de-DE" dirty="0" err="1"/>
-              <a:t>cluster</a:t>
-            </a:r>
-            <a:r>
-              <a:rPr lang="de-DE" dirty="0"/>
-              <a:t>, </a:t>
-            </a:r>
-            <a:r>
-              <a:rPr lang="de-DE" dirty="0" err="1"/>
-              <a:t>expand</a:t>
-            </a:r>
-            <a:r>
-              <a:rPr lang="de-DE" dirty="0"/>
-              <a:t> </a:t>
-            </a:r>
-            <a:r>
-              <a:rPr lang="de-DE" dirty="0" err="1"/>
-              <a:t>cluster</a:t>
-            </a:r>
-            <a:r>
-              <a:rPr lang="de-DE" dirty="0"/>
-              <a:t> (</a:t>
-            </a:r>
-            <a:r>
-              <a:rPr lang="de-DE" dirty="0" err="1"/>
-              <a:t>density-reachable</a:t>
-            </a:r>
-            <a:r>
-              <a:rPr lang="de-DE" dirty="0"/>
-              <a:t> </a:t>
-            </a:r>
-            <a:r>
-              <a:rPr lang="de-DE" dirty="0" err="1"/>
-              <a:t>points</a:t>
-            </a:r>
-            <a:r>
-              <a:rPr lang="de-DE" dirty="0"/>
-              <a:t>)</a:t>
-            </a:r>
-          </a:p>
-          <a:p>
-            <a:pPr marL="514350" indent="-514350">
-              <a:buFont typeface="+mj-lt"/>
-              <a:buAutoNum type="arabicPeriod"/>
-            </a:pPr>
-            <a:r>
-              <a:rPr lang="de-DE" dirty="0" err="1"/>
-              <a:t>If</a:t>
-            </a:r>
-            <a:r>
-              <a:rPr lang="de-DE" dirty="0"/>
-              <a:t> not: </a:t>
-            </a:r>
-            <a:r>
-              <a:rPr lang="de-DE" dirty="0" err="1"/>
-              <a:t>mark</a:t>
-            </a:r>
-            <a:r>
-              <a:rPr lang="de-DE" dirty="0"/>
-              <a:t> </a:t>
-            </a:r>
-            <a:r>
-              <a:rPr lang="de-DE" dirty="0" err="1"/>
-              <a:t>as</a:t>
-            </a:r>
-            <a:r>
-              <a:rPr lang="de-DE" dirty="0"/>
-              <a:t> </a:t>
-            </a:r>
-            <a:r>
-              <a:rPr lang="de-DE" dirty="0" err="1"/>
-              <a:t>noise</a:t>
-            </a:r>
-            <a:r>
-              <a:rPr lang="de-DE" dirty="0"/>
-              <a:t> (</a:t>
-            </a:r>
-            <a:r>
-              <a:rPr lang="de-DE" dirty="0" err="1"/>
-              <a:t>may</a:t>
-            </a:r>
-            <a:r>
-              <a:rPr lang="de-DE" dirty="0"/>
-              <a:t> </a:t>
-            </a:r>
-            <a:r>
-              <a:rPr lang="de-DE" dirty="0" err="1"/>
-              <a:t>later</a:t>
-            </a:r>
-            <a:r>
-              <a:rPr lang="de-DE" dirty="0"/>
-              <a:t> </a:t>
-            </a:r>
-            <a:r>
-              <a:rPr lang="de-DE" dirty="0" err="1"/>
-              <a:t>become</a:t>
-            </a:r>
-            <a:r>
-              <a:rPr lang="de-DE" dirty="0"/>
-              <a:t> </a:t>
-            </a:r>
-            <a:r>
-              <a:rPr lang="de-DE" dirty="0" err="1"/>
-              <a:t>border</a:t>
-            </a:r>
-            <a:r>
-              <a:rPr lang="de-DE" dirty="0"/>
-              <a:t>)</a:t>
-            </a:r>
-          </a:p>
-          <a:p>
-            <a:pPr marL="514350" indent="-514350">
-              <a:buFont typeface="+mj-lt"/>
-              <a:buAutoNum type="arabicPeriod"/>
-            </a:pPr>
-            <a:r>
-              <a:rPr lang="de-DE" dirty="0"/>
-              <a:t>Repeat </a:t>
-            </a:r>
-            <a:r>
-              <a:rPr lang="de-DE" dirty="0" err="1"/>
-              <a:t>until</a:t>
-            </a:r>
-            <a:r>
-              <a:rPr lang="de-DE" dirty="0"/>
-              <a:t> all </a:t>
-            </a:r>
-            <a:r>
-              <a:rPr lang="de-DE" dirty="0" err="1"/>
-              <a:t>points</a:t>
-            </a:r>
-            <a:r>
-              <a:rPr lang="de-DE" dirty="0"/>
-              <a:t> </a:t>
-            </a:r>
-            <a:r>
-              <a:rPr lang="de-DE" dirty="0" err="1"/>
-              <a:t>processed</a:t>
-            </a:r>
-            <a:endParaRPr lang="de-DE" dirty="0"/>
-          </a:p>
-          <a:p>
-            <a:pPr marL="0" indent="0">
-              <a:buNone/>
-            </a:pPr>
-            <a:endParaRPr lang="de-DE" dirty="0"/>
-          </a:p>
-          <a:p>
-            <a:pPr marL="0" indent="0">
-              <a:buNone/>
-            </a:pPr>
-            <a:r>
-              <a:rPr lang="de-DE" dirty="0"/>
-              <a:t>Cluster </a:t>
-            </a:r>
-            <a:r>
-              <a:rPr lang="de-DE" dirty="0" err="1"/>
-              <a:t>formation</a:t>
-            </a:r>
-            <a:r>
-              <a:rPr lang="de-DE" dirty="0"/>
-              <a:t> </a:t>
-            </a:r>
-            <a:r>
-              <a:rPr lang="de-DE" dirty="0" err="1"/>
-              <a:t>concept</a:t>
-            </a:r>
-            <a:r>
-              <a:rPr lang="de-DE" dirty="0"/>
-              <a:t>:</a:t>
-            </a:r>
-          </a:p>
-          <a:p>
-            <a:r>
-              <a:rPr lang="de-DE" dirty="0"/>
-              <a:t>Points </a:t>
-            </a:r>
-            <a:r>
-              <a:rPr lang="de-DE" dirty="0" err="1"/>
-              <a:t>are</a:t>
-            </a:r>
-            <a:r>
-              <a:rPr lang="de-DE" dirty="0"/>
-              <a:t> </a:t>
-            </a:r>
-            <a:r>
-              <a:rPr lang="de-DE" dirty="0" err="1"/>
-              <a:t>density-connected</a:t>
-            </a:r>
-            <a:r>
-              <a:rPr lang="de-DE" dirty="0"/>
-              <a:t> </a:t>
-            </a:r>
-            <a:r>
-              <a:rPr lang="de-DE" dirty="0" err="1"/>
-              <a:t>if</a:t>
-            </a:r>
-            <a:r>
-              <a:rPr lang="de-DE" dirty="0"/>
-              <a:t> </a:t>
-            </a:r>
-            <a:r>
-              <a:rPr lang="de-DE" dirty="0" err="1"/>
-              <a:t>they</a:t>
-            </a:r>
-            <a:r>
-              <a:rPr lang="de-DE" dirty="0"/>
-              <a:t> </a:t>
-            </a:r>
-            <a:r>
-              <a:rPr lang="de-DE" dirty="0" err="1"/>
-              <a:t>can</a:t>
-            </a:r>
-            <a:r>
-              <a:rPr lang="de-DE" dirty="0"/>
-              <a:t> </a:t>
-            </a:r>
-            <a:r>
-              <a:rPr lang="de-DE" dirty="0" err="1"/>
-              <a:t>be</a:t>
-            </a:r>
-            <a:r>
-              <a:rPr lang="de-DE" dirty="0"/>
-              <a:t> </a:t>
-            </a:r>
-            <a:r>
-              <a:rPr lang="de-DE" dirty="0" err="1"/>
-              <a:t>reached</a:t>
-            </a:r>
-            <a:r>
-              <a:rPr lang="de-DE" dirty="0"/>
-              <a:t> via a </a:t>
-            </a:r>
-            <a:r>
-              <a:rPr lang="de-DE" dirty="0" err="1"/>
-              <a:t>chain</a:t>
-            </a:r>
-            <a:r>
-              <a:rPr lang="de-DE" dirty="0"/>
-              <a:t> </a:t>
-            </a:r>
-            <a:r>
-              <a:rPr lang="de-DE" dirty="0" err="1"/>
-              <a:t>of</a:t>
-            </a:r>
-            <a:r>
-              <a:rPr lang="de-DE" dirty="0"/>
-              <a:t> </a:t>
-            </a:r>
-            <a:r>
-              <a:rPr lang="de-DE" dirty="0" err="1"/>
-              <a:t>core</a:t>
-            </a:r>
-            <a:r>
-              <a:rPr lang="de-DE" dirty="0"/>
-              <a:t> </a:t>
-            </a:r>
-            <a:r>
-              <a:rPr lang="de-DE" dirty="0" err="1"/>
-              <a:t>points</a:t>
-            </a:r>
-            <a:endParaRPr lang="de-DE" dirty="0"/>
-          </a:p>
-          <a:p>
-            <a:r>
-              <a:rPr lang="de-DE" dirty="0"/>
-              <a:t>Clusters </a:t>
-            </a:r>
-            <a:r>
-              <a:rPr lang="de-DE" dirty="0" err="1"/>
-              <a:t>grow</a:t>
-            </a:r>
-            <a:r>
-              <a:rPr lang="de-DE" dirty="0"/>
-              <a:t> </a:t>
-            </a:r>
-            <a:r>
-              <a:rPr lang="de-DE" dirty="0" err="1"/>
-              <a:t>outward</a:t>
-            </a:r>
-            <a:r>
-              <a:rPr lang="de-DE" dirty="0"/>
-              <a:t> </a:t>
-            </a:r>
-            <a:r>
-              <a:rPr lang="de-DE" dirty="0" err="1"/>
-              <a:t>from</a:t>
-            </a:r>
-            <a:r>
-              <a:rPr lang="de-DE" dirty="0"/>
-              <a:t> </a:t>
-            </a:r>
-            <a:r>
-              <a:rPr lang="de-DE" dirty="0" err="1"/>
-              <a:t>core</a:t>
-            </a:r>
-            <a:r>
-              <a:rPr lang="de-DE" dirty="0"/>
-              <a:t> </a:t>
-            </a:r>
-            <a:r>
-              <a:rPr lang="de-DE" dirty="0" err="1"/>
-              <a:t>points</a:t>
-            </a:r>
-            <a:endParaRPr lang="de-DE" dirty="0"/>
-          </a:p>
-        </p:txBody>
-      </p:sp>
+      <mc:AlternateContent xmlns:mc="http://schemas.openxmlformats.org/markup-compatibility/2006">
+        <mc:Choice xmlns:a14="http://schemas.microsoft.com/office/drawing/2010/main" Requires="a14">
+          <p:sp>
+            <p:nvSpPr>
+              <p:cNvPr id="3" name="Inhaltsplatzhalter 2">
+                <a:extLst>
+                  <a:ext uri="{FF2B5EF4-FFF2-40B4-BE49-F238E27FC236}">
+                    <a16:creationId xmlns:a16="http://schemas.microsoft.com/office/drawing/2014/main" id="{48293539-B5EA-4406-02DD-1F9D36FDC673}"/>
+                  </a:ext>
+                </a:extLst>
+              </p:cNvPr>
+              <p:cNvSpPr>
+                <a:spLocks noGrp="1"/>
+              </p:cNvSpPr>
+              <p:nvPr>
+                <p:ph idx="1"/>
+              </p:nvPr>
+            </p:nvSpPr>
+            <p:spPr/>
+            <p:txBody>
+              <a:bodyPr>
+                <a:normAutofit fontScale="70000" lnSpcReduction="20000"/>
+              </a:bodyPr>
+              <a:lstStyle/>
+              <a:p>
+                <a:pPr marL="514350" indent="-514350">
+                  <a:buFont typeface="+mj-lt"/>
+                  <a:buAutoNum type="arabicPeriod"/>
+                </a:pPr>
+                <a:r>
+                  <a:rPr lang="de-DE" dirty="0"/>
+                  <a:t>Pick an </a:t>
+                </a:r>
+                <a:r>
+                  <a:rPr lang="de-DE" dirty="0" err="1"/>
+                  <a:t>unvisited</a:t>
+                </a:r>
+                <a:r>
+                  <a:rPr lang="de-DE" dirty="0"/>
+                  <a:t> </a:t>
+                </a:r>
+                <a:r>
+                  <a:rPr lang="de-DE" dirty="0" err="1"/>
+                  <a:t>point</a:t>
+                </a:r>
+                <a:r>
+                  <a:rPr lang="de-DE" dirty="0"/>
+                  <a:t> </a:t>
+                </a:r>
+                <a:r>
+                  <a:rPr lang="de-DE" i="1" dirty="0">
+                    <a:latin typeface="Cambria Math" panose="02040503050406030204" pitchFamily="18" charset="0"/>
+                    <a:ea typeface="Cambria Math" panose="02040503050406030204" pitchFamily="18" charset="0"/>
+                  </a:rPr>
+                  <a:t>P</a:t>
+                </a:r>
+                <a:r>
+                  <a:rPr lang="de-DE" dirty="0"/>
+                  <a:t> and </a:t>
+                </a:r>
+                <a:r>
+                  <a:rPr lang="de-DE" dirty="0" err="1"/>
+                  <a:t>mark</a:t>
+                </a:r>
+                <a:r>
+                  <a:rPr lang="de-DE" dirty="0"/>
+                  <a:t> </a:t>
+                </a:r>
+                <a:r>
+                  <a:rPr lang="de-DE" dirty="0" err="1"/>
+                  <a:t>it</a:t>
+                </a:r>
+                <a:r>
+                  <a:rPr lang="de-DE" dirty="0"/>
+                  <a:t> </a:t>
+                </a:r>
+                <a:r>
+                  <a:rPr lang="de-DE" dirty="0" err="1"/>
+                  <a:t>as</a:t>
+                </a:r>
+                <a:r>
+                  <a:rPr lang="de-DE" dirty="0"/>
+                  <a:t> </a:t>
+                </a:r>
+                <a:r>
+                  <a:rPr lang="de-DE" dirty="0" err="1"/>
+                  <a:t>visited</a:t>
+                </a:r>
+                <a:endParaRPr lang="de-DE" dirty="0"/>
+              </a:p>
+              <a:p>
+                <a:pPr marL="514350" indent="-514350">
+                  <a:buFont typeface="+mj-lt"/>
+                  <a:buAutoNum type="arabicPeriod"/>
+                </a:pPr>
+                <a:r>
+                  <a:rPr lang="de-DE" dirty="0" err="1"/>
+                  <a:t>Retrieve</a:t>
+                </a:r>
+                <a:r>
+                  <a:rPr lang="de-DE" dirty="0"/>
+                  <a:t> </a:t>
+                </a:r>
+                <a:r>
+                  <a:rPr lang="de-DE" dirty="0" err="1"/>
+                  <a:t>its</a:t>
+                </a:r>
+                <a:r>
+                  <a:rPr lang="de-DE" dirty="0"/>
+                  <a:t> </a:t>
+                </a:r>
+                <a:r>
+                  <a:rPr lang="el-GR" dirty="0">
+                    <a:latin typeface="Cambria Math" panose="02040503050406030204" pitchFamily="18" charset="0"/>
+                    <a:ea typeface="Cambria Math" panose="02040503050406030204" pitchFamily="18" charset="0"/>
+                  </a:rPr>
+                  <a:t>ε</a:t>
+                </a:r>
+                <a:r>
+                  <a:rPr lang="el-GR" dirty="0"/>
+                  <a:t>-</a:t>
+                </a:r>
+                <a:r>
+                  <a:rPr lang="de-DE" dirty="0" err="1"/>
+                  <a:t>neighborhood</a:t>
+                </a:r>
+                <a:r>
+                  <a:rPr lang="de-DE" dirty="0"/>
+                  <a:t> </a:t>
+                </a:r>
+                <a14:m>
+                  <m:oMath xmlns:m="http://schemas.openxmlformats.org/officeDocument/2006/math">
+                    <m:sSub>
+                      <m:sSubPr>
+                        <m:ctrlPr>
+                          <a:rPr lang="de-DE" i="1">
+                            <a:latin typeface="Cambria Math" panose="02040503050406030204" pitchFamily="18" charset="0"/>
+                          </a:rPr>
+                        </m:ctrlPr>
+                      </m:sSubPr>
+                      <m:e>
+                        <m:r>
+                          <a:rPr lang="de-DE" i="1">
+                            <a:latin typeface="Cambria Math" panose="02040503050406030204" pitchFamily="18" charset="0"/>
+                          </a:rPr>
+                          <m:t>𝑁</m:t>
+                        </m:r>
+                      </m:e>
+                      <m:sub>
+                        <m:r>
+                          <m:rPr>
+                            <m:nor/>
+                          </m:rPr>
+                          <a:rPr lang="el-GR" dirty="0">
+                            <a:latin typeface="Cambria Math" panose="02040503050406030204" pitchFamily="18" charset="0"/>
+                            <a:ea typeface="Cambria Math" panose="02040503050406030204" pitchFamily="18" charset="0"/>
+                          </a:rPr>
+                          <m:t>ε</m:t>
+                        </m:r>
+                      </m:sub>
+                    </m:sSub>
+                    <m:r>
+                      <a:rPr lang="de-DE" i="1">
+                        <a:latin typeface="Cambria Math" panose="02040503050406030204" pitchFamily="18" charset="0"/>
+                      </a:rPr>
+                      <m:t>(</m:t>
+                    </m:r>
+                    <m:r>
+                      <a:rPr lang="de-DE" i="1">
+                        <a:latin typeface="Cambria Math" panose="02040503050406030204" pitchFamily="18" charset="0"/>
+                      </a:rPr>
+                      <m:t>𝑃</m:t>
+                    </m:r>
+                    <m:r>
+                      <a:rPr lang="de-DE" i="1">
+                        <a:latin typeface="Cambria Math" panose="02040503050406030204" pitchFamily="18" charset="0"/>
+                      </a:rPr>
+                      <m:t>)</m:t>
+                    </m:r>
+                  </m:oMath>
+                </a14:m>
+                <a:endParaRPr lang="de-DE" dirty="0"/>
+              </a:p>
+              <a:p>
+                <a:pPr marL="514350" indent="-514350">
+                  <a:buFont typeface="+mj-lt"/>
+                  <a:buAutoNum type="arabicPeriod"/>
+                </a:pPr>
+                <a:r>
+                  <a:rPr lang="de-DE" dirty="0" err="1"/>
+                  <a:t>If</a:t>
+                </a:r>
+                <a:r>
+                  <a:rPr lang="de-DE" dirty="0"/>
+                  <a:t> </a:t>
+                </a:r>
+                <a:r>
+                  <a:rPr lang="de-DE" i="1" dirty="0">
+                    <a:latin typeface="Cambria Math" panose="02040503050406030204" pitchFamily="18" charset="0"/>
+                    <a:ea typeface="Cambria Math" panose="02040503050406030204" pitchFamily="18" charset="0"/>
+                  </a:rPr>
+                  <a:t>P </a:t>
+                </a:r>
+                <a:r>
+                  <a:rPr lang="de-DE" dirty="0"/>
+                  <a:t> </a:t>
+                </a:r>
+                <a:r>
+                  <a:rPr lang="de-DE" dirty="0" err="1"/>
+                  <a:t>is</a:t>
+                </a:r>
+                <a:r>
+                  <a:rPr lang="de-DE" dirty="0"/>
+                  <a:t> a </a:t>
+                </a:r>
+                <a:r>
+                  <a:rPr lang="de-DE" dirty="0" err="1"/>
+                  <a:t>core</a:t>
+                </a:r>
+                <a:r>
+                  <a:rPr lang="de-DE" dirty="0"/>
+                  <a:t> </a:t>
+                </a:r>
+                <a:r>
+                  <a:rPr lang="de-DE" dirty="0" err="1"/>
+                  <a:t>point</a:t>
+                </a:r>
+                <a:r>
+                  <a:rPr lang="de-DE" dirty="0"/>
+                  <a:t>:</a:t>
+                </a:r>
+              </a:p>
+              <a:p>
+                <a:pPr lvl="1"/>
+                <a:r>
+                  <a:rPr lang="de-DE" dirty="0"/>
+                  <a:t>Create a </a:t>
+                </a:r>
+                <a:r>
+                  <a:rPr lang="de-DE" dirty="0" err="1"/>
+                  <a:t>new</a:t>
+                </a:r>
+                <a:r>
+                  <a:rPr lang="de-DE" dirty="0"/>
+                  <a:t> </a:t>
+                </a:r>
+                <a:r>
+                  <a:rPr lang="de-DE" dirty="0" err="1"/>
+                  <a:t>cluster</a:t>
+                </a:r>
+                <a:r>
+                  <a:rPr lang="de-DE" dirty="0"/>
+                  <a:t> and </a:t>
+                </a:r>
+                <a:r>
+                  <a:rPr lang="de-DE" dirty="0" err="1"/>
+                  <a:t>add</a:t>
+                </a:r>
+                <a:r>
+                  <a:rPr lang="de-DE" dirty="0"/>
+                  <a:t> </a:t>
+                </a:r>
+                <a:r>
+                  <a:rPr lang="de-DE" i="1" dirty="0">
+                    <a:latin typeface="Cambria Math" panose="02040503050406030204" pitchFamily="18" charset="0"/>
+                    <a:ea typeface="Cambria Math" panose="02040503050406030204" pitchFamily="18" charset="0"/>
+                  </a:rPr>
+                  <a:t>P</a:t>
+                </a:r>
+                <a:r>
+                  <a:rPr lang="de-DE" dirty="0"/>
+                  <a:t> and all </a:t>
+                </a:r>
+                <a:r>
+                  <a:rPr lang="de-DE" dirty="0" err="1"/>
+                  <a:t>points</a:t>
+                </a:r>
+                <a:r>
+                  <a:rPr lang="de-DE" dirty="0"/>
+                  <a:t> in </a:t>
+                </a:r>
+                <a14:m>
+                  <m:oMath xmlns:m="http://schemas.openxmlformats.org/officeDocument/2006/math">
+                    <m:sSub>
+                      <m:sSubPr>
+                        <m:ctrlPr>
+                          <a:rPr lang="de-DE" i="1">
+                            <a:latin typeface="Cambria Math" panose="02040503050406030204" pitchFamily="18" charset="0"/>
+                          </a:rPr>
+                        </m:ctrlPr>
+                      </m:sSubPr>
+                      <m:e>
+                        <m:r>
+                          <a:rPr lang="de-DE" i="1">
+                            <a:latin typeface="Cambria Math" panose="02040503050406030204" pitchFamily="18" charset="0"/>
+                          </a:rPr>
+                          <m:t>𝑁</m:t>
+                        </m:r>
+                      </m:e>
+                      <m:sub>
+                        <m:r>
+                          <m:rPr>
+                            <m:nor/>
+                          </m:rPr>
+                          <a:rPr lang="el-GR" dirty="0">
+                            <a:latin typeface="Cambria Math" panose="02040503050406030204" pitchFamily="18" charset="0"/>
+                            <a:ea typeface="Cambria Math" panose="02040503050406030204" pitchFamily="18" charset="0"/>
+                          </a:rPr>
+                          <m:t>ε</m:t>
+                        </m:r>
+                      </m:sub>
+                    </m:sSub>
+                    <m:r>
+                      <a:rPr lang="de-DE" i="1">
+                        <a:latin typeface="Cambria Math" panose="02040503050406030204" pitchFamily="18" charset="0"/>
+                      </a:rPr>
+                      <m:t>(</m:t>
+                    </m:r>
+                    <m:r>
+                      <a:rPr lang="de-DE" i="1">
+                        <a:latin typeface="Cambria Math" panose="02040503050406030204" pitchFamily="18" charset="0"/>
+                      </a:rPr>
+                      <m:t>𝑃</m:t>
+                    </m:r>
+                    <m:r>
+                      <a:rPr lang="de-DE" i="1" smtClean="0">
+                        <a:latin typeface="Cambria Math" panose="02040503050406030204" pitchFamily="18" charset="0"/>
+                      </a:rPr>
+                      <m:t>)</m:t>
+                    </m:r>
+                  </m:oMath>
+                </a14:m>
+                <a:r>
+                  <a:rPr lang="de-DE" dirty="0"/>
+                  <a:t> </a:t>
+                </a:r>
+                <a:r>
+                  <a:rPr lang="de-DE" dirty="0" err="1"/>
+                  <a:t>to</a:t>
+                </a:r>
+                <a:r>
+                  <a:rPr lang="de-DE" dirty="0"/>
+                  <a:t> </a:t>
+                </a:r>
+                <a:r>
+                  <a:rPr lang="de-DE" dirty="0" err="1"/>
+                  <a:t>it</a:t>
+                </a:r>
+                <a:r>
+                  <a:rPr lang="de-DE" dirty="0"/>
+                  <a:t> (</a:t>
+                </a:r>
+                <a:r>
+                  <a:rPr lang="de-DE" dirty="0" err="1"/>
+                  <a:t>that</a:t>
+                </a:r>
+                <a:r>
+                  <a:rPr lang="de-DE" dirty="0"/>
+                  <a:t> </a:t>
+                </a:r>
+                <a:r>
+                  <a:rPr lang="de-DE" dirty="0" err="1"/>
+                  <a:t>are</a:t>
+                </a:r>
+                <a:r>
+                  <a:rPr lang="de-DE" dirty="0"/>
+                  <a:t> not </a:t>
+                </a:r>
+                <a:r>
+                  <a:rPr lang="de-DE" dirty="0" err="1"/>
+                  <a:t>yet</a:t>
+                </a:r>
+                <a:r>
+                  <a:rPr lang="de-DE" dirty="0"/>
+                  <a:t> </a:t>
+                </a:r>
+                <a:r>
+                  <a:rPr lang="de-DE" dirty="0" err="1"/>
+                  <a:t>assigned</a:t>
+                </a:r>
+                <a:r>
+                  <a:rPr lang="de-DE" dirty="0"/>
+                  <a:t> </a:t>
+                </a:r>
+                <a:r>
+                  <a:rPr lang="de-DE" dirty="0" err="1"/>
+                  <a:t>to</a:t>
+                </a:r>
+                <a:r>
+                  <a:rPr lang="de-DE" dirty="0"/>
+                  <a:t> </a:t>
+                </a:r>
+                <a:r>
+                  <a:rPr lang="de-DE" dirty="0" err="1"/>
+                  <a:t>any</a:t>
+                </a:r>
+                <a:r>
+                  <a:rPr lang="de-DE" dirty="0"/>
+                  <a:t> </a:t>
+                </a:r>
+                <a:r>
+                  <a:rPr lang="de-DE" dirty="0" err="1"/>
+                  <a:t>cluster</a:t>
+                </a:r>
+                <a:r>
+                  <a:rPr lang="de-DE" dirty="0"/>
+                  <a:t>)</a:t>
+                </a:r>
+              </a:p>
+              <a:p>
+                <a:pPr lvl="1"/>
+                <a:r>
+                  <a:rPr lang="de-DE" dirty="0" err="1"/>
+                  <a:t>For</a:t>
+                </a:r>
+                <a:r>
+                  <a:rPr lang="de-DE" dirty="0"/>
+                  <a:t> </a:t>
+                </a:r>
+                <a:r>
+                  <a:rPr lang="de-DE" dirty="0" err="1"/>
+                  <a:t>each</a:t>
+                </a:r>
+                <a:r>
+                  <a:rPr lang="de-DE" dirty="0"/>
+                  <a:t> </a:t>
+                </a:r>
+                <a:r>
+                  <a:rPr lang="de-DE" dirty="0" err="1"/>
+                  <a:t>point</a:t>
+                </a:r>
+                <a:r>
+                  <a:rPr lang="de-DE" dirty="0"/>
+                  <a:t> </a:t>
+                </a:r>
+                <a:r>
+                  <a:rPr lang="de-DE" i="1" dirty="0">
+                    <a:latin typeface="Cambria Math" panose="02040503050406030204" pitchFamily="18" charset="0"/>
+                    <a:ea typeface="Cambria Math" panose="02040503050406030204" pitchFamily="18" charset="0"/>
+                  </a:rPr>
+                  <a:t>Q</a:t>
+                </a:r>
+                <a:r>
+                  <a:rPr lang="de-DE" dirty="0"/>
+                  <a:t> in </a:t>
+                </a:r>
+                <a14:m>
+                  <m:oMath xmlns:m="http://schemas.openxmlformats.org/officeDocument/2006/math">
+                    <m:sSub>
+                      <m:sSubPr>
+                        <m:ctrlPr>
+                          <a:rPr lang="de-DE" i="1" smtClean="0">
+                            <a:latin typeface="Cambria Math" panose="02040503050406030204" pitchFamily="18" charset="0"/>
+                          </a:rPr>
+                        </m:ctrlPr>
+                      </m:sSubPr>
+                      <m:e>
+                        <m:r>
+                          <a:rPr lang="de-DE" b="0" i="1" smtClean="0">
+                            <a:latin typeface="Cambria Math" panose="02040503050406030204" pitchFamily="18" charset="0"/>
+                          </a:rPr>
+                          <m:t>𝑁</m:t>
+                        </m:r>
+                      </m:e>
+                      <m:sub>
+                        <m:r>
+                          <m:rPr>
+                            <m:nor/>
+                          </m:rPr>
+                          <a:rPr lang="el-GR" dirty="0">
+                            <a:latin typeface="Cambria Math" panose="02040503050406030204" pitchFamily="18" charset="0"/>
+                            <a:ea typeface="Cambria Math" panose="02040503050406030204" pitchFamily="18" charset="0"/>
+                          </a:rPr>
+                          <m:t>ε</m:t>
+                        </m:r>
+                      </m:sub>
+                    </m:sSub>
+                    <m:r>
+                      <a:rPr lang="de-DE" b="0" i="1" smtClean="0">
+                        <a:latin typeface="Cambria Math" panose="02040503050406030204" pitchFamily="18" charset="0"/>
+                      </a:rPr>
+                      <m:t>(</m:t>
+                    </m:r>
+                    <m:r>
+                      <a:rPr lang="de-DE" b="0" i="1" smtClean="0">
+                        <a:latin typeface="Cambria Math" panose="02040503050406030204" pitchFamily="18" charset="0"/>
+                      </a:rPr>
+                      <m:t>𝑃</m:t>
+                    </m:r>
+                    <m:r>
+                      <a:rPr lang="de-DE" b="0" i="1" smtClean="0">
+                        <a:latin typeface="Cambria Math" panose="02040503050406030204" pitchFamily="18" charset="0"/>
+                      </a:rPr>
+                      <m:t>)</m:t>
+                    </m:r>
+                  </m:oMath>
+                </a14:m>
+                <a:r>
+                  <a:rPr lang="de-DE" dirty="0"/>
+                  <a:t>:</a:t>
+                </a:r>
+              </a:p>
+              <a:p>
+                <a:pPr lvl="2"/>
+                <a:r>
+                  <a:rPr lang="de-DE" dirty="0"/>
+                  <a:t>Mark </a:t>
+                </a:r>
+                <a:r>
+                  <a:rPr lang="de-DE" dirty="0" err="1"/>
+                  <a:t>as</a:t>
+                </a:r>
+                <a:r>
+                  <a:rPr lang="de-DE" dirty="0"/>
+                  <a:t> </a:t>
+                </a:r>
+                <a:r>
+                  <a:rPr lang="de-DE" dirty="0" err="1"/>
+                  <a:t>visited</a:t>
+                </a:r>
+                <a:r>
+                  <a:rPr lang="de-DE" dirty="0"/>
+                  <a:t> (</a:t>
+                </a:r>
+                <a:r>
+                  <a:rPr lang="de-DE" dirty="0" err="1"/>
+                  <a:t>if</a:t>
+                </a:r>
+                <a:r>
+                  <a:rPr lang="de-DE" dirty="0"/>
+                  <a:t> </a:t>
+                </a:r>
+                <a:r>
+                  <a:rPr lang="de-DE" dirty="0" err="1"/>
+                  <a:t>unvisited</a:t>
+                </a:r>
+                <a:r>
+                  <a:rPr lang="de-DE" dirty="0"/>
+                  <a:t>) and </a:t>
+                </a:r>
+                <a:r>
+                  <a:rPr lang="de-DE" dirty="0" err="1"/>
+                  <a:t>retrieve</a:t>
+                </a:r>
+                <a:r>
+                  <a:rPr lang="de-DE" dirty="0"/>
+                  <a:t> </a:t>
+                </a:r>
+                <a14:m>
+                  <m:oMath xmlns:m="http://schemas.openxmlformats.org/officeDocument/2006/math">
+                    <m:sSub>
+                      <m:sSubPr>
+                        <m:ctrlPr>
+                          <a:rPr lang="de-DE" i="1">
+                            <a:latin typeface="Cambria Math" panose="02040503050406030204" pitchFamily="18" charset="0"/>
+                          </a:rPr>
+                        </m:ctrlPr>
+                      </m:sSubPr>
+                      <m:e>
+                        <m:r>
+                          <a:rPr lang="de-DE" i="1">
+                            <a:latin typeface="Cambria Math" panose="02040503050406030204" pitchFamily="18" charset="0"/>
+                          </a:rPr>
+                          <m:t>𝑁</m:t>
+                        </m:r>
+                      </m:e>
+                      <m:sub>
+                        <m:r>
+                          <m:rPr>
+                            <m:nor/>
+                          </m:rPr>
+                          <a:rPr lang="el-GR" dirty="0">
+                            <a:latin typeface="Cambria Math" panose="02040503050406030204" pitchFamily="18" charset="0"/>
+                            <a:ea typeface="Cambria Math" panose="02040503050406030204" pitchFamily="18" charset="0"/>
+                          </a:rPr>
+                          <m:t>ε</m:t>
+                        </m:r>
+                      </m:sub>
+                    </m:sSub>
+                    <m:r>
+                      <a:rPr lang="de-DE" i="1">
+                        <a:latin typeface="Cambria Math" panose="02040503050406030204" pitchFamily="18" charset="0"/>
+                      </a:rPr>
+                      <m:t>(</m:t>
+                    </m:r>
+                    <m:r>
+                      <a:rPr lang="de-DE" b="0" i="1" smtClean="0">
+                        <a:latin typeface="Cambria Math" panose="02040503050406030204" pitchFamily="18" charset="0"/>
+                      </a:rPr>
+                      <m:t>𝑄</m:t>
+                    </m:r>
+                    <m:r>
+                      <a:rPr lang="de-DE" i="1">
+                        <a:latin typeface="Cambria Math" panose="02040503050406030204" pitchFamily="18" charset="0"/>
+                      </a:rPr>
+                      <m:t>)</m:t>
+                    </m:r>
+                  </m:oMath>
+                </a14:m>
+                <a:endParaRPr lang="de-DE" dirty="0"/>
+              </a:p>
+              <a:p>
+                <a:pPr lvl="2"/>
+                <a:r>
+                  <a:rPr lang="de-DE" dirty="0" err="1"/>
+                  <a:t>If</a:t>
+                </a:r>
+                <a:r>
+                  <a:rPr lang="de-DE" dirty="0"/>
+                  <a:t> </a:t>
+                </a:r>
+                <a:r>
+                  <a:rPr lang="de-DE" i="1" dirty="0">
+                    <a:latin typeface="Cambria Math" panose="02040503050406030204" pitchFamily="18" charset="0"/>
+                    <a:ea typeface="Cambria Math" panose="02040503050406030204" pitchFamily="18" charset="0"/>
+                  </a:rPr>
+                  <a:t>Q</a:t>
+                </a:r>
+                <a:r>
+                  <a:rPr lang="de-DE" dirty="0"/>
+                  <a:t> </a:t>
+                </a:r>
+                <a:r>
+                  <a:rPr lang="de-DE" dirty="0" err="1"/>
+                  <a:t>is</a:t>
+                </a:r>
+                <a:r>
+                  <a:rPr lang="de-DE" dirty="0"/>
+                  <a:t> a </a:t>
+                </a:r>
+                <a:r>
+                  <a:rPr lang="de-DE" dirty="0" err="1"/>
+                  <a:t>core</a:t>
+                </a:r>
+                <a:r>
+                  <a:rPr lang="de-DE" dirty="0"/>
+                  <a:t> </a:t>
+                </a:r>
+                <a:r>
+                  <a:rPr lang="de-DE" dirty="0" err="1"/>
+                  <a:t>core</a:t>
+                </a:r>
+                <a:r>
+                  <a:rPr lang="de-DE" dirty="0"/>
+                  <a:t> </a:t>
+                </a:r>
+                <a:r>
+                  <a:rPr lang="de-DE" dirty="0" err="1"/>
+                  <a:t>point</a:t>
+                </a:r>
+                <a:r>
+                  <a:rPr lang="de-DE" dirty="0"/>
+                  <a:t>: </a:t>
+                </a:r>
+                <a:r>
+                  <a:rPr lang="de-DE" dirty="0" err="1"/>
+                  <a:t>iteratively</a:t>
+                </a:r>
+                <a:r>
+                  <a:rPr lang="de-DE" dirty="0"/>
+                  <a:t> </a:t>
+                </a:r>
+                <a:r>
+                  <a:rPr lang="de-DE" dirty="0" err="1"/>
+                  <a:t>expand</a:t>
+                </a:r>
+                <a:r>
+                  <a:rPr lang="de-DE" dirty="0"/>
+                  <a:t> </a:t>
+                </a:r>
+                <a:r>
+                  <a:rPr lang="de-DE" dirty="0" err="1"/>
+                  <a:t>the</a:t>
+                </a:r>
+                <a:r>
+                  <a:rPr lang="de-DE" dirty="0"/>
+                  <a:t> </a:t>
+                </a:r>
+                <a:r>
+                  <a:rPr lang="de-DE" dirty="0" err="1"/>
+                  <a:t>cluster</a:t>
+                </a:r>
+                <a:r>
+                  <a:rPr lang="de-DE" dirty="0"/>
+                  <a:t> (</a:t>
+                </a:r>
+                <a:r>
+                  <a:rPr lang="de-DE" dirty="0" err="1"/>
+                  <a:t>density-reachable</a:t>
+                </a:r>
+                <a:r>
+                  <a:rPr lang="de-DE" dirty="0"/>
+                  <a:t> </a:t>
+                </a:r>
+                <a:r>
+                  <a:rPr lang="de-DE" dirty="0" err="1"/>
+                  <a:t>points</a:t>
+                </a:r>
+                <a:r>
+                  <a:rPr lang="de-DE" dirty="0"/>
+                  <a:t>)</a:t>
+                </a:r>
+              </a:p>
+              <a:p>
+                <a:pPr marL="514350" indent="-514350">
+                  <a:buFont typeface="+mj-lt"/>
+                  <a:buAutoNum type="arabicPeriod"/>
+                </a:pPr>
+                <a:r>
+                  <a:rPr lang="de-DE" dirty="0"/>
+                  <a:t>Else: </a:t>
+                </a:r>
+                <a:r>
+                  <a:rPr lang="de-DE" dirty="0" err="1"/>
+                  <a:t>mark</a:t>
+                </a:r>
+                <a:r>
+                  <a:rPr lang="de-DE" dirty="0"/>
+                  <a:t> </a:t>
+                </a:r>
+                <a:r>
+                  <a:rPr lang="de-DE" i="1" dirty="0">
+                    <a:latin typeface="Cambria Math" panose="02040503050406030204" pitchFamily="18" charset="0"/>
+                    <a:ea typeface="Cambria Math" panose="02040503050406030204" pitchFamily="18" charset="0"/>
+                  </a:rPr>
+                  <a:t>P </a:t>
+                </a:r>
+                <a:r>
+                  <a:rPr lang="de-DE" dirty="0"/>
+                  <a:t> </a:t>
+                </a:r>
+                <a:r>
+                  <a:rPr lang="de-DE" dirty="0" err="1"/>
+                  <a:t>as</a:t>
+                </a:r>
+                <a:r>
+                  <a:rPr lang="de-DE" dirty="0"/>
+                  <a:t> </a:t>
+                </a:r>
+                <a:r>
+                  <a:rPr lang="de-DE" dirty="0" err="1"/>
+                  <a:t>noise</a:t>
+                </a:r>
+                <a:r>
+                  <a:rPr lang="de-DE" dirty="0"/>
+                  <a:t> (</a:t>
+                </a:r>
+                <a:r>
+                  <a:rPr lang="de-DE" dirty="0" err="1"/>
+                  <a:t>temporary</a:t>
+                </a:r>
+                <a:r>
+                  <a:rPr lang="de-DE" dirty="0"/>
+                  <a:t>, </a:t>
+                </a:r>
+                <a:r>
+                  <a:rPr lang="de-DE" dirty="0" err="1"/>
+                  <a:t>may</a:t>
+                </a:r>
+                <a:r>
+                  <a:rPr lang="de-DE" dirty="0"/>
+                  <a:t> </a:t>
+                </a:r>
+                <a:r>
+                  <a:rPr lang="de-DE" dirty="0" err="1"/>
+                  <a:t>later</a:t>
+                </a:r>
+                <a:r>
+                  <a:rPr lang="de-DE" dirty="0"/>
+                  <a:t> </a:t>
+                </a:r>
+                <a:r>
+                  <a:rPr lang="de-DE" dirty="0" err="1"/>
+                  <a:t>become</a:t>
+                </a:r>
+                <a:r>
+                  <a:rPr lang="de-DE" dirty="0"/>
+                  <a:t> a </a:t>
+                </a:r>
+                <a:r>
+                  <a:rPr lang="de-DE" dirty="0" err="1"/>
+                  <a:t>border</a:t>
+                </a:r>
+                <a:r>
+                  <a:rPr lang="de-DE" dirty="0"/>
+                  <a:t> </a:t>
+                </a:r>
+                <a:r>
+                  <a:rPr lang="de-DE" dirty="0" err="1"/>
+                  <a:t>point</a:t>
+                </a:r>
+                <a:r>
+                  <a:rPr lang="de-DE" dirty="0"/>
+                  <a:t>)</a:t>
+                </a:r>
+              </a:p>
+              <a:p>
+                <a:pPr marL="514350" indent="-514350">
+                  <a:buFont typeface="+mj-lt"/>
+                  <a:buAutoNum type="arabicPeriod"/>
+                </a:pPr>
+                <a:r>
+                  <a:rPr lang="de-DE" dirty="0"/>
+                  <a:t>Repeat </a:t>
+                </a:r>
+                <a:r>
+                  <a:rPr lang="de-DE" dirty="0" err="1"/>
+                  <a:t>until</a:t>
+                </a:r>
+                <a:r>
+                  <a:rPr lang="de-DE" dirty="0"/>
+                  <a:t> all </a:t>
+                </a:r>
+                <a:r>
+                  <a:rPr lang="de-DE" dirty="0" err="1"/>
+                  <a:t>points</a:t>
+                </a:r>
+                <a:r>
+                  <a:rPr lang="de-DE" dirty="0"/>
+                  <a:t> </a:t>
+                </a:r>
+                <a:r>
+                  <a:rPr lang="de-DE" dirty="0" err="1"/>
+                  <a:t>are</a:t>
+                </a:r>
+                <a:r>
+                  <a:rPr lang="de-DE" dirty="0"/>
+                  <a:t> </a:t>
+                </a:r>
+                <a:r>
+                  <a:rPr lang="de-DE" dirty="0" err="1"/>
+                  <a:t>processed</a:t>
+                </a:r>
+                <a:endParaRPr lang="de-DE" dirty="0"/>
+              </a:p>
+              <a:p>
+                <a:pPr marL="0" indent="0">
+                  <a:buNone/>
+                </a:pPr>
+                <a:endParaRPr lang="de-DE" dirty="0"/>
+              </a:p>
+              <a:p>
+                <a:pPr marL="0" indent="0">
+                  <a:buNone/>
+                </a:pPr>
+                <a:r>
+                  <a:rPr lang="de-DE" dirty="0"/>
+                  <a:t>Cluster </a:t>
+                </a:r>
+                <a:r>
+                  <a:rPr lang="de-DE" dirty="0" err="1"/>
+                  <a:t>formation</a:t>
+                </a:r>
+                <a:r>
+                  <a:rPr lang="de-DE" dirty="0"/>
+                  <a:t> </a:t>
+                </a:r>
+                <a:r>
+                  <a:rPr lang="de-DE" dirty="0" err="1"/>
+                  <a:t>concept</a:t>
+                </a:r>
+                <a:r>
+                  <a:rPr lang="de-DE" dirty="0"/>
+                  <a:t>:</a:t>
+                </a:r>
+              </a:p>
+              <a:p>
+                <a:r>
+                  <a:rPr lang="de-DE" dirty="0"/>
+                  <a:t>Points </a:t>
+                </a:r>
+                <a:r>
+                  <a:rPr lang="de-DE" dirty="0" err="1"/>
+                  <a:t>are</a:t>
+                </a:r>
+                <a:r>
+                  <a:rPr lang="de-DE" dirty="0"/>
+                  <a:t> </a:t>
+                </a:r>
+                <a:r>
+                  <a:rPr lang="de-DE" dirty="0" err="1"/>
+                  <a:t>density-connected</a:t>
+                </a:r>
+                <a:r>
+                  <a:rPr lang="de-DE" dirty="0"/>
+                  <a:t> </a:t>
+                </a:r>
+                <a:r>
+                  <a:rPr lang="de-DE" dirty="0" err="1"/>
+                  <a:t>if</a:t>
+                </a:r>
+                <a:r>
+                  <a:rPr lang="de-DE" dirty="0"/>
+                  <a:t> </a:t>
+                </a:r>
+                <a:r>
+                  <a:rPr lang="de-DE" dirty="0" err="1"/>
+                  <a:t>they</a:t>
+                </a:r>
+                <a:r>
+                  <a:rPr lang="de-DE" dirty="0"/>
+                  <a:t> </a:t>
+                </a:r>
+                <a:r>
+                  <a:rPr lang="de-DE" dirty="0" err="1"/>
+                  <a:t>can</a:t>
+                </a:r>
+                <a:r>
+                  <a:rPr lang="de-DE" dirty="0"/>
+                  <a:t> </a:t>
+                </a:r>
+                <a:r>
+                  <a:rPr lang="de-DE" dirty="0" err="1"/>
+                  <a:t>be</a:t>
+                </a:r>
+                <a:r>
+                  <a:rPr lang="de-DE" dirty="0"/>
+                  <a:t> </a:t>
+                </a:r>
+                <a:r>
+                  <a:rPr lang="de-DE" dirty="0" err="1"/>
+                  <a:t>reached</a:t>
+                </a:r>
+                <a:r>
+                  <a:rPr lang="de-DE" dirty="0"/>
+                  <a:t> via a </a:t>
+                </a:r>
+                <a:r>
+                  <a:rPr lang="de-DE" dirty="0" err="1"/>
+                  <a:t>chain</a:t>
+                </a:r>
+                <a:r>
+                  <a:rPr lang="de-DE" dirty="0"/>
+                  <a:t> </a:t>
+                </a:r>
+                <a:r>
+                  <a:rPr lang="de-DE" dirty="0" err="1"/>
+                  <a:t>of</a:t>
+                </a:r>
+                <a:r>
+                  <a:rPr lang="de-DE" dirty="0"/>
+                  <a:t> </a:t>
+                </a:r>
+                <a:r>
+                  <a:rPr lang="de-DE" dirty="0" err="1"/>
+                  <a:t>core</a:t>
+                </a:r>
+                <a:r>
+                  <a:rPr lang="de-DE" dirty="0"/>
+                  <a:t> </a:t>
+                </a:r>
+                <a:r>
+                  <a:rPr lang="de-DE" dirty="0" err="1"/>
+                  <a:t>points</a:t>
+                </a:r>
+                <a:endParaRPr lang="de-DE" dirty="0"/>
+              </a:p>
+              <a:p>
+                <a:r>
+                  <a:rPr lang="de-DE" dirty="0"/>
+                  <a:t>Clusters </a:t>
+                </a:r>
+                <a:r>
+                  <a:rPr lang="de-DE" dirty="0" err="1"/>
+                  <a:t>grow</a:t>
+                </a:r>
+                <a:r>
+                  <a:rPr lang="de-DE" dirty="0"/>
+                  <a:t> </a:t>
+                </a:r>
+                <a:r>
+                  <a:rPr lang="de-DE" dirty="0" err="1"/>
+                  <a:t>outward</a:t>
+                </a:r>
+                <a:r>
+                  <a:rPr lang="de-DE" dirty="0"/>
+                  <a:t> </a:t>
+                </a:r>
+                <a:r>
+                  <a:rPr lang="de-DE" dirty="0" err="1"/>
+                  <a:t>from</a:t>
+                </a:r>
+                <a:r>
+                  <a:rPr lang="de-DE" dirty="0"/>
+                  <a:t> </a:t>
+                </a:r>
+                <a:r>
+                  <a:rPr lang="de-DE" dirty="0" err="1"/>
+                  <a:t>core</a:t>
+                </a:r>
+                <a:r>
+                  <a:rPr lang="de-DE" dirty="0"/>
+                  <a:t> </a:t>
+                </a:r>
+                <a:r>
+                  <a:rPr lang="de-DE" dirty="0" err="1"/>
+                  <a:t>points</a:t>
+                </a:r>
+                <a:endParaRPr lang="de-DE" dirty="0"/>
+              </a:p>
+            </p:txBody>
+          </p:sp>
+        </mc:Choice>
+        <mc:Fallback>
+          <p:sp>
+            <p:nvSpPr>
+              <p:cNvPr id="3" name="Inhaltsplatzhalter 2">
+                <a:extLst>
+                  <a:ext uri="{FF2B5EF4-FFF2-40B4-BE49-F238E27FC236}">
+                    <a16:creationId xmlns:a16="http://schemas.microsoft.com/office/drawing/2014/main" id="{48293539-B5EA-4406-02DD-1F9D36FDC673}"/>
+                  </a:ext>
+                </a:extLst>
+              </p:cNvPr>
+              <p:cNvSpPr>
+                <a:spLocks noGrp="1" noRot="1" noChangeAspect="1" noMove="1" noResize="1" noEditPoints="1" noAdjustHandles="1" noChangeArrowheads="1" noChangeShapeType="1" noTextEdit="1"/>
+              </p:cNvSpPr>
+              <p:nvPr>
+                <p:ph idx="1"/>
+              </p:nvPr>
+            </p:nvSpPr>
+            <p:spPr>
+              <a:blipFill>
+                <a:blip r:embed="rId2"/>
+                <a:stretch>
+                  <a:fillRect l="-724" t="-2616"/>
+                </a:stretch>
+              </a:blipFill>
+            </p:spPr>
+            <p:txBody>
+              <a:bodyPr/>
+              <a:lstStyle/>
+              <a:p>
+                <a:r>
+                  <a:rPr lang="de-DE">
+                    <a:noFill/>
+                  </a:rPr>
+                  <a:t> </a:t>
+                </a:r>
+              </a:p>
+            </p:txBody>
+          </p:sp>
+        </mc:Fallback>
+      </mc:AlternateContent>
       <p:sp>
         <p:nvSpPr>
           <p:cNvPr id="4" name="Foliennummernplatzhalter 3">
@@ -17945,6 +19045,607 @@
           <p:cNvPr id="2" name="Titel 1">
             <a:extLst>
               <a:ext uri="{FF2B5EF4-FFF2-40B4-BE49-F238E27FC236}">
+                <a16:creationId xmlns:a16="http://schemas.microsoft.com/office/drawing/2014/main" id="{12451C77-ED0D-F705-8D1C-ADFA8F6C97BF}"/>
+              </a:ext>
+            </a:extLst>
+          </p:cNvPr>
+          <p:cNvSpPr>
+            <a:spLocks noGrp="1"/>
+          </p:cNvSpPr>
+          <p:nvPr>
+            <p:ph type="title"/>
+          </p:nvPr>
+        </p:nvSpPr>
+        <p:spPr/>
+        <p:txBody>
+          <a:bodyPr/>
+          <a:lstStyle/>
+          <a:p>
+            <a:r>
+              <a:rPr lang="de-DE" dirty="0"/>
+              <a:t>How </a:t>
+            </a:r>
+            <a:r>
+              <a:rPr lang="de-DE" dirty="0" err="1"/>
+              <a:t>to</a:t>
+            </a:r>
+            <a:r>
+              <a:rPr lang="de-DE" dirty="0"/>
+              <a:t> </a:t>
+            </a:r>
+            <a:r>
+              <a:rPr lang="de-DE" dirty="0" err="1"/>
+              <a:t>Assign</a:t>
+            </a:r>
+            <a:r>
+              <a:rPr lang="de-DE" dirty="0"/>
+              <a:t> New Points</a:t>
+            </a:r>
+          </a:p>
+        </p:txBody>
+      </p:sp>
+      <p:sp>
+        <p:nvSpPr>
+          <p:cNvPr id="3" name="Inhaltsplatzhalter 2">
+            <a:extLst>
+              <a:ext uri="{FF2B5EF4-FFF2-40B4-BE49-F238E27FC236}">
+                <a16:creationId xmlns:a16="http://schemas.microsoft.com/office/drawing/2014/main" id="{FA126657-2593-4771-3A67-51F3B2F3A6EF}"/>
+              </a:ext>
+            </a:extLst>
+          </p:cNvPr>
+          <p:cNvSpPr>
+            <a:spLocks noGrp="1"/>
+          </p:cNvSpPr>
+          <p:nvPr>
+            <p:ph idx="1"/>
+          </p:nvPr>
+        </p:nvSpPr>
+        <p:spPr/>
+        <p:txBody>
+          <a:bodyPr>
+            <a:normAutofit/>
+          </a:bodyPr>
+          <a:lstStyle/>
+          <a:p>
+            <a:pPr marL="0" indent="0">
+              <a:buNone/>
+            </a:pPr>
+            <a:r>
+              <a:rPr lang="de-DE" dirty="0" err="1"/>
+              <a:t>For</a:t>
+            </a:r>
+            <a:r>
+              <a:rPr lang="de-DE" dirty="0"/>
+              <a:t> a </a:t>
+            </a:r>
+            <a:r>
+              <a:rPr lang="de-DE" dirty="0" err="1"/>
+              <a:t>new</a:t>
+            </a:r>
+            <a:r>
+              <a:rPr lang="de-DE" dirty="0"/>
+              <a:t> </a:t>
+            </a:r>
+            <a:r>
+              <a:rPr lang="de-DE" dirty="0" err="1"/>
+              <a:t>point</a:t>
+            </a:r>
+            <a:r>
+              <a:rPr lang="de-DE" dirty="0"/>
+              <a:t>: Check </a:t>
+            </a:r>
+            <a:r>
+              <a:rPr lang="de-DE" dirty="0" err="1"/>
+              <a:t>its</a:t>
+            </a:r>
+            <a:r>
+              <a:rPr lang="de-DE" dirty="0"/>
+              <a:t> </a:t>
+            </a:r>
+            <a:r>
+              <a:rPr lang="el-GR" dirty="0">
+                <a:latin typeface="Cambria Math" panose="02040503050406030204" pitchFamily="18" charset="0"/>
+                <a:ea typeface="Cambria Math" panose="02040503050406030204" pitchFamily="18" charset="0"/>
+              </a:rPr>
+              <a:t>ε</a:t>
+            </a:r>
+            <a:r>
+              <a:rPr lang="el-GR" dirty="0"/>
+              <a:t>-</a:t>
+            </a:r>
+            <a:r>
+              <a:rPr lang="de-DE" dirty="0" err="1"/>
+              <a:t>neighborhood</a:t>
+            </a:r>
+            <a:endParaRPr lang="de-DE" dirty="0"/>
+          </a:p>
+          <a:p>
+            <a:r>
+              <a:rPr lang="de-DE" dirty="0" err="1"/>
+              <a:t>If</a:t>
+            </a:r>
+            <a:r>
+              <a:rPr lang="de-DE" dirty="0"/>
+              <a:t> </a:t>
+            </a:r>
+            <a:r>
+              <a:rPr lang="de-DE" dirty="0" err="1"/>
+              <a:t>within</a:t>
+            </a:r>
+            <a:r>
+              <a:rPr lang="de-DE" dirty="0"/>
+              <a:t> </a:t>
+            </a:r>
+            <a:r>
+              <a:rPr lang="el-GR" dirty="0">
+                <a:latin typeface="Cambria Math" panose="02040503050406030204" pitchFamily="18" charset="0"/>
+                <a:ea typeface="Cambria Math" panose="02040503050406030204" pitchFamily="18" charset="0"/>
+              </a:rPr>
+              <a:t>ε</a:t>
+            </a:r>
+            <a:r>
+              <a:rPr lang="el-GR" dirty="0"/>
+              <a:t> </a:t>
+            </a:r>
+            <a:r>
+              <a:rPr lang="de-DE" dirty="0" err="1"/>
+              <a:t>of</a:t>
+            </a:r>
+            <a:r>
+              <a:rPr lang="de-DE" dirty="0"/>
+              <a:t> a </a:t>
+            </a:r>
+            <a:r>
+              <a:rPr lang="de-DE" dirty="0" err="1"/>
+              <a:t>core</a:t>
+            </a:r>
+            <a:r>
+              <a:rPr lang="de-DE" dirty="0"/>
+              <a:t> </a:t>
+            </a:r>
+            <a:r>
+              <a:rPr lang="de-DE" dirty="0" err="1"/>
+              <a:t>point</a:t>
+            </a:r>
+            <a:r>
+              <a:rPr lang="de-DE" dirty="0"/>
+              <a:t>: </a:t>
+            </a:r>
+            <a:r>
+              <a:rPr lang="de-DE" dirty="0" err="1"/>
+              <a:t>Assign</a:t>
+            </a:r>
+            <a:r>
+              <a:rPr lang="de-DE" dirty="0"/>
+              <a:t> </a:t>
+            </a:r>
+            <a:r>
+              <a:rPr lang="de-DE" dirty="0" err="1"/>
+              <a:t>it</a:t>
+            </a:r>
+            <a:r>
+              <a:rPr lang="de-DE" dirty="0"/>
+              <a:t> </a:t>
+            </a:r>
+            <a:r>
+              <a:rPr lang="de-DE" dirty="0" err="1"/>
+              <a:t>to</a:t>
+            </a:r>
+            <a:r>
+              <a:rPr lang="de-DE" dirty="0"/>
+              <a:t> </a:t>
+            </a:r>
+            <a:r>
+              <a:rPr lang="de-DE" dirty="0" err="1"/>
+              <a:t>that</a:t>
+            </a:r>
+            <a:r>
+              <a:rPr lang="de-DE" dirty="0"/>
+              <a:t> </a:t>
+            </a:r>
+            <a:r>
+              <a:rPr lang="de-DE" dirty="0" err="1"/>
+              <a:t>cluster</a:t>
+            </a:r>
+            <a:endParaRPr lang="de-DE" dirty="0"/>
+          </a:p>
+          <a:p>
+            <a:r>
+              <a:rPr lang="de-DE" dirty="0" err="1"/>
+              <a:t>If</a:t>
+            </a:r>
+            <a:r>
+              <a:rPr lang="de-DE" dirty="0"/>
+              <a:t> not </a:t>
+            </a:r>
+            <a:r>
+              <a:rPr lang="de-DE" dirty="0" err="1"/>
+              <a:t>near</a:t>
+            </a:r>
+            <a:r>
+              <a:rPr lang="de-DE" dirty="0"/>
+              <a:t> </a:t>
+            </a:r>
+            <a:r>
+              <a:rPr lang="de-DE" dirty="0" err="1"/>
+              <a:t>any</a:t>
+            </a:r>
+            <a:r>
+              <a:rPr lang="de-DE" dirty="0"/>
+              <a:t> </a:t>
+            </a:r>
+            <a:r>
+              <a:rPr lang="de-DE" dirty="0" err="1"/>
+              <a:t>core</a:t>
+            </a:r>
+            <a:r>
+              <a:rPr lang="de-DE" dirty="0"/>
+              <a:t> </a:t>
+            </a:r>
+            <a:r>
+              <a:rPr lang="de-DE" dirty="0" err="1"/>
+              <a:t>point</a:t>
+            </a:r>
+            <a:r>
+              <a:rPr lang="de-DE" dirty="0"/>
+              <a:t>: Label </a:t>
+            </a:r>
+            <a:r>
+              <a:rPr lang="de-DE" dirty="0" err="1"/>
+              <a:t>as</a:t>
+            </a:r>
+            <a:r>
+              <a:rPr lang="de-DE" dirty="0"/>
+              <a:t> </a:t>
+            </a:r>
+            <a:r>
+              <a:rPr lang="de-DE" dirty="0" err="1"/>
+              <a:t>noise</a:t>
+            </a:r>
+            <a:endParaRPr lang="de-DE" dirty="0"/>
+          </a:p>
+          <a:p>
+            <a:r>
+              <a:rPr lang="de-DE" dirty="0" err="1"/>
+              <a:t>If</a:t>
+            </a:r>
+            <a:r>
+              <a:rPr lang="de-DE" dirty="0"/>
+              <a:t> </a:t>
+            </a:r>
+            <a:r>
+              <a:rPr lang="de-DE" dirty="0" err="1"/>
+              <a:t>within</a:t>
+            </a:r>
+            <a:r>
+              <a:rPr lang="de-DE" dirty="0"/>
+              <a:t> </a:t>
+            </a:r>
+            <a:r>
+              <a:rPr lang="el-GR" dirty="0">
+                <a:latin typeface="Cambria Math" panose="02040503050406030204" pitchFamily="18" charset="0"/>
+                <a:ea typeface="Cambria Math" panose="02040503050406030204" pitchFamily="18" charset="0"/>
+              </a:rPr>
+              <a:t>ε</a:t>
+            </a:r>
+            <a:r>
+              <a:rPr lang="el-GR" dirty="0"/>
+              <a:t> </a:t>
+            </a:r>
+            <a:r>
+              <a:rPr lang="de-DE" dirty="0" err="1"/>
+              <a:t>of</a:t>
+            </a:r>
+            <a:r>
+              <a:rPr lang="de-DE" dirty="0"/>
+              <a:t> </a:t>
+            </a:r>
+            <a:r>
+              <a:rPr lang="de-DE" dirty="0" err="1"/>
+              <a:t>core</a:t>
+            </a:r>
+            <a:r>
+              <a:rPr lang="de-DE" dirty="0"/>
+              <a:t> </a:t>
+            </a:r>
+            <a:r>
+              <a:rPr lang="de-DE" dirty="0" err="1"/>
+              <a:t>points</a:t>
+            </a:r>
+            <a:r>
+              <a:rPr lang="de-DE" dirty="0"/>
+              <a:t> </a:t>
+            </a:r>
+            <a:r>
+              <a:rPr lang="de-DE" dirty="0" err="1"/>
+              <a:t>from</a:t>
+            </a:r>
+            <a:r>
+              <a:rPr lang="de-DE" dirty="0"/>
+              <a:t> different </a:t>
+            </a:r>
+            <a:r>
+              <a:rPr lang="de-DE" dirty="0" err="1"/>
+              <a:t>clusters</a:t>
+            </a:r>
+            <a:r>
+              <a:rPr lang="de-DE" dirty="0"/>
+              <a:t>:</a:t>
+            </a:r>
+          </a:p>
+          <a:p>
+            <a:pPr lvl="1"/>
+            <a:r>
+              <a:rPr lang="de-DE" dirty="0"/>
+              <a:t>Option 1: </a:t>
+            </a:r>
+            <a:r>
+              <a:rPr lang="de-DE" dirty="0" err="1"/>
+              <a:t>Assign</a:t>
+            </a:r>
+            <a:r>
+              <a:rPr lang="de-DE" dirty="0"/>
+              <a:t> </a:t>
+            </a:r>
+            <a:r>
+              <a:rPr lang="de-DE" dirty="0" err="1"/>
+              <a:t>to</a:t>
+            </a:r>
+            <a:r>
+              <a:rPr lang="de-DE" dirty="0"/>
+              <a:t> </a:t>
+            </a:r>
+            <a:r>
+              <a:rPr lang="de-DE" dirty="0" err="1"/>
+              <a:t>first</a:t>
+            </a:r>
+            <a:r>
+              <a:rPr lang="de-DE" dirty="0"/>
+              <a:t> </a:t>
+            </a:r>
+            <a:r>
+              <a:rPr lang="de-DE" dirty="0" err="1"/>
+              <a:t>found</a:t>
+            </a:r>
+            <a:r>
+              <a:rPr lang="de-DE" dirty="0"/>
+              <a:t> (like DBSCAN </a:t>
+            </a:r>
+            <a:r>
+              <a:rPr lang="de-DE" dirty="0" err="1"/>
+              <a:t>would</a:t>
+            </a:r>
+            <a:r>
+              <a:rPr lang="de-DE" dirty="0"/>
+              <a:t>)</a:t>
+            </a:r>
+          </a:p>
+          <a:p>
+            <a:pPr lvl="1"/>
+            <a:r>
+              <a:rPr lang="de-DE" dirty="0"/>
+              <a:t>Option 2: </a:t>
+            </a:r>
+            <a:r>
+              <a:rPr lang="de-DE" dirty="0" err="1"/>
+              <a:t>Assign</a:t>
+            </a:r>
+            <a:r>
+              <a:rPr lang="de-DE" dirty="0"/>
+              <a:t> </a:t>
+            </a:r>
+            <a:r>
+              <a:rPr lang="de-DE" dirty="0" err="1"/>
+              <a:t>to</a:t>
+            </a:r>
+            <a:r>
+              <a:rPr lang="de-DE" dirty="0"/>
+              <a:t> </a:t>
+            </a:r>
+            <a:r>
+              <a:rPr lang="de-DE" dirty="0" err="1"/>
+              <a:t>closest</a:t>
+            </a:r>
+            <a:r>
+              <a:rPr lang="de-DE" dirty="0"/>
+              <a:t> </a:t>
+            </a:r>
+            <a:r>
+              <a:rPr lang="de-DE" dirty="0" err="1"/>
+              <a:t>core</a:t>
+            </a:r>
+            <a:r>
+              <a:rPr lang="de-DE" dirty="0"/>
+              <a:t> </a:t>
+            </a:r>
+            <a:r>
+              <a:rPr lang="de-DE" dirty="0" err="1"/>
+              <a:t>point</a:t>
+            </a:r>
+            <a:endParaRPr lang="de-DE" dirty="0"/>
+          </a:p>
+          <a:p>
+            <a:pPr marL="0" indent="0">
+              <a:buNone/>
+            </a:pPr>
+            <a:endParaRPr lang="de-DE" b="1" dirty="0"/>
+          </a:p>
+          <a:p>
+            <a:pPr marL="0" indent="0">
+              <a:buNone/>
+            </a:pPr>
+            <a:r>
+              <a:rPr lang="de-DE" dirty="0" err="1"/>
+              <a:t>Adding</a:t>
+            </a:r>
+            <a:r>
+              <a:rPr lang="de-DE" dirty="0"/>
+              <a:t> </a:t>
+            </a:r>
+            <a:r>
+              <a:rPr lang="de-DE" dirty="0" err="1"/>
+              <a:t>one</a:t>
+            </a:r>
+            <a:r>
+              <a:rPr lang="de-DE" dirty="0"/>
+              <a:t> </a:t>
+            </a:r>
+            <a:r>
+              <a:rPr lang="de-DE" dirty="0" err="1"/>
+              <a:t>point</a:t>
+            </a:r>
+            <a:r>
+              <a:rPr lang="de-DE" dirty="0"/>
+              <a:t> </a:t>
+            </a:r>
+            <a:r>
+              <a:rPr lang="de-DE" dirty="0" err="1"/>
+              <a:t>can</a:t>
+            </a:r>
+            <a:r>
+              <a:rPr lang="de-DE" dirty="0"/>
+              <a:t> </a:t>
+            </a:r>
+            <a:r>
+              <a:rPr lang="de-DE" dirty="0" err="1"/>
+              <a:t>change</a:t>
+            </a:r>
+            <a:r>
+              <a:rPr lang="de-DE" dirty="0"/>
+              <a:t> </a:t>
+            </a:r>
+            <a:r>
+              <a:rPr lang="de-DE" dirty="0" err="1"/>
+              <a:t>cluster</a:t>
+            </a:r>
+            <a:r>
+              <a:rPr lang="de-DE" dirty="0"/>
+              <a:t> </a:t>
+            </a:r>
+            <a:r>
+              <a:rPr lang="de-DE" dirty="0" err="1"/>
+              <a:t>structure</a:t>
+            </a:r>
+            <a:endParaRPr lang="de-DE" dirty="0"/>
+          </a:p>
+          <a:p>
+            <a:pPr marL="0" indent="0">
+              <a:buNone/>
+            </a:pPr>
+            <a:r>
+              <a:rPr lang="de-DE" dirty="0">
+                <a:sym typeface="Wingdings" pitchFamily="2" charset="2"/>
+              </a:rPr>
+              <a:t> </a:t>
+            </a:r>
+            <a:r>
+              <a:rPr lang="de-DE" dirty="0"/>
+              <a:t>True DBSCAN </a:t>
+            </a:r>
+            <a:r>
+              <a:rPr lang="de-DE" dirty="0" err="1"/>
+              <a:t>would</a:t>
+            </a:r>
+            <a:r>
+              <a:rPr lang="de-DE" dirty="0"/>
+              <a:t> </a:t>
+            </a:r>
+            <a:r>
+              <a:rPr lang="de-DE" dirty="0" err="1"/>
+              <a:t>require</a:t>
+            </a:r>
+            <a:r>
+              <a:rPr lang="de-DE" dirty="0"/>
+              <a:t> </a:t>
+            </a:r>
+            <a:r>
+              <a:rPr lang="de-DE" dirty="0" err="1"/>
+              <a:t>re-running</a:t>
+            </a:r>
+            <a:r>
+              <a:rPr lang="de-DE" dirty="0"/>
+              <a:t> </a:t>
+            </a:r>
+            <a:r>
+              <a:rPr lang="de-DE" dirty="0" err="1"/>
+              <a:t>the</a:t>
+            </a:r>
+            <a:r>
+              <a:rPr lang="de-DE" dirty="0"/>
+              <a:t> </a:t>
+            </a:r>
+            <a:r>
+              <a:rPr lang="de-DE" dirty="0" err="1"/>
+              <a:t>algorithm</a:t>
+            </a:r>
+            <a:endParaRPr lang="de-DE" dirty="0"/>
+          </a:p>
+        </p:txBody>
+      </p:sp>
+      <p:sp>
+        <p:nvSpPr>
+          <p:cNvPr id="4" name="Foliennummernplatzhalter 3">
+            <a:extLst>
+              <a:ext uri="{FF2B5EF4-FFF2-40B4-BE49-F238E27FC236}">
+                <a16:creationId xmlns:a16="http://schemas.microsoft.com/office/drawing/2014/main" id="{0B161C99-D9A5-D8DB-0687-150C7C9C9AE1}"/>
+              </a:ext>
+            </a:extLst>
+          </p:cNvPr>
+          <p:cNvSpPr>
+            <a:spLocks noGrp="1"/>
+          </p:cNvSpPr>
+          <p:nvPr>
+            <p:ph type="sldNum" sz="quarter" idx="12"/>
+          </p:nvPr>
+        </p:nvSpPr>
+        <p:spPr/>
+        <p:txBody>
+          <a:bodyPr/>
+          <a:lstStyle/>
+          <a:p>
+            <a:fld id="{08C366F5-AFAD-49CB-854A-9D9E238FCA13}" type="slidenum">
+              <a:rPr lang="en-GB" smtClean="0"/>
+              <a:t>34</a:t>
+            </a:fld>
+            <a:endParaRPr lang="en-GB"/>
+          </a:p>
+        </p:txBody>
+      </p:sp>
+    </p:spTree>
+    <p:extLst>
+      <p:ext uri="{BB962C8B-B14F-4D97-AF65-F5344CB8AC3E}">
+        <p14:creationId xmlns:p14="http://schemas.microsoft.com/office/powerpoint/2010/main" val="1263246602"/>
+      </p:ext>
+    </p:extLst>
+  </p:cSld>
+  <p:clrMapOvr>
+    <a:masterClrMapping/>
+  </p:clrMapOvr>
+</p:sld>
+</file>
+
+<file path=ppt/slides/slide35.xml><?xml version="1.0" encoding="utf-8"?>
+<p:sld xmlns:a="http://schemas.openxmlformats.org/drawingml/2006/main" xmlns:r="http://schemas.openxmlformats.org/officeDocument/2006/relationships" xmlns:p="http://schemas.openxmlformats.org/presentationml/2006/main">
+  <p:cSld>
+    <p:spTree>
+      <p:nvGrpSpPr>
+        <p:cNvPr id="1" name=""/>
+        <p:cNvGrpSpPr/>
+        <p:nvPr/>
+      </p:nvGrpSpPr>
+      <p:grpSpPr>
+        <a:xfrm>
+          <a:off x="0" y="0"/>
+          <a:ext cx="0" cy="0"/>
+          <a:chOff x="0" y="0"/>
+          <a:chExt cx="0" cy="0"/>
+        </a:xfrm>
+      </p:grpSpPr>
+      <p:sp>
+        <p:nvSpPr>
+          <p:cNvPr id="2" name="Titel 1">
+            <a:extLst>
+              <a:ext uri="{FF2B5EF4-FFF2-40B4-BE49-F238E27FC236}">
                 <a16:creationId xmlns:a16="http://schemas.microsoft.com/office/drawing/2014/main" id="{AB0A312D-A6FF-AB8E-359F-EE1BDB1D4399}"/>
               </a:ext>
             </a:extLst>
@@ -18383,7 +20084,7 @@
           <a:p>
             <a:fld id="{08C366F5-AFAD-49CB-854A-9D9E238FCA13}" type="slidenum">
               <a:rPr lang="en-GB" smtClean="0"/>
-              <a:t>34</a:t>
+              <a:t>35</a:t>
             </a:fld>
             <a:endParaRPr lang="en-GB"/>
           </a:p>
@@ -18449,7 +20150,7 @@
 </p:sld>
 </file>
 
-<file path=ppt/slides/slide35.xml><?xml version="1.0" encoding="utf-8"?>
+<file path=ppt/slides/slide36.xml><?xml version="1.0" encoding="utf-8"?>
 <p:sld xmlns:a="http://schemas.openxmlformats.org/drawingml/2006/main" xmlns:r="http://schemas.openxmlformats.org/officeDocument/2006/relationships" xmlns:p="http://schemas.openxmlformats.org/presentationml/2006/main">
   <p:cSld>
     <p:spTree>
@@ -18593,7 +20294,7 @@
           <a:p>
             <a:fld id="{08C366F5-AFAD-49CB-854A-9D9E238FCA13}" type="slidenum">
               <a:rPr lang="en-GB" smtClean="0"/>
-              <a:t>35</a:t>
+              <a:t>36</a:t>
             </a:fld>
             <a:endParaRPr lang="en-GB"/>
           </a:p>

</xml_diff>